<commit_message>
Aggiunge sezione anomalie e materiali alla guida e alle slide
Co-Authored-By: Claude Sonnet 5.5 <noreply@anthropic.com>
Claude-Session: https://claude.ai/code/session_015bvwL7pS6S8pvXY1d6szrs
</commit_message>
<xml_diff>
--- a/lidia-nails-corso/output/slide-lezione.pptx
+++ b/lidia-nails-corso/output/slide-lezione.pptx
@@ -20,6 +20,8 @@
     <p:sldId id="268" r:id="rId20"/>
     <p:sldId id="269" r:id="rId21"/>
     <p:sldId id="270" r:id="rId22"/>
+    <p:sldId id="271" r:id="rId23"/>
+    <p:sldId id="272" r:id="rId24"/>
   </p:sldIdLst>
   <p:sldSz cx="12191695" cy="6858000" type="screen4x3"/>
   <p:notesSz cx="6858000" cy="9144000"/>
@@ -1048,6 +1050,238 @@
           <a:p>
             <a:r>
               <a:t>- Mai staccare la tip da sola.</a:t>
+            </a:r>
+          </a:p>
+        </p:txBody>
+      </p:sp>
+      <p:sp>
+        <p:nvSpPr>
+          <p:cNvPr id="4" name="Slide Number Placeholder 3"/>
+          <p:cNvSpPr>
+            <a:spLocks noGrp="1"/>
+          </p:cNvSpPr>
+          <p:nvPr>
+            <p:ph type="sldNum" idx="5" sz="quarter"/>
+          </p:nvPr>
+        </p:nvSpPr>
+        <p:spPr/>
+      </p:sp>
+    </p:spTree>
+  </p:cSld>
+  <p:clrMapOvr>
+    <a:masterClrMapping/>
+  </p:clrMapOvr>
+</p:notes>
+</file>
+
+<file path=ppt/notesSlides/notesSlide15.xml><?xml version="1.0" encoding="utf-8"?>
+<p:notes xmlns:a="http://schemas.openxmlformats.org/drawingml/2006/main" xmlns:p="http://schemas.openxmlformats.org/presentationml/2006/main" xmlns:r="http://schemas.openxmlformats.org/officeDocument/2006/relationships">
+  <p:cSld>
+    <p:spTree>
+      <p:nvGrpSpPr>
+        <p:cNvPr id="1" name=""/>
+        <p:cNvGrpSpPr/>
+        <p:nvPr/>
+      </p:nvGrpSpPr>
+      <p:grpSpPr>
+        <a:xfrm>
+          <a:off x="0" y="0"/>
+          <a:ext cx="0" cy="0"/>
+          <a:chOff x="0" y="0"/>
+          <a:chExt cx="0" cy="0"/>
+        </a:xfrm>
+      </p:grpSpPr>
+      <p:sp>
+        <p:nvSpPr>
+          <p:cNvPr id="2" name="Slide Image Placeholder 1"/>
+          <p:cNvSpPr>
+            <a:spLocks noGrp="1"/>
+          </p:cNvSpPr>
+          <p:nvPr>
+            <p:ph type="sldImg" idx="2"/>
+          </p:nvPr>
+        </p:nvSpPr>
+        <p:spPr/>
+      </p:sp>
+      <p:sp>
+        <p:nvSpPr>
+          <p:cNvPr id="3" name="Notes Placeholder 2"/>
+          <p:cNvSpPr>
+            <a:spLocks noGrp="1"/>
+          </p:cNvSpPr>
+          <p:nvPr>
+            <p:ph type="body" idx="3" sz="quarter"/>
+          </p:nvPr>
+        </p:nvSpPr>
+        <p:spPr/>
+        <p:txBody>
+          <a:bodyPr/>
+          <a:lstStyle/>
+          <a:p>
+            <a:r>
+              <a:t>Slide di sicurezza: usare il 'semaforo'. Verde = si lavora, giallo = con cautela, rosso = medico.</a:t>
+            </a:r>
+          </a:p>
+          <a:p/>
+          <a:p>
+            <a:r>
+              <a:t>Dettaglio:</a:t>
+            </a:r>
+          </a:p>
+          <a:p>
+            <a:r>
+              <a:t>- Regola d'oro: noi curiamo l'estetica, non la salute. Mai prescrivere farmaci o antimicotici. Se qualcosa non ci è chiaro o non è normale: cliente dal medico o dermatologo.</a:t>
+            </a:r>
+          </a:p>
+          <a:p>
+            <a:r>
+              <a:t>- Criterio pratico: un trauma colpisce 1-3 unghie. Se l'anomalia è su molte o tutte le dita, ragionare come patologia e inviare dal medico.</a:t>
+            </a:r>
+          </a:p>
+          <a:p>
+            <a:r>
+              <a:t>- Onicolisi (distacco dell'unghia dal letto ungueale): da trauma parte dal bordo libero o dai laterali. Con sangue o dolore: accorciare, disinfettare, rimandare. Si lavora solo sulla parte ancora salda; se il distacco è circa metà unghia o più, non si ricostruisce.</a:t>
+            </a:r>
+          </a:p>
+          <a:p>
+            <a:r>
+              <a:t>- Distacco lieve (circa un terzo): tagliare la parte sollevata lasciando un bordo di sicurezza, applicare una copertura leggera. Evitare che il prodotto tocchi la pelle. Con la gel tip il gel va solo sulla zona salda; controllo dopo circa 2 settimane.</a:t>
+            </a:r>
+          </a:p>
+          <a:p>
+            <a:r>
+              <a:t>- Leuconichia (macchie bianche): di solito traumi o limature troppo aggressive. Su una o poche unghie si può lavorare con mano leggera; su tutte e dieci, medico.</a:t>
+            </a:r>
+          </a:p>
+          <a:p>
+            <a:r>
+              <a:t>- Emorragia a scheggia (linee sottili rosso scuro o bluastre sotto l'unghia): spesso un urto. Si può lavorare senza limare a fondo. Se è una linea lunga fino alla matrice o su più dita, medico.</a:t>
+            </a:r>
+          </a:p>
+          <a:p>
+            <a:r>
+              <a:t>- Onicomicosi (fungo): macchia bianca o gialla che parte dal bordo libero, unghia spessa o fragile. Non si lavora. Cliente dal medico, strumenti disinfettati o buttati (lime), mascherina, mai usare lo stesso strumento sulle altre dita.</a:t>
+            </a:r>
+          </a:p>
+          <a:p>
+            <a:r>
+              <a:t>- Pseudomonas (verde): nasce con umidità tra gel e unghia (sollevamenti, gel non polimerizzato, cuticole non sigillate). Giallino = inizio. Smontare, cambiare/sterilizzare gli strumenti, lasciare l'unghia scoperta circa 15 giorni (minimo una settimana). Verde scuro avanzato: farmacista o medico.</a:t>
+            </a:r>
+          </a:p>
+          <a:p>
+            <a:r>
+              <a:t>- Paronichia (infiammazione attorno all'unghia, rossore, calore, dolore): non lavorare, medico. Cause: errori tecnici (cuticole forate), onicofagia, tagli. Evitare di spingere strumenti sotto la cuticola.</a:t>
+            </a:r>
+          </a:p>
+          <a:p>
+            <a:r>
+              <a:t>- Allergie (rossore, prurito, bollicine, pelle che si screpola): quasi sempre contatto del prodotto con la pelle o gel non polimerizzato. Possono comparire anche dopo mesi. Rimuovere tutto, inviare al medico; si riprende solo con certificato. Valutare prodotti senza ingredienti sensibilizzanti noti.</a:t>
+            </a:r>
+          </a:p>
+          <a:p>
+            <a:r>
+              <a:t>- Prevenzione: prodotto mai sulla pelle (anche primer e colore), guanti e mani pulite, lampada e polimerizzazione corrette. Meglio perdere un appuntamento che la fiducia della cliente.</a:t>
+            </a:r>
+          </a:p>
+        </p:txBody>
+      </p:sp>
+      <p:sp>
+        <p:nvSpPr>
+          <p:cNvPr id="4" name="Slide Number Placeholder 3"/>
+          <p:cNvSpPr>
+            <a:spLocks noGrp="1"/>
+          </p:cNvSpPr>
+          <p:nvPr>
+            <p:ph type="sldNum" idx="5" sz="quarter"/>
+          </p:nvPr>
+        </p:nvSpPr>
+        <p:spPr/>
+      </p:sp>
+    </p:spTree>
+  </p:cSld>
+  <p:clrMapOvr>
+    <a:masterClrMapping/>
+  </p:clrMapOvr>
+</p:notes>
+</file>
+
+<file path=ppt/notesSlides/notesSlide16.xml><?xml version="1.0" encoding="utf-8"?>
+<p:notes xmlns:a="http://schemas.openxmlformats.org/drawingml/2006/main" xmlns:p="http://schemas.openxmlformats.org/presentationml/2006/main" xmlns:r="http://schemas.openxmlformats.org/officeDocument/2006/relationships">
+  <p:cSld>
+    <p:spTree>
+      <p:nvGrpSpPr>
+        <p:cNvPr id="1" name=""/>
+        <p:cNvGrpSpPr/>
+        <p:nvPr/>
+      </p:nvGrpSpPr>
+      <p:grpSpPr>
+        <a:xfrm>
+          <a:off x="0" y="0"/>
+          <a:ext cx="0" cy="0"/>
+          <a:chOff x="0" y="0"/>
+          <a:chExt cx="0" cy="0"/>
+        </a:xfrm>
+      </p:grpSpPr>
+      <p:sp>
+        <p:nvSpPr>
+          <p:cNvPr id="2" name="Slide Image Placeholder 1"/>
+          <p:cNvSpPr>
+            <a:spLocks noGrp="1"/>
+          </p:cNvSpPr>
+          <p:nvPr>
+            <p:ph type="sldImg" idx="2"/>
+          </p:nvPr>
+        </p:nvSpPr>
+        <p:spPr/>
+      </p:sp>
+      <p:sp>
+        <p:nvSpPr>
+          <p:cNvPr id="3" name="Notes Placeholder 2"/>
+          <p:cNvSpPr>
+            <a:spLocks noGrp="1"/>
+          </p:cNvSpPr>
+          <p:nvPr>
+            <p:ph type="body" idx="3" sz="quarter"/>
+          </p:nvPr>
+        </p:nvSpPr>
+        <p:spPr/>
+        <p:txBody>
+          <a:bodyPr/>
+          <a:lstStyle/>
+          <a:p>
+            <a:r>
+              <a:t>Elenco generico: i marchi li scegliamo noi, non quelli citati nel corso.</a:t>
+            </a:r>
+          </a:p>
+          <a:p/>
+          <a:p>
+            <a:r>
+              <a:t>Dettaglio:</a:t>
+            </a:r>
+          </a:p>
+          <a:p>
+            <a:r>
+              <a:t>- Gel Tip trasparenti in gamma completa di misure e forme.</a:t>
+            </a:r>
+          </a:p>
+          <a:p>
+            <a:r>
+              <a:t>- Base/extension gel (anche rubber), deidratante, primer acid-free.</a:t>
+            </a:r>
+          </a:p>
+          <a:p>
+            <a:r>
+              <a:t>- Mandrino con cilindro abrasivo, punta conica in ceramica, punta per rimuovere lo scalino, buffer.</a:t>
+            </a:r>
+          </a:p>
+          <a:p>
+            <a:r>
+              <a:t>- Lampada/torcia per il blocco rapido.</a:t>
+            </a:r>
+          </a:p>
+          <a:p>
+            <a:r>
+              <a:t>- Rimozione: remover per semipermanente, vaschetta o ciotola, pusher, eventuale alluminio e pad.</a:t>
             </a:r>
           </a:p>
         </p:txBody>
@@ -6561,6 +6795,558 @@
                 <a:latin typeface="Calibri"/>
               </a:rPr>
               <a:t>•  Mai staccarla da sola</a:t>
+            </a:r>
+          </a:p>
+        </p:txBody>
+      </p:sp>
+      <p:sp>
+        <p:nvSpPr>
+          <p:cNvPr id="6" name="TextBox 5"/>
+          <p:cNvSpPr txBox="1"/>
+          <p:nvPr/>
+        </p:nvSpPr>
+        <p:spPr>
+          <a:xfrm>
+            <a:off x="822960" y="6309360"/>
+            <a:ext cx="3657600" cy="365760"/>
+          </a:xfrm>
+          <a:prstGeom prst="rect">
+            <a:avLst/>
+          </a:prstGeom>
+          <a:noFill/>
+        </p:spPr>
+        <p:txBody>
+          <a:bodyPr wrap="square">
+            <a:spAutoFit/>
+          </a:bodyPr>
+          <a:lstStyle/>
+          <a:p>
+            <a:r>
+              <a:rPr sz="1200" b="0">
+                <a:solidFill>
+                  <a:srgbClr val="B76E79"/>
+                </a:solidFill>
+                <a:latin typeface="Calibri"/>
+              </a:rPr>
+              <a:t>Lidia Nails</a:t>
+            </a:r>
+          </a:p>
+        </p:txBody>
+      </p:sp>
+    </p:spTree>
+  </p:cSld>
+  <p:clrMapOvr>
+    <a:masterClrMapping/>
+  </p:clrMapOvr>
+</p:sld>
+</file>
+
+<file path=ppt/slides/slide16.xml><?xml version="1.0" encoding="utf-8"?>
+<p:sld xmlns:a="http://schemas.openxmlformats.org/drawingml/2006/main" xmlns:p="http://schemas.openxmlformats.org/presentationml/2006/main" xmlns:r="http://schemas.openxmlformats.org/officeDocument/2006/relationships">
+  <p:cSld>
+    <p:spTree>
+      <p:nvGrpSpPr>
+        <p:cNvPr id="1" name=""/>
+        <p:cNvGrpSpPr/>
+        <p:nvPr/>
+      </p:nvGrpSpPr>
+      <p:grpSpPr/>
+      <p:sp>
+        <p:nvSpPr>
+          <p:cNvPr id="2" name="Rectangle 1"/>
+          <p:cNvSpPr/>
+          <p:nvPr/>
+        </p:nvSpPr>
+        <p:spPr>
+          <a:xfrm>
+            <a:off x="0" y="0"/>
+            <a:ext cx="12191695" cy="6858000"/>
+          </a:xfrm>
+          <a:prstGeom prst="rect">
+            <a:avLst/>
+          </a:prstGeom>
+          <a:solidFill>
+            <a:srgbClr val="FFFFFF"/>
+          </a:solidFill>
+          <a:ln>
+            <a:noFill/>
+          </a:ln>
+        </p:spPr>
+        <p:style>
+          <a:lnRef idx="1">
+            <a:schemeClr val="accent1"/>
+          </a:lnRef>
+          <a:fillRef idx="3">
+            <a:schemeClr val="accent1"/>
+          </a:fillRef>
+          <a:effectRef idx="2">
+            <a:schemeClr val="accent1"/>
+          </a:effectRef>
+          <a:fontRef idx="minor">
+            <a:schemeClr val="lt1"/>
+          </a:fontRef>
+        </p:style>
+        <p:txBody>
+          <a:bodyPr rtlCol="0" anchor="ctr"/>
+          <a:lstStyle/>
+          <a:p>
+            <a:pPr algn="ctr"/>
+          </a:p>
+        </p:txBody>
+      </p:sp>
+      <p:sp>
+        <p:nvSpPr>
+          <p:cNvPr id="3" name="Rectangle 2"/>
+          <p:cNvSpPr/>
+          <p:nvPr/>
+        </p:nvSpPr>
+        <p:spPr>
+          <a:xfrm>
+            <a:off x="0" y="0"/>
+            <a:ext cx="228600" cy="6858000"/>
+          </a:xfrm>
+          <a:prstGeom prst="rect">
+            <a:avLst/>
+          </a:prstGeom>
+          <a:solidFill>
+            <a:srgbClr val="B76E79"/>
+          </a:solidFill>
+          <a:ln>
+            <a:noFill/>
+          </a:ln>
+        </p:spPr>
+        <p:style>
+          <a:lnRef idx="1">
+            <a:schemeClr val="accent1"/>
+          </a:lnRef>
+          <a:fillRef idx="3">
+            <a:schemeClr val="accent1"/>
+          </a:fillRef>
+          <a:effectRef idx="2">
+            <a:schemeClr val="accent1"/>
+          </a:effectRef>
+          <a:fontRef idx="minor">
+            <a:schemeClr val="lt1"/>
+          </a:fontRef>
+        </p:style>
+        <p:txBody>
+          <a:bodyPr rtlCol="0" anchor="ctr"/>
+          <a:lstStyle/>
+          <a:p>
+            <a:pPr algn="ctr"/>
+          </a:p>
+        </p:txBody>
+      </p:sp>
+      <p:sp>
+        <p:nvSpPr>
+          <p:cNvPr id="4" name="TextBox 3"/>
+          <p:cNvSpPr txBox="1"/>
+          <p:nvPr/>
+        </p:nvSpPr>
+        <p:spPr>
+          <a:xfrm>
+            <a:off x="822960" y="548640"/>
+            <a:ext cx="10515600" cy="914400"/>
+          </a:xfrm>
+          <a:prstGeom prst="rect">
+            <a:avLst/>
+          </a:prstGeom>
+          <a:noFill/>
+        </p:spPr>
+        <p:txBody>
+          <a:bodyPr wrap="square">
+            <a:spAutoFit/>
+          </a:bodyPr>
+          <a:lstStyle/>
+          <a:p>
+            <a:r>
+              <a:rPr sz="3600" b="1">
+                <a:solidFill>
+                  <a:srgbClr val="2B2B2B"/>
+                </a:solidFill>
+                <a:latin typeface="Calibri"/>
+              </a:rPr>
+              <a:t>15. Anomalie: quando agire e quando inviare al medico</a:t>
+            </a:r>
+          </a:p>
+        </p:txBody>
+      </p:sp>
+      <p:sp>
+        <p:nvSpPr>
+          <p:cNvPr id="5" name="TextBox 4"/>
+          <p:cNvSpPr txBox="1"/>
+          <p:nvPr/>
+        </p:nvSpPr>
+        <p:spPr>
+          <a:xfrm>
+            <a:off x="822960" y="1737360"/>
+            <a:ext cx="10515600" cy="4389120"/>
+          </a:xfrm>
+          <a:prstGeom prst="rect">
+            <a:avLst/>
+          </a:prstGeom>
+          <a:noFill/>
+        </p:spPr>
+        <p:txBody>
+          <a:bodyPr wrap="square">
+            <a:spAutoFit/>
+          </a:bodyPr>
+          <a:lstStyle/>
+          <a:p>
+            <a:pPr>
+              <a:spcAft>
+                <a:spcPts val="1800"/>
+              </a:spcAft>
+            </a:pPr>
+            <a:r>
+              <a:rPr sz="2400" b="0">
+                <a:solidFill>
+                  <a:srgbClr val="2B2B2B"/>
+                </a:solidFill>
+                <a:latin typeface="Calibri"/>
+              </a:rPr>
+              <a:t/>
+            </a:r>
+            <a:r>
+              <a:rPr sz="2800">
+                <a:solidFill>
+                  <a:srgbClr val="2B2B2B"/>
+                </a:solidFill>
+                <a:latin typeface="Calibri"/>
+              </a:rPr>
+              <a:t>•  Noi curiamo l'estetica, non la salute</a:t>
+            </a:r>
+          </a:p>
+          <a:p>
+            <a:pPr>
+              <a:spcAft>
+                <a:spcPts val="1800"/>
+              </a:spcAft>
+            </a:pPr>
+            <a:r>
+              <a:rPr sz="2800">
+                <a:solidFill>
+                  <a:srgbClr val="2B2B2B"/>
+                </a:solidFill>
+                <a:latin typeface="Calibri"/>
+              </a:rPr>
+              <a:t>•  Anomalia su molte dita → medico</a:t>
+            </a:r>
+          </a:p>
+          <a:p>
+            <a:pPr>
+              <a:spcAft>
+                <a:spcPts val="1800"/>
+              </a:spcAft>
+            </a:pPr>
+            <a:r>
+              <a:rPr sz="2800">
+                <a:solidFill>
+                  <a:srgbClr val="2B2B2B"/>
+                </a:solidFill>
+                <a:latin typeface="Calibri"/>
+              </a:rPr>
+              <a:t>•  Fungo, pseudomonas grave, paronichia, allergia → si ferma</a:t>
+            </a:r>
+          </a:p>
+          <a:p>
+            <a:pPr>
+              <a:spcAft>
+                <a:spcPts val="1800"/>
+              </a:spcAft>
+            </a:pPr>
+            <a:r>
+              <a:rPr sz="2800">
+                <a:solidFill>
+                  <a:srgbClr val="2B2B2B"/>
+                </a:solidFill>
+                <a:latin typeface="Calibri"/>
+              </a:rPr>
+              <a:t>•  Prodotto mai sulla pelle</a:t>
+            </a:r>
+          </a:p>
+        </p:txBody>
+      </p:sp>
+      <p:sp>
+        <p:nvSpPr>
+          <p:cNvPr id="6" name="TextBox 5"/>
+          <p:cNvSpPr txBox="1"/>
+          <p:nvPr/>
+        </p:nvSpPr>
+        <p:spPr>
+          <a:xfrm>
+            <a:off x="822960" y="6309360"/>
+            <a:ext cx="3657600" cy="365760"/>
+          </a:xfrm>
+          <a:prstGeom prst="rect">
+            <a:avLst/>
+          </a:prstGeom>
+          <a:noFill/>
+        </p:spPr>
+        <p:txBody>
+          <a:bodyPr wrap="square">
+            <a:spAutoFit/>
+          </a:bodyPr>
+          <a:lstStyle/>
+          <a:p>
+            <a:r>
+              <a:rPr sz="1200" b="0">
+                <a:solidFill>
+                  <a:srgbClr val="B76E79"/>
+                </a:solidFill>
+                <a:latin typeface="Calibri"/>
+              </a:rPr>
+              <a:t>Lidia Nails</a:t>
+            </a:r>
+          </a:p>
+        </p:txBody>
+      </p:sp>
+    </p:spTree>
+  </p:cSld>
+  <p:clrMapOvr>
+    <a:masterClrMapping/>
+  </p:clrMapOvr>
+</p:sld>
+</file>
+
+<file path=ppt/slides/slide17.xml><?xml version="1.0" encoding="utf-8"?>
+<p:sld xmlns:a="http://schemas.openxmlformats.org/drawingml/2006/main" xmlns:p="http://schemas.openxmlformats.org/presentationml/2006/main" xmlns:r="http://schemas.openxmlformats.org/officeDocument/2006/relationships">
+  <p:cSld>
+    <p:spTree>
+      <p:nvGrpSpPr>
+        <p:cNvPr id="1" name=""/>
+        <p:cNvGrpSpPr/>
+        <p:nvPr/>
+      </p:nvGrpSpPr>
+      <p:grpSpPr/>
+      <p:sp>
+        <p:nvSpPr>
+          <p:cNvPr id="2" name="Rectangle 1"/>
+          <p:cNvSpPr/>
+          <p:nvPr/>
+        </p:nvSpPr>
+        <p:spPr>
+          <a:xfrm>
+            <a:off x="0" y="0"/>
+            <a:ext cx="12191695" cy="6858000"/>
+          </a:xfrm>
+          <a:prstGeom prst="rect">
+            <a:avLst/>
+          </a:prstGeom>
+          <a:solidFill>
+            <a:srgbClr val="FFFFFF"/>
+          </a:solidFill>
+          <a:ln>
+            <a:noFill/>
+          </a:ln>
+        </p:spPr>
+        <p:style>
+          <a:lnRef idx="1">
+            <a:schemeClr val="accent1"/>
+          </a:lnRef>
+          <a:fillRef idx="3">
+            <a:schemeClr val="accent1"/>
+          </a:fillRef>
+          <a:effectRef idx="2">
+            <a:schemeClr val="accent1"/>
+          </a:effectRef>
+          <a:fontRef idx="minor">
+            <a:schemeClr val="lt1"/>
+          </a:fontRef>
+        </p:style>
+        <p:txBody>
+          <a:bodyPr rtlCol="0" anchor="ctr"/>
+          <a:lstStyle/>
+          <a:p>
+            <a:pPr algn="ctr"/>
+          </a:p>
+        </p:txBody>
+      </p:sp>
+      <p:sp>
+        <p:nvSpPr>
+          <p:cNvPr id="3" name="Rectangle 2"/>
+          <p:cNvSpPr/>
+          <p:nvPr/>
+        </p:nvSpPr>
+        <p:spPr>
+          <a:xfrm>
+            <a:off x="0" y="0"/>
+            <a:ext cx="228600" cy="6858000"/>
+          </a:xfrm>
+          <a:prstGeom prst="rect">
+            <a:avLst/>
+          </a:prstGeom>
+          <a:solidFill>
+            <a:srgbClr val="B76E79"/>
+          </a:solidFill>
+          <a:ln>
+            <a:noFill/>
+          </a:ln>
+        </p:spPr>
+        <p:style>
+          <a:lnRef idx="1">
+            <a:schemeClr val="accent1"/>
+          </a:lnRef>
+          <a:fillRef idx="3">
+            <a:schemeClr val="accent1"/>
+          </a:fillRef>
+          <a:effectRef idx="2">
+            <a:schemeClr val="accent1"/>
+          </a:effectRef>
+          <a:fontRef idx="minor">
+            <a:schemeClr val="lt1"/>
+          </a:fontRef>
+        </p:style>
+        <p:txBody>
+          <a:bodyPr rtlCol="0" anchor="ctr"/>
+          <a:lstStyle/>
+          <a:p>
+            <a:pPr algn="ctr"/>
+          </a:p>
+        </p:txBody>
+      </p:sp>
+      <p:sp>
+        <p:nvSpPr>
+          <p:cNvPr id="4" name="TextBox 3"/>
+          <p:cNvSpPr txBox="1"/>
+          <p:nvPr/>
+        </p:nvSpPr>
+        <p:spPr>
+          <a:xfrm>
+            <a:off x="822960" y="548640"/>
+            <a:ext cx="10515600" cy="914400"/>
+          </a:xfrm>
+          <a:prstGeom prst="rect">
+            <a:avLst/>
+          </a:prstGeom>
+          <a:noFill/>
+        </p:spPr>
+        <p:txBody>
+          <a:bodyPr wrap="square">
+            <a:spAutoFit/>
+          </a:bodyPr>
+          <a:lstStyle/>
+          <a:p>
+            <a:r>
+              <a:rPr sz="3600" b="1">
+                <a:solidFill>
+                  <a:srgbClr val="2B2B2B"/>
+                </a:solidFill>
+                <a:latin typeface="Calibri"/>
+              </a:rPr>
+              <a:t>16. Materiali da avere</a:t>
+            </a:r>
+          </a:p>
+        </p:txBody>
+      </p:sp>
+      <p:sp>
+        <p:nvSpPr>
+          <p:cNvPr id="5" name="TextBox 4"/>
+          <p:cNvSpPr txBox="1"/>
+          <p:nvPr/>
+        </p:nvSpPr>
+        <p:spPr>
+          <a:xfrm>
+            <a:off x="822960" y="1737360"/>
+            <a:ext cx="10515600" cy="4389120"/>
+          </a:xfrm>
+          <a:prstGeom prst="rect">
+            <a:avLst/>
+          </a:prstGeom>
+          <a:noFill/>
+        </p:spPr>
+        <p:txBody>
+          <a:bodyPr wrap="square">
+            <a:spAutoFit/>
+          </a:bodyPr>
+          <a:lstStyle/>
+          <a:p>
+            <a:pPr>
+              <a:spcAft>
+                <a:spcPts val="1800"/>
+              </a:spcAft>
+            </a:pPr>
+            <a:r>
+              <a:rPr sz="2400" b="0">
+                <a:solidFill>
+                  <a:srgbClr val="2B2B2B"/>
+                </a:solidFill>
+                <a:latin typeface="Calibri"/>
+              </a:rPr>
+              <a:t/>
+            </a:r>
+            <a:r>
+              <a:rPr sz="2800">
+                <a:solidFill>
+                  <a:srgbClr val="2B2B2B"/>
+                </a:solidFill>
+                <a:latin typeface="Calibri"/>
+              </a:rPr>
+              <a:t>•  Gel tip trasparenti, tutte le misure</a:t>
+            </a:r>
+          </a:p>
+          <a:p>
+            <a:pPr>
+              <a:spcAft>
+                <a:spcPts val="1800"/>
+              </a:spcAft>
+            </a:pPr>
+            <a:r>
+              <a:rPr sz="2800">
+                <a:solidFill>
+                  <a:srgbClr val="2B2B2B"/>
+                </a:solidFill>
+                <a:latin typeface="Calibri"/>
+              </a:rPr>
+              <a:t>•  Base/extension gel, deidratante, primer acid-free</a:t>
+            </a:r>
+          </a:p>
+          <a:p>
+            <a:pPr>
+              <a:spcAft>
+                <a:spcPts val="1800"/>
+              </a:spcAft>
+            </a:pPr>
+            <a:r>
+              <a:rPr sz="2800">
+                <a:solidFill>
+                  <a:srgbClr val="2B2B2B"/>
+                </a:solidFill>
+                <a:latin typeface="Calibri"/>
+              </a:rPr>
+              <a:t>•  Mandrino, punta ceramica, punta scalino, buffer</a:t>
+            </a:r>
+          </a:p>
+          <a:p>
+            <a:pPr>
+              <a:spcAft>
+                <a:spcPts val="1800"/>
+              </a:spcAft>
+            </a:pPr>
+            <a:r>
+              <a:rPr sz="2800">
+                <a:solidFill>
+                  <a:srgbClr val="2B2B2B"/>
+                </a:solidFill>
+                <a:latin typeface="Calibri"/>
+              </a:rPr>
+              <a:t>•  Torcia + lampada</a:t>
+            </a:r>
+          </a:p>
+          <a:p>
+            <a:pPr>
+              <a:spcAft>
+                <a:spcPts val="1800"/>
+              </a:spcAft>
+            </a:pPr>
+            <a:r>
+              <a:rPr sz="2800">
+                <a:solidFill>
+                  <a:srgbClr val="2B2B2B"/>
+                </a:solidFill>
+                <a:latin typeface="Calibri"/>
+              </a:rPr>
+              <a:t>•  Remover, vaschetta, pusher</a:t>
             </a:r>
           </a:p>
         </p:txBody>

</xml_diff>

<commit_message>
Aggiunge schemi illustrati alle slide e script di generazione
Co-Authored-By: Claude Sonnet 5.5 <noreply@anthropic.com>
Claude-Session: https://claude.ai/code/session_015bvwL7pS6S8pvXY1d6szrs
</commit_message>
<xml_diff>
--- a/lidia-nails-corso/output/slide-lezione.pptx
+++ b/lidia-nails-corso/output/slide-lezione.pptx
@@ -5640,7 +5640,7 @@
         <p:spPr>
           <a:xfrm>
             <a:off x="822960" y="1737360"/>
-            <a:ext cx="10515600" cy="4389120"/>
+            <a:ext cx="5577840" cy="4389120"/>
           </a:xfrm>
           <a:prstGeom prst="rect">
             <a:avLst/>
@@ -5668,7 +5668,7 @@
               <a:t/>
             </a:r>
             <a:r>
-              <a:rPr sz="2800">
+              <a:rPr sz="2400">
                 <a:solidFill>
                   <a:srgbClr val="2B2B2B"/>
                 </a:solidFill>
@@ -5684,7 +5684,7 @@
               </a:spcAft>
             </a:pPr>
             <a:r>
-              <a:rPr sz="2800">
+              <a:rPr sz="2400">
                 <a:solidFill>
                   <a:srgbClr val="2B2B2B"/>
                 </a:solidFill>
@@ -5700,7 +5700,7 @@
               </a:spcAft>
             </a:pPr>
             <a:r>
-              <a:rPr sz="2800">
+              <a:rPr sz="2400">
                 <a:solidFill>
                   <a:srgbClr val="2B2B2B"/>
                 </a:solidFill>
@@ -5716,7 +5716,7 @@
               </a:spcAft>
             </a:pPr>
             <a:r>
-              <a:rPr sz="2800">
+              <a:rPr sz="2400">
                 <a:solidFill>
                   <a:srgbClr val="2B2B2B"/>
                 </a:solidFill>
@@ -5732,7 +5732,7 @@
               </a:spcAft>
             </a:pPr>
             <a:r>
-              <a:rPr sz="2800">
+              <a:rPr sz="2400">
                 <a:solidFill>
                   <a:srgbClr val="2B2B2B"/>
                 </a:solidFill>
@@ -5743,9 +5743,33 @@
           </a:p>
         </p:txBody>
       </p:sp>
-      <p:sp>
-        <p:nvSpPr>
-          <p:cNvPr id="6" name="TextBox 5"/>
+      <p:pic>
+        <p:nvPicPr>
+          <p:cNvPr id="6" name="Picture 5" descr="applicazione.png"/>
+          <p:cNvPicPr>
+            <a:picLocks noChangeAspect="1"/>
+          </p:cNvPicPr>
+          <p:nvPr/>
+        </p:nvPicPr>
+        <p:blipFill>
+          <a:blip r:embed="rId2"/>
+          <a:stretch>
+            <a:fillRect/>
+          </a:stretch>
+        </p:blipFill>
+        <p:spPr>
+          <a:xfrm>
+            <a:off x="6766560" y="1554480"/>
+            <a:ext cx="5029200" cy="3394710"/>
+          </a:xfrm>
+          <a:prstGeom prst="rect">
+            <a:avLst/>
+          </a:prstGeom>
+        </p:spPr>
+      </p:pic>
+      <p:sp>
+        <p:nvSpPr>
+          <p:cNvPr id="7" name="TextBox 6"/>
           <p:cNvSpPr txBox="1"/>
           <p:nvPr/>
         </p:nvSpPr>
@@ -5924,7 +5948,7 @@
         <p:spPr>
           <a:xfrm>
             <a:off x="822960" y="1737360"/>
-            <a:ext cx="10515600" cy="4389120"/>
+            <a:ext cx="5577840" cy="4389120"/>
           </a:xfrm>
           <a:prstGeom prst="rect">
             <a:avLst/>
@@ -5952,7 +5976,7 @@
               <a:t/>
             </a:r>
             <a:r>
-              <a:rPr sz="2800">
+              <a:rPr sz="2400">
                 <a:solidFill>
                   <a:srgbClr val="2B2B2B"/>
                 </a:solidFill>
@@ -5968,7 +5992,7 @@
               </a:spcAft>
             </a:pPr>
             <a:r>
-              <a:rPr sz="2800">
+              <a:rPr sz="2400">
                 <a:solidFill>
                   <a:srgbClr val="2B2B2B"/>
                 </a:solidFill>
@@ -5984,7 +6008,7 @@
               </a:spcAft>
             </a:pPr>
             <a:r>
-              <a:rPr sz="2800">
+              <a:rPr sz="2400">
                 <a:solidFill>
                   <a:srgbClr val="2B2B2B"/>
                 </a:solidFill>
@@ -5995,9 +6019,33 @@
           </a:p>
         </p:txBody>
       </p:sp>
-      <p:sp>
-        <p:nvSpPr>
-          <p:cNvPr id="6" name="TextBox 5"/>
+      <p:pic>
+        <p:nvPicPr>
+          <p:cNvPr id="6" name="Picture 5" descr="inclinazione.png"/>
+          <p:cNvPicPr>
+            <a:picLocks noChangeAspect="1"/>
+          </p:cNvPicPr>
+          <p:nvPr/>
+        </p:nvPicPr>
+        <p:blipFill>
+          <a:blip r:embed="rId2"/>
+          <a:stretch>
+            <a:fillRect/>
+          </a:stretch>
+        </p:blipFill>
+        <p:spPr>
+          <a:xfrm>
+            <a:off x="6766560" y="1554480"/>
+            <a:ext cx="5029200" cy="3771900"/>
+          </a:xfrm>
+          <a:prstGeom prst="rect">
+            <a:avLst/>
+          </a:prstGeom>
+        </p:spPr>
+      </p:pic>
+      <p:sp>
+        <p:nvSpPr>
+          <p:cNvPr id="7" name="TextBox 6"/>
           <p:cNvSpPr txBox="1"/>
           <p:nvPr/>
         </p:nvSpPr>
@@ -6444,7 +6492,7 @@
         <p:spPr>
           <a:xfrm>
             <a:off x="822960" y="1737360"/>
-            <a:ext cx="10515600" cy="4389120"/>
+            <a:ext cx="5577840" cy="4389120"/>
           </a:xfrm>
           <a:prstGeom prst="rect">
             <a:avLst/>
@@ -6472,7 +6520,7 @@
               <a:t/>
             </a:r>
             <a:r>
-              <a:rPr sz="2800">
+              <a:rPr sz="2400">
                 <a:solidFill>
                   <a:srgbClr val="2B2B2B"/>
                 </a:solidFill>
@@ -6488,7 +6536,7 @@
               </a:spcAft>
             </a:pPr>
             <a:r>
-              <a:rPr sz="2800">
+              <a:rPr sz="2400">
                 <a:solidFill>
                   <a:srgbClr val="2B2B2B"/>
                 </a:solidFill>
@@ -6504,7 +6552,7 @@
               </a:spcAft>
             </a:pPr>
             <a:r>
-              <a:rPr sz="2800">
+              <a:rPr sz="2400">
                 <a:solidFill>
                   <a:srgbClr val="2B2B2B"/>
                 </a:solidFill>
@@ -6520,7 +6568,7 @@
               </a:spcAft>
             </a:pPr>
             <a:r>
-              <a:rPr sz="2800">
+              <a:rPr sz="2400">
                 <a:solidFill>
                   <a:srgbClr val="2B2B2B"/>
                 </a:solidFill>
@@ -6531,9 +6579,33 @@
           </a:p>
         </p:txBody>
       </p:sp>
-      <p:sp>
-        <p:nvSpPr>
-          <p:cNvPr id="6" name="TextBox 5"/>
+      <p:pic>
+        <p:nvPicPr>
+          <p:cNvPr id="6" name="Picture 5" descr="rimozione.png"/>
+          <p:cNvPicPr>
+            <a:picLocks noChangeAspect="1"/>
+          </p:cNvPicPr>
+          <p:nvPr/>
+        </p:nvPicPr>
+        <p:blipFill>
+          <a:blip r:embed="rId2"/>
+          <a:stretch>
+            <a:fillRect/>
+          </a:stretch>
+        </p:blipFill>
+        <p:spPr>
+          <a:xfrm>
+            <a:off x="6766560" y="1554480"/>
+            <a:ext cx="5029200" cy="3394710"/>
+          </a:xfrm>
+          <a:prstGeom prst="rect">
+            <a:avLst/>
+          </a:prstGeom>
+        </p:spPr>
+      </p:pic>
+      <p:sp>
+        <p:nvSpPr>
+          <p:cNvPr id="7" name="TextBox 6"/>
           <p:cNvSpPr txBox="1"/>
           <p:nvPr/>
         </p:nvSpPr>
@@ -6966,7 +7038,7 @@
                 </a:solidFill>
                 <a:latin typeface="Calibri"/>
               </a:rPr>
-              <a:t>15. Anomalie: quando agire e quando inviare al medico</a:t>
+              <a:t>15. Anomalie: quando fermarsi</a:t>
             </a:r>
           </a:p>
         </p:txBody>
@@ -6980,7 +7052,7 @@
         <p:spPr>
           <a:xfrm>
             <a:off x="822960" y="1737360"/>
-            <a:ext cx="10515600" cy="4389120"/>
+            <a:ext cx="5577840" cy="4389120"/>
           </a:xfrm>
           <a:prstGeom prst="rect">
             <a:avLst/>
@@ -7008,7 +7080,7 @@
               <a:t/>
             </a:r>
             <a:r>
-              <a:rPr sz="2800">
+              <a:rPr sz="2400">
                 <a:solidFill>
                   <a:srgbClr val="2B2B2B"/>
                 </a:solidFill>
@@ -7024,7 +7096,7 @@
               </a:spcAft>
             </a:pPr>
             <a:r>
-              <a:rPr sz="2800">
+              <a:rPr sz="2400">
                 <a:solidFill>
                   <a:srgbClr val="2B2B2B"/>
                 </a:solidFill>
@@ -7040,7 +7112,7 @@
               </a:spcAft>
             </a:pPr>
             <a:r>
-              <a:rPr sz="2800">
+              <a:rPr sz="2400">
                 <a:solidFill>
                   <a:srgbClr val="2B2B2B"/>
                 </a:solidFill>
@@ -7056,7 +7128,7 @@
               </a:spcAft>
             </a:pPr>
             <a:r>
-              <a:rPr sz="2800">
+              <a:rPr sz="2400">
                 <a:solidFill>
                   <a:srgbClr val="2B2B2B"/>
                 </a:solidFill>
@@ -7067,9 +7139,33 @@
           </a:p>
         </p:txBody>
       </p:sp>
-      <p:sp>
-        <p:nvSpPr>
-          <p:cNvPr id="6" name="TextBox 5"/>
+      <p:pic>
+        <p:nvPicPr>
+          <p:cNvPr id="6" name="Picture 5" descr="semaforo.png"/>
+          <p:cNvPicPr>
+            <a:picLocks noChangeAspect="1"/>
+          </p:cNvPicPr>
+          <p:nvPr/>
+        </p:nvPicPr>
+        <p:blipFill>
+          <a:blip r:embed="rId2"/>
+          <a:stretch>
+            <a:fillRect/>
+          </a:stretch>
+        </p:blipFill>
+        <p:spPr>
+          <a:xfrm>
+            <a:off x="6766560" y="1554480"/>
+            <a:ext cx="5029200" cy="3834765"/>
+          </a:xfrm>
+          <a:prstGeom prst="rect">
+            <a:avLst/>
+          </a:prstGeom>
+        </p:spPr>
+      </p:pic>
+      <p:sp>
+        <p:nvSpPr>
+          <p:cNvPr id="7" name="TextBox 6"/>
           <p:cNvSpPr txBox="1"/>
           <p:nvPr/>
         </p:nvSpPr>
@@ -8336,7 +8432,7 @@
         <p:spPr>
           <a:xfrm>
             <a:off x="822960" y="1737360"/>
-            <a:ext cx="10515600" cy="4389120"/>
+            <a:ext cx="5577840" cy="4389120"/>
           </a:xfrm>
           <a:prstGeom prst="rect">
             <a:avLst/>
@@ -8364,7 +8460,7 @@
               <a:t/>
             </a:r>
             <a:r>
-              <a:rPr sz="2800">
+              <a:rPr sz="2400">
                 <a:solidFill>
                   <a:srgbClr val="2B2B2B"/>
                 </a:solidFill>
@@ -8380,7 +8476,7 @@
               </a:spcAft>
             </a:pPr>
             <a:r>
-              <a:rPr sz="2800">
+              <a:rPr sz="2400">
                 <a:solidFill>
                   <a:srgbClr val="2B2B2B"/>
                 </a:solidFill>
@@ -8396,7 +8492,7 @@
               </a:spcAft>
             </a:pPr>
             <a:r>
-              <a:rPr sz="2800">
+              <a:rPr sz="2400">
                 <a:solidFill>
                   <a:srgbClr val="2B2B2B"/>
                 </a:solidFill>
@@ -8412,7 +8508,7 @@
               </a:spcAft>
             </a:pPr>
             <a:r>
-              <a:rPr sz="2800">
+              <a:rPr sz="2400">
                 <a:solidFill>
                   <a:srgbClr val="2B2B2B"/>
                 </a:solidFill>
@@ -8423,9 +8519,33 @@
           </a:p>
         </p:txBody>
       </p:sp>
-      <p:sp>
-        <p:nvSpPr>
-          <p:cNvPr id="6" name="TextBox 5"/>
+      <p:pic>
+        <p:nvPicPr>
+          <p:cNvPr id="6" name="Picture 5" descr="struttura-tip.png"/>
+          <p:cNvPicPr>
+            <a:picLocks noChangeAspect="1"/>
+          </p:cNvPicPr>
+          <p:nvPr/>
+        </p:nvPicPr>
+        <p:blipFill>
+          <a:blip r:embed="rId2"/>
+          <a:stretch>
+            <a:fillRect/>
+          </a:stretch>
+        </p:blipFill>
+        <p:spPr>
+          <a:xfrm>
+            <a:off x="6766560" y="1554480"/>
+            <a:ext cx="5029200" cy="3771900"/>
+          </a:xfrm>
+          <a:prstGeom prst="rect">
+            <a:avLst/>
+          </a:prstGeom>
+        </p:spPr>
+      </p:pic>
+      <p:sp>
+        <p:nvSpPr>
+          <p:cNvPr id="7" name="TextBox 6"/>
           <p:cNvSpPr txBox="1"/>
           <p:nvPr/>
         </p:nvSpPr>
@@ -8604,7 +8724,7 @@
         <p:spPr>
           <a:xfrm>
             <a:off x="822960" y="1737360"/>
-            <a:ext cx="10515600" cy="4389120"/>
+            <a:ext cx="5577840" cy="4389120"/>
           </a:xfrm>
           <a:prstGeom prst="rect">
             <a:avLst/>
@@ -8632,7 +8752,7 @@
               <a:t/>
             </a:r>
             <a:r>
-              <a:rPr sz="2800">
+              <a:rPr sz="2400">
                 <a:solidFill>
                   <a:srgbClr val="2B2B2B"/>
                 </a:solidFill>
@@ -8648,7 +8768,7 @@
               </a:spcAft>
             </a:pPr>
             <a:r>
-              <a:rPr sz="2800">
+              <a:rPr sz="2400">
                 <a:solidFill>
                   <a:srgbClr val="2B2B2B"/>
                 </a:solidFill>
@@ -8664,7 +8784,7 @@
               </a:spcAft>
             </a:pPr>
             <a:r>
-              <a:rPr sz="2800">
+              <a:rPr sz="2400">
                 <a:solidFill>
                   <a:srgbClr val="2B2B2B"/>
                 </a:solidFill>
@@ -8675,9 +8795,33 @@
           </a:p>
         </p:txBody>
       </p:sp>
-      <p:sp>
-        <p:nvSpPr>
-          <p:cNvPr id="6" name="TextBox 5"/>
+      <p:pic>
+        <p:nvPicPr>
+          <p:cNvPr id="6" name="Picture 5" descr="tip-tipi.png"/>
+          <p:cNvPicPr>
+            <a:picLocks noChangeAspect="1"/>
+          </p:cNvPicPr>
+          <p:nvPr/>
+        </p:nvPicPr>
+        <p:blipFill>
+          <a:blip r:embed="rId2"/>
+          <a:stretch>
+            <a:fillRect/>
+          </a:stretch>
+        </p:blipFill>
+        <p:spPr>
+          <a:xfrm>
+            <a:off x="6766560" y="1554480"/>
+            <a:ext cx="5029200" cy="3771900"/>
+          </a:xfrm>
+          <a:prstGeom prst="rect">
+            <a:avLst/>
+          </a:prstGeom>
+        </p:spPr>
+      </p:pic>
+      <p:sp>
+        <p:nvSpPr>
+          <p:cNvPr id="7" name="TextBox 6"/>
           <p:cNvSpPr txBox="1"/>
           <p:nvPr/>
         </p:nvSpPr>
@@ -8856,7 +9000,7 @@
         <p:spPr>
           <a:xfrm>
             <a:off x="822960" y="1737360"/>
-            <a:ext cx="10515600" cy="4389120"/>
+            <a:ext cx="5577840" cy="4389120"/>
           </a:xfrm>
           <a:prstGeom prst="rect">
             <a:avLst/>
@@ -8884,7 +9028,7 @@
               <a:t/>
             </a:r>
             <a:r>
-              <a:rPr sz="2800">
+              <a:rPr sz="2400">
                 <a:solidFill>
                   <a:srgbClr val="2B2B2B"/>
                 </a:solidFill>
@@ -8900,7 +9044,7 @@
               </a:spcAft>
             </a:pPr>
             <a:r>
-              <a:rPr sz="2800">
+              <a:rPr sz="2400">
                 <a:solidFill>
                   <a:srgbClr val="2B2B2B"/>
                 </a:solidFill>
@@ -8916,7 +9060,7 @@
               </a:spcAft>
             </a:pPr>
             <a:r>
-              <a:rPr sz="2800">
+              <a:rPr sz="2400">
                 <a:solidFill>
                   <a:srgbClr val="2B2B2B"/>
                 </a:solidFill>
@@ -8932,7 +9076,7 @@
               </a:spcAft>
             </a:pPr>
             <a:r>
-              <a:rPr sz="2800">
+              <a:rPr sz="2400">
                 <a:solidFill>
                   <a:srgbClr val="2B2B2B"/>
                 </a:solidFill>
@@ -8943,9 +9087,33 @@
           </a:p>
         </p:txBody>
       </p:sp>
-      <p:sp>
-        <p:nvSpPr>
-          <p:cNvPr id="6" name="TextBox 5"/>
+      <p:pic>
+        <p:nvPicPr>
+          <p:cNvPr id="6" name="Picture 5" descr="misure-mano.png"/>
+          <p:cNvPicPr>
+            <a:picLocks noChangeAspect="1"/>
+          </p:cNvPicPr>
+          <p:nvPr/>
+        </p:nvPicPr>
+        <p:blipFill>
+          <a:blip r:embed="rId2"/>
+          <a:stretch>
+            <a:fillRect/>
+          </a:stretch>
+        </p:blipFill>
+        <p:spPr>
+          <a:xfrm>
+            <a:off x="6766560" y="1554480"/>
+            <a:ext cx="5029200" cy="3771900"/>
+          </a:xfrm>
+          <a:prstGeom prst="rect">
+            <a:avLst/>
+          </a:prstGeom>
+        </p:spPr>
+      </p:pic>
+      <p:sp>
+        <p:nvSpPr>
+          <p:cNvPr id="7" name="TextBox 6"/>
           <p:cNvSpPr txBox="1"/>
           <p:nvPr/>
         </p:nvSpPr>
@@ -9124,7 +9292,7 @@
         <p:spPr>
           <a:xfrm>
             <a:off x="822960" y="1737360"/>
-            <a:ext cx="10515600" cy="4389120"/>
+            <a:ext cx="5577840" cy="4389120"/>
           </a:xfrm>
           <a:prstGeom prst="rect">
             <a:avLst/>
@@ -9152,7 +9320,7 @@
               <a:t/>
             </a:r>
             <a:r>
-              <a:rPr sz="2800">
+              <a:rPr sz="2400">
                 <a:solidFill>
                   <a:srgbClr val="2B2B2B"/>
                 </a:solidFill>
@@ -9168,7 +9336,7 @@
               </a:spcAft>
             </a:pPr>
             <a:r>
-              <a:rPr sz="2800">
+              <a:rPr sz="2400">
                 <a:solidFill>
                   <a:srgbClr val="2B2B2B"/>
                 </a:solidFill>
@@ -9184,7 +9352,7 @@
               </a:spcAft>
             </a:pPr>
             <a:r>
-              <a:rPr sz="2800">
+              <a:rPr sz="2400">
                 <a:solidFill>
                   <a:srgbClr val="2B2B2B"/>
                 </a:solidFill>
@@ -9200,7 +9368,7 @@
               </a:spcAft>
             </a:pPr>
             <a:r>
-              <a:rPr sz="2800">
+              <a:rPr sz="2400">
                 <a:solidFill>
                   <a:srgbClr val="2B2B2B"/>
                 </a:solidFill>
@@ -9211,9 +9379,33 @@
           </a:p>
         </p:txBody>
       </p:sp>
-      <p:sp>
-        <p:nvSpPr>
-          <p:cNvPr id="6" name="TextBox 5"/>
+      <p:pic>
+        <p:nvPicPr>
+          <p:cNvPr id="6" name="Picture 5" descr="unghia-naturale.png"/>
+          <p:cNvPicPr>
+            <a:picLocks noChangeAspect="1"/>
+          </p:cNvPicPr>
+          <p:nvPr/>
+        </p:nvPicPr>
+        <p:blipFill>
+          <a:blip r:embed="rId2"/>
+          <a:stretch>
+            <a:fillRect/>
+          </a:stretch>
+        </p:blipFill>
+        <p:spPr>
+          <a:xfrm>
+            <a:off x="6766560" y="1554480"/>
+            <a:ext cx="5029200" cy="3771900"/>
+          </a:xfrm>
+          <a:prstGeom prst="rect">
+            <a:avLst/>
+          </a:prstGeom>
+        </p:spPr>
+      </p:pic>
+      <p:sp>
+        <p:nvSpPr>
+          <p:cNvPr id="7" name="TextBox 6"/>
           <p:cNvSpPr txBox="1"/>
           <p:nvPr/>
         </p:nvSpPr>
@@ -9392,7 +9584,7 @@
         <p:spPr>
           <a:xfrm>
             <a:off x="822960" y="1737360"/>
-            <a:ext cx="10515600" cy="4389120"/>
+            <a:ext cx="5577840" cy="4389120"/>
           </a:xfrm>
           <a:prstGeom prst="rect">
             <a:avLst/>
@@ -9420,7 +9612,7 @@
               <a:t/>
             </a:r>
             <a:r>
-              <a:rPr sz="2800">
+              <a:rPr sz="2400">
                 <a:solidFill>
                   <a:srgbClr val="2B2B2B"/>
                 </a:solidFill>
@@ -9436,7 +9628,7 @@
               </a:spcAft>
             </a:pPr>
             <a:r>
-              <a:rPr sz="2800">
+              <a:rPr sz="2400">
                 <a:solidFill>
                   <a:srgbClr val="2B2B2B"/>
                 </a:solidFill>
@@ -9452,7 +9644,7 @@
               </a:spcAft>
             </a:pPr>
             <a:r>
-              <a:rPr sz="2800">
+              <a:rPr sz="2400">
                 <a:solidFill>
                   <a:srgbClr val="2B2B2B"/>
                 </a:solidFill>
@@ -9468,7 +9660,7 @@
               </a:spcAft>
             </a:pPr>
             <a:r>
-              <a:rPr sz="2800">
+              <a:rPr sz="2400">
                 <a:solidFill>
                   <a:srgbClr val="2B2B2B"/>
                 </a:solidFill>
@@ -9479,9 +9671,33 @@
           </a:p>
         </p:txBody>
       </p:sp>
-      <p:sp>
-        <p:nvSpPr>
-          <p:cNvPr id="6" name="TextBox 5"/>
+      <p:pic>
+        <p:nvPicPr>
+          <p:cNvPr id="6" name="Picture 5" descr="scelta-misura.png"/>
+          <p:cNvPicPr>
+            <a:picLocks noChangeAspect="1"/>
+          </p:cNvPicPr>
+          <p:nvPr/>
+        </p:nvPicPr>
+        <p:blipFill>
+          <a:blip r:embed="rId2"/>
+          <a:stretch>
+            <a:fillRect/>
+          </a:stretch>
+        </p:blipFill>
+        <p:spPr>
+          <a:xfrm>
+            <a:off x="6766560" y="1554480"/>
+            <a:ext cx="5029200" cy="3771900"/>
+          </a:xfrm>
+          <a:prstGeom prst="rect">
+            <a:avLst/>
+          </a:prstGeom>
+        </p:spPr>
+      </p:pic>
+      <p:sp>
+        <p:nvSpPr>
+          <p:cNvPr id="7" name="TextBox 6"/>
           <p:cNvSpPr txBox="1"/>
           <p:nvPr/>
         </p:nvSpPr>

</xml_diff>

<commit_message>
Logo finale B, kit social e applicazione brand a guida e slide
Co-Authored-By: Claude Sonnet 5.5 <noreply@anthropic.com>
Claude-Session: https://claude.ai/code/session_015bvwL7pS6S8pvXY1d6szrs
</commit_message>
<xml_diff>
--- a/lidia-nails-corso/output/slide-lezione.pptx
+++ b/lidia-nails-corso/output/slide-lezione.pptx
@@ -5095,7 +5095,7 @@
             <a:avLst/>
           </a:prstGeom>
           <a:solidFill>
-            <a:srgbClr val="F6ECE9"/>
+            <a:srgbClr val="34402F"/>
           </a:solidFill>
           <a:ln>
             <a:noFill/>
@@ -5123,16 +5123,40 @@
           </a:p>
         </p:txBody>
       </p:sp>
-      <p:sp>
-        <p:nvSpPr>
-          <p:cNvPr id="3" name="TextBox 2"/>
+      <p:pic>
+        <p:nvPicPr>
+          <p:cNvPr id="3" name="Picture 2" descr="verticale-oro.png"/>
+          <p:cNvPicPr>
+            <a:picLocks noChangeAspect="1"/>
+          </p:cNvPicPr>
+          <p:nvPr/>
+        </p:nvPicPr>
+        <p:blipFill>
+          <a:blip r:embed="rId2"/>
+          <a:stretch>
+            <a:fillRect/>
+          </a:stretch>
+        </p:blipFill>
+        <p:spPr>
+          <a:xfrm>
+            <a:off x="914400" y="822960"/>
+            <a:ext cx="4839789" cy="5212080"/>
+          </a:xfrm>
+          <a:prstGeom prst="rect">
+            <a:avLst/>
+          </a:prstGeom>
+        </p:spPr>
+      </p:pic>
+      <p:sp>
+        <p:nvSpPr>
+          <p:cNvPr id="4" name="TextBox 3"/>
           <p:cNvSpPr txBox="1"/>
           <p:nvPr/>
         </p:nvSpPr>
         <p:spPr>
           <a:xfrm>
-            <a:off x="822960" y="2011680"/>
-            <a:ext cx="10058400" cy="548640"/>
+            <a:off x="5852160" y="2377440"/>
+            <a:ext cx="5852160" cy="1645920"/>
           </a:xfrm>
           <a:prstGeom prst="rect">
             <a:avLst/>
@@ -5146,27 +5170,70 @@
           <a:lstStyle/>
           <a:p>
             <a:r>
-              <a:rPr sz="2000" b="1">
-                <a:solidFill>
-                  <a:srgbClr val="B76E79"/>
-                </a:solidFill>
-                <a:latin typeface="Calibri"/>
+              <a:rPr sz="4000" b="0">
+                <a:solidFill>
+                  <a:srgbClr val="C9D8C5"/>
+                </a:solidFill>
+                <a:latin typeface="Playfair Display"/>
               </a:rPr>
-              <a:t>LIDIA NAILS</a:t>
-            </a:r>
-          </a:p>
-        </p:txBody>
-      </p:sp>
-      <p:sp>
-        <p:nvSpPr>
-          <p:cNvPr id="4" name="TextBox 3"/>
+              <a:t>Gel Tip: guida all'applicazione</a:t>
+            </a:r>
+          </a:p>
+        </p:txBody>
+      </p:sp>
+      <p:sp>
+        <p:nvSpPr>
+          <p:cNvPr id="5" name="Rectangle 4"/>
+          <p:cNvSpPr/>
+          <p:nvPr/>
+        </p:nvSpPr>
+        <p:spPr>
+          <a:xfrm>
+            <a:off x="5897880" y="3977639"/>
+            <a:ext cx="1463040" cy="45720"/>
+          </a:xfrm>
+          <a:prstGeom prst="rect">
+            <a:avLst/>
+          </a:prstGeom>
+          <a:solidFill>
+            <a:srgbClr val="C8A04A"/>
+          </a:solidFill>
+          <a:ln>
+            <a:noFill/>
+          </a:ln>
+        </p:spPr>
+        <p:style>
+          <a:lnRef idx="1">
+            <a:schemeClr val="accent1"/>
+          </a:lnRef>
+          <a:fillRef idx="3">
+            <a:schemeClr val="accent1"/>
+          </a:fillRef>
+          <a:effectRef idx="2">
+            <a:schemeClr val="accent1"/>
+          </a:effectRef>
+          <a:fontRef idx="minor">
+            <a:schemeClr val="lt1"/>
+          </a:fontRef>
+        </p:style>
+        <p:txBody>
+          <a:bodyPr rtlCol="0" anchor="ctr"/>
+          <a:lstStyle/>
+          <a:p>
+            <a:pPr algn="ctr"/>
+          </a:p>
+        </p:txBody>
+      </p:sp>
+      <p:sp>
+        <p:nvSpPr>
+          <p:cNvPr id="6" name="TextBox 5"/>
           <p:cNvSpPr txBox="1"/>
           <p:nvPr/>
         </p:nvSpPr>
         <p:spPr>
           <a:xfrm>
-            <a:off x="822960" y="2651760"/>
-            <a:ext cx="10515600" cy="1371600"/>
+            <a:off x="5852160" y="4206240"/>
+            <a:ext cx="5852160" cy="548640"/>
           </a:xfrm>
           <a:prstGeom prst="rect">
             <a:avLst/>
@@ -5180,45 +5247,11 @@
           <a:lstStyle/>
           <a:p>
             <a:r>
-              <a:rPr sz="4800" b="1">
-                <a:solidFill>
-                  <a:srgbClr val="2B2B2B"/>
-                </a:solidFill>
-                <a:latin typeface="Calibri"/>
-              </a:rPr>
-              <a:t>Gel Tip: guida all'applicazione</a:t>
-            </a:r>
-          </a:p>
-        </p:txBody>
-      </p:sp>
-      <p:sp>
-        <p:nvSpPr>
-          <p:cNvPr id="5" name="TextBox 4"/>
-          <p:cNvSpPr txBox="1"/>
-          <p:nvPr/>
-        </p:nvSpPr>
-        <p:spPr>
-          <a:xfrm>
-            <a:off x="822960" y="4206240"/>
-            <a:ext cx="10058400" cy="548640"/>
-          </a:xfrm>
-          <a:prstGeom prst="rect">
-            <a:avLst/>
-          </a:prstGeom>
-          <a:noFill/>
-        </p:spPr>
-        <p:txBody>
-          <a:bodyPr wrap="square">
-            <a:spAutoFit/>
-          </a:bodyPr>
-          <a:lstStyle/>
-          <a:p>
-            <a:r>
-              <a:rPr sz="2200" b="0">
-                <a:solidFill>
-                  <a:srgbClr val="777777"/>
-                </a:solidFill>
-                <a:latin typeface="Calibri"/>
+              <a:rPr sz="1800" b="0">
+                <a:solidFill>
+                  <a:srgbClr val="C9D8C5"/>
+                </a:solidFill>
+                <a:latin typeface="Montserrat"/>
               </a:rPr>
               <a:t>Metodo passo passo – uso interno</a:t>
             </a:r>
@@ -5258,7 +5291,7 @@
             <a:avLst/>
           </a:prstGeom>
           <a:solidFill>
-            <a:srgbClr val="FFFFFF"/>
+            <a:srgbClr val="FAF7F0"/>
           </a:solidFill>
           <a:ln>
             <a:noFill/>
@@ -5295,13 +5328,13 @@
         <p:spPr>
           <a:xfrm>
             <a:off x="0" y="0"/>
-            <a:ext cx="228600" cy="6858000"/>
+            <a:ext cx="201168" cy="6858000"/>
           </a:xfrm>
           <a:prstGeom prst="rect">
             <a:avLst/>
           </a:prstGeom>
           <a:solidFill>
-            <a:srgbClr val="B76E79"/>
+            <a:srgbClr val="C9D8C5"/>
           </a:solidFill>
           <a:ln>
             <a:noFill/>
@@ -5331,14 +5364,57 @@
       </p:sp>
       <p:sp>
         <p:nvSpPr>
-          <p:cNvPr id="4" name="TextBox 3"/>
+          <p:cNvPr id="4" name="Rectangle 3"/>
+          <p:cNvSpPr/>
+          <p:nvPr/>
+        </p:nvSpPr>
+        <p:spPr>
+          <a:xfrm>
+            <a:off x="201168" y="0"/>
+            <a:ext cx="36576" cy="6858000"/>
+          </a:xfrm>
+          <a:prstGeom prst="rect">
+            <a:avLst/>
+          </a:prstGeom>
+          <a:solidFill>
+            <a:srgbClr val="C8A04A"/>
+          </a:solidFill>
+          <a:ln>
+            <a:noFill/>
+          </a:ln>
+        </p:spPr>
+        <p:style>
+          <a:lnRef idx="1">
+            <a:schemeClr val="accent1"/>
+          </a:lnRef>
+          <a:fillRef idx="3">
+            <a:schemeClr val="accent1"/>
+          </a:fillRef>
+          <a:effectRef idx="2">
+            <a:schemeClr val="accent1"/>
+          </a:effectRef>
+          <a:fontRef idx="minor">
+            <a:schemeClr val="lt1"/>
+          </a:fontRef>
+        </p:style>
+        <p:txBody>
+          <a:bodyPr rtlCol="0" anchor="ctr"/>
+          <a:lstStyle/>
+          <a:p>
+            <a:pPr algn="ctr"/>
+          </a:p>
+        </p:txBody>
+      </p:sp>
+      <p:sp>
+        <p:nvSpPr>
+          <p:cNvPr id="5" name="TextBox 4"/>
           <p:cNvSpPr txBox="1"/>
           <p:nvPr/>
         </p:nvSpPr>
         <p:spPr>
           <a:xfrm>
-            <a:off x="822960" y="548640"/>
-            <a:ext cx="10515600" cy="914400"/>
+            <a:off x="822960" y="502920"/>
+            <a:ext cx="10789920" cy="914400"/>
           </a:xfrm>
           <a:prstGeom prst="rect">
             <a:avLst/>
@@ -5352,11 +5428,11 @@
           <a:lstStyle/>
           <a:p>
             <a:r>
-              <a:rPr sz="3600" b="1">
-                <a:solidFill>
-                  <a:srgbClr val="2B2B2B"/>
-                </a:solidFill>
-                <a:latin typeface="Calibri"/>
+              <a:rPr sz="3400" b="0">
+                <a:solidFill>
+                  <a:srgbClr val="34402F"/>
+                </a:solidFill>
+                <a:latin typeface="Playfair Display"/>
               </a:rPr>
               <a:t>9. Preparare la tip (interno)</a:t>
             </a:r>
@@ -5365,7 +5441,7 @@
       </p:sp>
       <p:sp>
         <p:nvSpPr>
-          <p:cNvPr id="5" name="TextBox 4"/>
+          <p:cNvPr id="6" name="TextBox 5"/>
           <p:cNvSpPr txBox="1"/>
           <p:nvPr/>
         </p:nvSpPr>
@@ -5387,24 +5463,24 @@
           <a:p>
             <a:pPr>
               <a:spcAft>
-                <a:spcPts val="1800"/>
+                <a:spcPts val="1600"/>
               </a:spcAft>
             </a:pPr>
             <a:r>
-              <a:rPr sz="2400" b="0">
-                <a:solidFill>
-                  <a:srgbClr val="2B2B2B"/>
-                </a:solidFill>
-                <a:latin typeface="Calibri"/>
+              <a:rPr sz="2200" b="0">
+                <a:solidFill>
+                  <a:srgbClr val="34402F"/>
+                </a:solidFill>
+                <a:latin typeface="Montserrat"/>
               </a:rPr>
               <a:t/>
             </a:r>
             <a:r>
-              <a:rPr sz="2800">
-                <a:solidFill>
-                  <a:srgbClr val="2B2B2B"/>
-                </a:solidFill>
-                <a:latin typeface="Calibri"/>
+              <a:rPr sz="2400">
+                <a:solidFill>
+                  <a:srgbClr val="34402F"/>
+                </a:solidFill>
+                <a:latin typeface="Montserrat"/>
               </a:rPr>
               <a:t>•  15.000–18.000 giri, fresa parallela</a:t>
             </a:r>
@@ -5412,15 +5488,15 @@
           <a:p>
             <a:pPr>
               <a:spcAft>
-                <a:spcPts val="1800"/>
+                <a:spcPts val="1600"/>
               </a:spcAft>
             </a:pPr>
             <a:r>
-              <a:rPr sz="2800">
-                <a:solidFill>
-                  <a:srgbClr val="2B2B2B"/>
-                </a:solidFill>
-                <a:latin typeface="Calibri"/>
+              <a:rPr sz="2400">
+                <a:solidFill>
+                  <a:srgbClr val="34402F"/>
+                </a:solidFill>
+                <a:latin typeface="Montserrat"/>
               </a:rPr>
               <a:t>•  Opacizza l'interno fino al letto ungueale</a:t>
             </a:r>
@@ -5428,15 +5504,15 @@
           <a:p>
             <a:pPr>
               <a:spcAft>
-                <a:spcPts val="1800"/>
+                <a:spcPts val="1600"/>
               </a:spcAft>
             </a:pPr>
             <a:r>
-              <a:rPr sz="2800">
-                <a:solidFill>
-                  <a:srgbClr val="2B2B2B"/>
-                </a:solidFill>
-                <a:latin typeface="Calibri"/>
+              <a:rPr sz="2400">
+                <a:solidFill>
+                  <a:srgbClr val="34402F"/>
+                </a:solidFill>
+                <a:latin typeface="Montserrat"/>
               </a:rPr>
               <a:t>•  Giro cuticola: solo in uscita (all'inizio)</a:t>
             </a:r>
@@ -5444,30 +5520,54 @@
           <a:p>
             <a:pPr>
               <a:spcAft>
-                <a:spcPts val="1800"/>
+                <a:spcPts val="1600"/>
               </a:spcAft>
             </a:pPr>
             <a:r>
-              <a:rPr sz="2800">
-                <a:solidFill>
-                  <a:srgbClr val="2B2B2B"/>
-                </a:solidFill>
-                <a:latin typeface="Calibri"/>
+              <a:rPr sz="2400">
+                <a:solidFill>
+                  <a:srgbClr val="34402F"/>
+                </a:solidFill>
+                <a:latin typeface="Montserrat"/>
               </a:rPr>
               <a:t>•  Mignolo: punta conica in ceramica</a:t>
             </a:r>
           </a:p>
         </p:txBody>
       </p:sp>
-      <p:sp>
-        <p:nvSpPr>
-          <p:cNvPr id="6" name="TextBox 5"/>
+      <p:pic>
+        <p:nvPicPr>
+          <p:cNvPr id="7" name="Picture 6" descr="emblema-oliva.png"/>
+          <p:cNvPicPr>
+            <a:picLocks noChangeAspect="1"/>
+          </p:cNvPicPr>
+          <p:nvPr/>
+        </p:nvPicPr>
+        <p:blipFill>
+          <a:blip r:embed="rId2"/>
+          <a:stretch>
+            <a:fillRect/>
+          </a:stretch>
+        </p:blipFill>
+        <p:spPr>
+          <a:xfrm>
+            <a:off x="822960" y="6126480"/>
+            <a:ext cx="342900" cy="457200"/>
+          </a:xfrm>
+          <a:prstGeom prst="rect">
+            <a:avLst/>
+          </a:prstGeom>
+        </p:spPr>
+      </p:pic>
+      <p:sp>
+        <p:nvSpPr>
+          <p:cNvPr id="8" name="TextBox 7"/>
           <p:cNvSpPr txBox="1"/>
           <p:nvPr/>
         </p:nvSpPr>
         <p:spPr>
           <a:xfrm>
-            <a:off x="822960" y="6309360"/>
+            <a:off x="1371600" y="6236208"/>
             <a:ext cx="3657600" cy="365760"/>
           </a:xfrm>
           <a:prstGeom prst="rect">
@@ -5482,13 +5582,13 @@
           <a:lstStyle/>
           <a:p>
             <a:r>
-              <a:rPr sz="1200" b="0">
-                <a:solidFill>
-                  <a:srgbClr val="B76E79"/>
-                </a:solidFill>
-                <a:latin typeface="Calibri"/>
+              <a:rPr sz="1000" b="1">
+                <a:solidFill>
+                  <a:srgbClr val="C8A04A"/>
+                </a:solidFill>
+                <a:latin typeface="Montserrat"/>
               </a:rPr>
-              <a:t>Lidia Nails</a:t>
+              <a:t>LIDIA · NAIL EXPERT</a:t>
             </a:r>
           </a:p>
         </p:txBody>
@@ -5526,7 +5626,7 @@
             <a:avLst/>
           </a:prstGeom>
           <a:solidFill>
-            <a:srgbClr val="FFFFFF"/>
+            <a:srgbClr val="FAF7F0"/>
           </a:solidFill>
           <a:ln>
             <a:noFill/>
@@ -5563,13 +5663,13 @@
         <p:spPr>
           <a:xfrm>
             <a:off x="0" y="0"/>
-            <a:ext cx="228600" cy="6858000"/>
+            <a:ext cx="201168" cy="6858000"/>
           </a:xfrm>
           <a:prstGeom prst="rect">
             <a:avLst/>
           </a:prstGeom>
           <a:solidFill>
-            <a:srgbClr val="B76E79"/>
+            <a:srgbClr val="C9D8C5"/>
           </a:solidFill>
           <a:ln>
             <a:noFill/>
@@ -5599,14 +5699,57 @@
       </p:sp>
       <p:sp>
         <p:nvSpPr>
-          <p:cNvPr id="4" name="TextBox 3"/>
+          <p:cNvPr id="4" name="Rectangle 3"/>
+          <p:cNvSpPr/>
+          <p:nvPr/>
+        </p:nvSpPr>
+        <p:spPr>
+          <a:xfrm>
+            <a:off x="201168" y="0"/>
+            <a:ext cx="36576" cy="6858000"/>
+          </a:xfrm>
+          <a:prstGeom prst="rect">
+            <a:avLst/>
+          </a:prstGeom>
+          <a:solidFill>
+            <a:srgbClr val="C8A04A"/>
+          </a:solidFill>
+          <a:ln>
+            <a:noFill/>
+          </a:ln>
+        </p:spPr>
+        <p:style>
+          <a:lnRef idx="1">
+            <a:schemeClr val="accent1"/>
+          </a:lnRef>
+          <a:fillRef idx="3">
+            <a:schemeClr val="accent1"/>
+          </a:fillRef>
+          <a:effectRef idx="2">
+            <a:schemeClr val="accent1"/>
+          </a:effectRef>
+          <a:fontRef idx="minor">
+            <a:schemeClr val="lt1"/>
+          </a:fontRef>
+        </p:style>
+        <p:txBody>
+          <a:bodyPr rtlCol="0" anchor="ctr"/>
+          <a:lstStyle/>
+          <a:p>
+            <a:pPr algn="ctr"/>
+          </a:p>
+        </p:txBody>
+      </p:sp>
+      <p:sp>
+        <p:nvSpPr>
+          <p:cNvPr id="5" name="TextBox 4"/>
           <p:cNvSpPr txBox="1"/>
           <p:nvPr/>
         </p:nvSpPr>
         <p:spPr>
           <a:xfrm>
-            <a:off x="822960" y="548640"/>
-            <a:ext cx="10515600" cy="914400"/>
+            <a:off x="822960" y="502920"/>
+            <a:ext cx="10789920" cy="914400"/>
           </a:xfrm>
           <a:prstGeom prst="rect">
             <a:avLst/>
@@ -5620,11 +5763,11 @@
           <a:lstStyle/>
           <a:p>
             <a:r>
-              <a:rPr sz="3600" b="1">
-                <a:solidFill>
-                  <a:srgbClr val="2B2B2B"/>
-                </a:solidFill>
-                <a:latin typeface="Calibri"/>
+              <a:rPr sz="3400" b="0">
+                <a:solidFill>
+                  <a:srgbClr val="34402F"/>
+                </a:solidFill>
+                <a:latin typeface="Playfair Display"/>
               </a:rPr>
               <a:t>10. Applicazione passo passo</a:t>
             </a:r>
@@ -5633,7 +5776,7 @@
       </p:sp>
       <p:sp>
         <p:nvSpPr>
-          <p:cNvPr id="5" name="TextBox 4"/>
+          <p:cNvPr id="6" name="TextBox 5"/>
           <p:cNvSpPr txBox="1"/>
           <p:nvPr/>
         </p:nvSpPr>
@@ -5655,24 +5798,24 @@
           <a:p>
             <a:pPr>
               <a:spcAft>
-                <a:spcPts val="1800"/>
+                <a:spcPts val="1600"/>
               </a:spcAft>
             </a:pPr>
             <a:r>
-              <a:rPr sz="2400" b="0">
-                <a:solidFill>
-                  <a:srgbClr val="2B2B2B"/>
-                </a:solidFill>
-                <a:latin typeface="Calibri"/>
+              <a:rPr sz="2200" b="0">
+                <a:solidFill>
+                  <a:srgbClr val="34402F"/>
+                </a:solidFill>
+                <a:latin typeface="Montserrat"/>
               </a:rPr>
               <a:t/>
             </a:r>
             <a:r>
-              <a:rPr sz="2400">
-                <a:solidFill>
-                  <a:srgbClr val="2B2B2B"/>
-                </a:solidFill>
-                <a:latin typeface="Calibri"/>
+              <a:rPr sz="2000">
+                <a:solidFill>
+                  <a:srgbClr val="34402F"/>
+                </a:solidFill>
+                <a:latin typeface="Montserrat"/>
               </a:rPr>
               <a:t>•  Dry manicure → opacizza → spolvera</a:t>
             </a:r>
@@ -5680,15 +5823,15 @@
           <a:p>
             <a:pPr>
               <a:spcAft>
-                <a:spcPts val="1800"/>
+                <a:spcPts val="1600"/>
               </a:spcAft>
             </a:pPr>
             <a:r>
-              <a:rPr sz="2400">
-                <a:solidFill>
-                  <a:srgbClr val="2B2B2B"/>
-                </a:solidFill>
-                <a:latin typeface="Calibri"/>
+              <a:rPr sz="2000">
+                <a:solidFill>
+                  <a:srgbClr val="34402F"/>
+                </a:solidFill>
+                <a:latin typeface="Montserrat"/>
               </a:rPr>
               <a:t>•  Deidratante + primer acid-free</a:t>
             </a:r>
@@ -5696,15 +5839,15 @@
           <a:p>
             <a:pPr>
               <a:spcAft>
-                <a:spcPts val="1800"/>
+                <a:spcPts val="1600"/>
               </a:spcAft>
             </a:pPr>
             <a:r>
-              <a:rPr sz="2400">
-                <a:solidFill>
-                  <a:srgbClr val="2B2B2B"/>
-                </a:solidFill>
-                <a:latin typeface="Calibri"/>
+              <a:rPr sz="2000">
+                <a:solidFill>
+                  <a:srgbClr val="34402F"/>
+                </a:solidFill>
+                <a:latin typeface="Montserrat"/>
               </a:rPr>
               <a:t>•  Base gel sottile + goccia nella tip</a:t>
             </a:r>
@@ -5712,15 +5855,15 @@
           <a:p>
             <a:pPr>
               <a:spcAft>
-                <a:spcPts val="1800"/>
+                <a:spcPts val="1600"/>
               </a:spcAft>
             </a:pPr>
             <a:r>
-              <a:rPr sz="2400">
-                <a:solidFill>
-                  <a:srgbClr val="2B2B2B"/>
-                </a:solidFill>
-                <a:latin typeface="Calibri"/>
+              <a:rPr sz="2000">
+                <a:solidFill>
+                  <a:srgbClr val="34402F"/>
+                </a:solidFill>
+                <a:latin typeface="Montserrat"/>
               </a:rPr>
               <a:t>•  Inclina, premi al centro, scendi lenta</a:t>
             </a:r>
@@ -5728,15 +5871,15 @@
           <a:p>
             <a:pPr>
               <a:spcAft>
-                <a:spcPts val="1800"/>
+                <a:spcPts val="1600"/>
               </a:spcAft>
             </a:pPr>
             <a:r>
-              <a:rPr sz="2400">
-                <a:solidFill>
-                  <a:srgbClr val="2B2B2B"/>
-                </a:solidFill>
-                <a:latin typeface="Calibri"/>
+              <a:rPr sz="2000">
+                <a:solidFill>
+                  <a:srgbClr val="34402F"/>
+                </a:solidFill>
+                <a:latin typeface="Montserrat"/>
               </a:rPr>
               <a:t>•  Lampo 7-8 s, poi 60 s in lampada</a:t>
             </a:r>
@@ -5745,7 +5888,7 @@
       </p:sp>
       <p:pic>
         <p:nvPicPr>
-          <p:cNvPr id="6" name="Picture 5" descr="applicazione.png"/>
+          <p:cNvPr id="7" name="Picture 6" descr="applicazione.png"/>
           <p:cNvPicPr>
             <a:picLocks noChangeAspect="1"/>
           </p:cNvPicPr>
@@ -5767,15 +5910,39 @@
           </a:prstGeom>
         </p:spPr>
       </p:pic>
-      <p:sp>
-        <p:nvSpPr>
-          <p:cNvPr id="7" name="TextBox 6"/>
+      <p:pic>
+        <p:nvPicPr>
+          <p:cNvPr id="8" name="Picture 7" descr="emblema-oliva.png"/>
+          <p:cNvPicPr>
+            <a:picLocks noChangeAspect="1"/>
+          </p:cNvPicPr>
+          <p:nvPr/>
+        </p:nvPicPr>
+        <p:blipFill>
+          <a:blip r:embed="rId3"/>
+          <a:stretch>
+            <a:fillRect/>
+          </a:stretch>
+        </p:blipFill>
+        <p:spPr>
+          <a:xfrm>
+            <a:off x="822960" y="6126480"/>
+            <a:ext cx="342900" cy="457200"/>
+          </a:xfrm>
+          <a:prstGeom prst="rect">
+            <a:avLst/>
+          </a:prstGeom>
+        </p:spPr>
+      </p:pic>
+      <p:sp>
+        <p:nvSpPr>
+          <p:cNvPr id="9" name="TextBox 8"/>
           <p:cNvSpPr txBox="1"/>
           <p:nvPr/>
         </p:nvSpPr>
         <p:spPr>
           <a:xfrm>
-            <a:off x="822960" y="6309360"/>
+            <a:off x="1371600" y="6236208"/>
             <a:ext cx="3657600" cy="365760"/>
           </a:xfrm>
           <a:prstGeom prst="rect">
@@ -5790,13 +5957,13 @@
           <a:lstStyle/>
           <a:p>
             <a:r>
-              <a:rPr sz="1200" b="0">
-                <a:solidFill>
-                  <a:srgbClr val="B76E79"/>
-                </a:solidFill>
-                <a:latin typeface="Calibri"/>
+              <a:rPr sz="1000" b="1">
+                <a:solidFill>
+                  <a:srgbClr val="C8A04A"/>
+                </a:solidFill>
+                <a:latin typeface="Montserrat"/>
               </a:rPr>
-              <a:t>Lidia Nails</a:t>
+              <a:t>LIDIA · NAIL EXPERT</a:t>
             </a:r>
           </a:p>
         </p:txBody>
@@ -5834,7 +6001,7 @@
             <a:avLst/>
           </a:prstGeom>
           <a:solidFill>
-            <a:srgbClr val="FFFFFF"/>
+            <a:srgbClr val="FAF7F0"/>
           </a:solidFill>
           <a:ln>
             <a:noFill/>
@@ -5871,13 +6038,13 @@
         <p:spPr>
           <a:xfrm>
             <a:off x="0" y="0"/>
-            <a:ext cx="228600" cy="6858000"/>
+            <a:ext cx="201168" cy="6858000"/>
           </a:xfrm>
           <a:prstGeom prst="rect">
             <a:avLst/>
           </a:prstGeom>
           <a:solidFill>
-            <a:srgbClr val="B76E79"/>
+            <a:srgbClr val="C9D8C5"/>
           </a:solidFill>
           <a:ln>
             <a:noFill/>
@@ -5907,14 +6074,57 @@
       </p:sp>
       <p:sp>
         <p:nvSpPr>
-          <p:cNvPr id="4" name="TextBox 3"/>
+          <p:cNvPr id="4" name="Rectangle 3"/>
+          <p:cNvSpPr/>
+          <p:nvPr/>
+        </p:nvSpPr>
+        <p:spPr>
+          <a:xfrm>
+            <a:off x="201168" y="0"/>
+            <a:ext cx="36576" cy="6858000"/>
+          </a:xfrm>
+          <a:prstGeom prst="rect">
+            <a:avLst/>
+          </a:prstGeom>
+          <a:solidFill>
+            <a:srgbClr val="C8A04A"/>
+          </a:solidFill>
+          <a:ln>
+            <a:noFill/>
+          </a:ln>
+        </p:spPr>
+        <p:style>
+          <a:lnRef idx="1">
+            <a:schemeClr val="accent1"/>
+          </a:lnRef>
+          <a:fillRef idx="3">
+            <a:schemeClr val="accent1"/>
+          </a:fillRef>
+          <a:effectRef idx="2">
+            <a:schemeClr val="accent1"/>
+          </a:effectRef>
+          <a:fontRef idx="minor">
+            <a:schemeClr val="lt1"/>
+          </a:fontRef>
+        </p:style>
+        <p:txBody>
+          <a:bodyPr rtlCol="0" anchor="ctr"/>
+          <a:lstStyle/>
+          <a:p>
+            <a:pPr algn="ctr"/>
+          </a:p>
+        </p:txBody>
+      </p:sp>
+      <p:sp>
+        <p:nvSpPr>
+          <p:cNvPr id="5" name="TextBox 4"/>
           <p:cNvSpPr txBox="1"/>
           <p:nvPr/>
         </p:nvSpPr>
         <p:spPr>
           <a:xfrm>
-            <a:off x="822960" y="548640"/>
-            <a:ext cx="10515600" cy="914400"/>
+            <a:off x="822960" y="502920"/>
+            <a:ext cx="10789920" cy="914400"/>
           </a:xfrm>
           <a:prstGeom prst="rect">
             <a:avLst/>
@@ -5928,11 +6138,11 @@
           <a:lstStyle/>
           <a:p>
             <a:r>
-              <a:rPr sz="3600" b="1">
-                <a:solidFill>
-                  <a:srgbClr val="2B2B2B"/>
-                </a:solidFill>
-                <a:latin typeface="Calibri"/>
+              <a:rPr sz="3400" b="0">
+                <a:solidFill>
+                  <a:srgbClr val="34402F"/>
+                </a:solidFill>
+                <a:latin typeface="Playfair Display"/>
               </a:rPr>
               <a:t>11. Errori di inclinazione e quantità</a:t>
             </a:r>
@@ -5941,7 +6151,7 @@
       </p:sp>
       <p:sp>
         <p:nvSpPr>
-          <p:cNvPr id="5" name="TextBox 4"/>
+          <p:cNvPr id="6" name="TextBox 5"/>
           <p:cNvSpPr txBox="1"/>
           <p:nvPr/>
         </p:nvSpPr>
@@ -5963,24 +6173,24 @@
           <a:p>
             <a:pPr>
               <a:spcAft>
-                <a:spcPts val="1800"/>
+                <a:spcPts val="1600"/>
               </a:spcAft>
             </a:pPr>
             <a:r>
-              <a:rPr sz="2400" b="0">
-                <a:solidFill>
-                  <a:srgbClr val="2B2B2B"/>
-                </a:solidFill>
-                <a:latin typeface="Calibri"/>
+              <a:rPr sz="2200" b="0">
+                <a:solidFill>
+                  <a:srgbClr val="34402F"/>
+                </a:solidFill>
+                <a:latin typeface="Montserrat"/>
               </a:rPr>
               <a:t/>
             </a:r>
             <a:r>
-              <a:rPr sz="2400">
-                <a:solidFill>
-                  <a:srgbClr val="2B2B2B"/>
-                </a:solidFill>
-                <a:latin typeface="Calibri"/>
+              <a:rPr sz="2000">
+                <a:solidFill>
+                  <a:srgbClr val="34402F"/>
+                </a:solidFill>
+                <a:latin typeface="Montserrat"/>
               </a:rPr>
               <a:t>•  Troppo veloce o troppo lento: gel sui lati</a:t>
             </a:r>
@@ -5988,15 +6198,15 @@
           <a:p>
             <a:pPr>
               <a:spcAft>
-                <a:spcPts val="1800"/>
+                <a:spcPts val="1600"/>
               </a:spcAft>
             </a:pPr>
             <a:r>
-              <a:rPr sz="2400">
-                <a:solidFill>
-                  <a:srgbClr val="2B2B2B"/>
-                </a:solidFill>
-                <a:latin typeface="Calibri"/>
+              <a:rPr sz="2000">
+                <a:solidFill>
+                  <a:srgbClr val="34402F"/>
+                </a:solidFill>
+                <a:latin typeface="Montserrat"/>
               </a:rPr>
               <a:t>•  Niente colpo a vuoto, non vicino alla cuticola</a:t>
             </a:r>
@@ -6004,15 +6214,15 @@
           <a:p>
             <a:pPr>
               <a:spcAft>
-                <a:spcPts val="1800"/>
+                <a:spcPts val="1600"/>
               </a:spcAft>
             </a:pPr>
             <a:r>
-              <a:rPr sz="2400">
-                <a:solidFill>
-                  <a:srgbClr val="2B2B2B"/>
-                </a:solidFill>
-                <a:latin typeface="Calibri"/>
+              <a:rPr sz="2000">
+                <a:solidFill>
+                  <a:srgbClr val="34402F"/>
+                </a:solidFill>
+                <a:latin typeface="Montserrat"/>
               </a:rPr>
               <a:t>•  Il gel che cammina = quantità giusta</a:t>
             </a:r>
@@ -6021,7 +6231,7 @@
       </p:sp>
       <p:pic>
         <p:nvPicPr>
-          <p:cNvPr id="6" name="Picture 5" descr="inclinazione.png"/>
+          <p:cNvPr id="7" name="Picture 6" descr="inclinazione.png"/>
           <p:cNvPicPr>
             <a:picLocks noChangeAspect="1"/>
           </p:cNvPicPr>
@@ -6043,15 +6253,39 @@
           </a:prstGeom>
         </p:spPr>
       </p:pic>
-      <p:sp>
-        <p:nvSpPr>
-          <p:cNvPr id="7" name="TextBox 6"/>
+      <p:pic>
+        <p:nvPicPr>
+          <p:cNvPr id="8" name="Picture 7" descr="emblema-oliva.png"/>
+          <p:cNvPicPr>
+            <a:picLocks noChangeAspect="1"/>
+          </p:cNvPicPr>
+          <p:nvPr/>
+        </p:nvPicPr>
+        <p:blipFill>
+          <a:blip r:embed="rId3"/>
+          <a:stretch>
+            <a:fillRect/>
+          </a:stretch>
+        </p:blipFill>
+        <p:spPr>
+          <a:xfrm>
+            <a:off x="822960" y="6126480"/>
+            <a:ext cx="342900" cy="457200"/>
+          </a:xfrm>
+          <a:prstGeom prst="rect">
+            <a:avLst/>
+          </a:prstGeom>
+        </p:spPr>
+      </p:pic>
+      <p:sp>
+        <p:nvSpPr>
+          <p:cNvPr id="9" name="TextBox 8"/>
           <p:cNvSpPr txBox="1"/>
           <p:nvPr/>
         </p:nvSpPr>
         <p:spPr>
           <a:xfrm>
-            <a:off x="822960" y="6309360"/>
+            <a:off x="1371600" y="6236208"/>
             <a:ext cx="3657600" cy="365760"/>
           </a:xfrm>
           <a:prstGeom prst="rect">
@@ -6066,13 +6300,13 @@
           <a:lstStyle/>
           <a:p>
             <a:r>
-              <a:rPr sz="1200" b="0">
-                <a:solidFill>
-                  <a:srgbClr val="B76E79"/>
-                </a:solidFill>
-                <a:latin typeface="Calibri"/>
+              <a:rPr sz="1000" b="1">
+                <a:solidFill>
+                  <a:srgbClr val="C8A04A"/>
+                </a:solidFill>
+                <a:latin typeface="Montserrat"/>
               </a:rPr>
-              <a:t>Lidia Nails</a:t>
+              <a:t>LIDIA · NAIL EXPERT</a:t>
             </a:r>
           </a:p>
         </p:txBody>
@@ -6110,7 +6344,7 @@
             <a:avLst/>
           </a:prstGeom>
           <a:solidFill>
-            <a:srgbClr val="FFFFFF"/>
+            <a:srgbClr val="FAF7F0"/>
           </a:solidFill>
           <a:ln>
             <a:noFill/>
@@ -6147,13 +6381,13 @@
         <p:spPr>
           <a:xfrm>
             <a:off x="0" y="0"/>
-            <a:ext cx="228600" cy="6858000"/>
+            <a:ext cx="201168" cy="6858000"/>
           </a:xfrm>
           <a:prstGeom prst="rect">
             <a:avLst/>
           </a:prstGeom>
           <a:solidFill>
-            <a:srgbClr val="B76E79"/>
+            <a:srgbClr val="C9D8C5"/>
           </a:solidFill>
           <a:ln>
             <a:noFill/>
@@ -6183,14 +6417,57 @@
       </p:sp>
       <p:sp>
         <p:nvSpPr>
-          <p:cNvPr id="4" name="TextBox 3"/>
+          <p:cNvPr id="4" name="Rectangle 3"/>
+          <p:cNvSpPr/>
+          <p:nvPr/>
+        </p:nvSpPr>
+        <p:spPr>
+          <a:xfrm>
+            <a:off x="201168" y="0"/>
+            <a:ext cx="36576" cy="6858000"/>
+          </a:xfrm>
+          <a:prstGeom prst="rect">
+            <a:avLst/>
+          </a:prstGeom>
+          <a:solidFill>
+            <a:srgbClr val="C8A04A"/>
+          </a:solidFill>
+          <a:ln>
+            <a:noFill/>
+          </a:ln>
+        </p:spPr>
+        <p:style>
+          <a:lnRef idx="1">
+            <a:schemeClr val="accent1"/>
+          </a:lnRef>
+          <a:fillRef idx="3">
+            <a:schemeClr val="accent1"/>
+          </a:fillRef>
+          <a:effectRef idx="2">
+            <a:schemeClr val="accent1"/>
+          </a:effectRef>
+          <a:fontRef idx="minor">
+            <a:schemeClr val="lt1"/>
+          </a:fontRef>
+        </p:style>
+        <p:txBody>
+          <a:bodyPr rtlCol="0" anchor="ctr"/>
+          <a:lstStyle/>
+          <a:p>
+            <a:pPr algn="ctr"/>
+          </a:p>
+        </p:txBody>
+      </p:sp>
+      <p:sp>
+        <p:nvSpPr>
+          <p:cNvPr id="5" name="TextBox 4"/>
           <p:cNvSpPr txBox="1"/>
           <p:nvPr/>
         </p:nvSpPr>
         <p:spPr>
           <a:xfrm>
-            <a:off x="822960" y="548640"/>
-            <a:ext cx="10515600" cy="914400"/>
+            <a:off x="822960" y="502920"/>
+            <a:ext cx="10789920" cy="914400"/>
           </a:xfrm>
           <a:prstGeom prst="rect">
             <a:avLst/>
@@ -6204,11 +6481,11 @@
           <a:lstStyle/>
           <a:p>
             <a:r>
-              <a:rPr sz="3600" b="1">
-                <a:solidFill>
-                  <a:srgbClr val="2B2B2B"/>
-                </a:solidFill>
-                <a:latin typeface="Calibri"/>
+              <a:rPr sz="3400" b="0">
+                <a:solidFill>
+                  <a:srgbClr val="34402F"/>
+                </a:solidFill>
+                <a:latin typeface="Playfair Display"/>
               </a:rPr>
               <a:t>12. Rifinitura e colore</a:t>
             </a:r>
@@ -6217,7 +6494,7 @@
       </p:sp>
       <p:sp>
         <p:nvSpPr>
-          <p:cNvPr id="5" name="TextBox 4"/>
+          <p:cNvPr id="6" name="TextBox 5"/>
           <p:cNvSpPr txBox="1"/>
           <p:nvPr/>
         </p:nvSpPr>
@@ -6239,24 +6516,24 @@
           <a:p>
             <a:pPr>
               <a:spcAft>
-                <a:spcPts val="1800"/>
+                <a:spcPts val="1600"/>
               </a:spcAft>
             </a:pPr>
             <a:r>
-              <a:rPr sz="2400" b="0">
-                <a:solidFill>
-                  <a:srgbClr val="2B2B2B"/>
-                </a:solidFill>
-                <a:latin typeface="Calibri"/>
+              <a:rPr sz="2200" b="0">
+                <a:solidFill>
+                  <a:srgbClr val="34402F"/>
+                </a:solidFill>
+                <a:latin typeface="Montserrat"/>
               </a:rPr>
               <a:t/>
             </a:r>
             <a:r>
-              <a:rPr sz="2800">
-                <a:solidFill>
-                  <a:srgbClr val="2B2B2B"/>
-                </a:solidFill>
-                <a:latin typeface="Calibri"/>
+              <a:rPr sz="2400">
+                <a:solidFill>
+                  <a:srgbClr val="34402F"/>
+                </a:solidFill>
+                <a:latin typeface="Montserrat"/>
               </a:rPr>
               <a:t>•  Scalino: punta dedicata 18.000 giri, mano leggera</a:t>
             </a:r>
@@ -6264,15 +6541,15 @@
           <a:p>
             <a:pPr>
               <a:spcAft>
-                <a:spcPts val="1800"/>
+                <a:spcPts val="1600"/>
               </a:spcAft>
             </a:pPr>
             <a:r>
-              <a:rPr sz="2800">
-                <a:solidFill>
-                  <a:srgbClr val="2B2B2B"/>
-                </a:solidFill>
-                <a:latin typeface="Calibri"/>
+              <a:rPr sz="2400">
+                <a:solidFill>
+                  <a:srgbClr val="34402F"/>
+                </a:solidFill>
+                <a:latin typeface="Montserrat"/>
               </a:rPr>
               <a:t>•  Lima fine solo nel giro cuticola</a:t>
             </a:r>
@@ -6280,15 +6557,15 @@
           <a:p>
             <a:pPr>
               <a:spcAft>
-                <a:spcPts val="1800"/>
+                <a:spcPts val="1600"/>
               </a:spcAft>
             </a:pPr>
             <a:r>
-              <a:rPr sz="2800">
-                <a:solidFill>
-                  <a:srgbClr val="2B2B2B"/>
-                </a:solidFill>
-                <a:latin typeface="Calibri"/>
+              <a:rPr sz="2400">
+                <a:solidFill>
+                  <a:srgbClr val="34402F"/>
+                </a:solidFill>
+                <a:latin typeface="Montserrat"/>
               </a:rPr>
               <a:t>•  Deidratante prima del colore</a:t>
             </a:r>
@@ -6296,30 +6573,54 @@
           <a:p>
             <a:pPr>
               <a:spcAft>
-                <a:spcPts val="1800"/>
+                <a:spcPts val="1600"/>
               </a:spcAft>
             </a:pPr>
             <a:r>
-              <a:rPr sz="2800">
-                <a:solidFill>
-                  <a:srgbClr val="2B2B2B"/>
-                </a:solidFill>
-                <a:latin typeface="Calibri"/>
+              <a:rPr sz="2400">
+                <a:solidFill>
+                  <a:srgbClr val="34402F"/>
+                </a:solidFill>
+                <a:latin typeface="Montserrat"/>
               </a:rPr>
               <a:t>•  Colore: mai partire dalla cuticola</a:t>
             </a:r>
           </a:p>
         </p:txBody>
       </p:sp>
-      <p:sp>
-        <p:nvSpPr>
-          <p:cNvPr id="6" name="TextBox 5"/>
+      <p:pic>
+        <p:nvPicPr>
+          <p:cNvPr id="7" name="Picture 6" descr="emblema-oliva.png"/>
+          <p:cNvPicPr>
+            <a:picLocks noChangeAspect="1"/>
+          </p:cNvPicPr>
+          <p:nvPr/>
+        </p:nvPicPr>
+        <p:blipFill>
+          <a:blip r:embed="rId2"/>
+          <a:stretch>
+            <a:fillRect/>
+          </a:stretch>
+        </p:blipFill>
+        <p:spPr>
+          <a:xfrm>
+            <a:off x="822960" y="6126480"/>
+            <a:ext cx="342900" cy="457200"/>
+          </a:xfrm>
+          <a:prstGeom prst="rect">
+            <a:avLst/>
+          </a:prstGeom>
+        </p:spPr>
+      </p:pic>
+      <p:sp>
+        <p:nvSpPr>
+          <p:cNvPr id="8" name="TextBox 7"/>
           <p:cNvSpPr txBox="1"/>
           <p:nvPr/>
         </p:nvSpPr>
         <p:spPr>
           <a:xfrm>
-            <a:off x="822960" y="6309360"/>
+            <a:off x="1371600" y="6236208"/>
             <a:ext cx="3657600" cy="365760"/>
           </a:xfrm>
           <a:prstGeom prst="rect">
@@ -6334,13 +6635,13 @@
           <a:lstStyle/>
           <a:p>
             <a:r>
-              <a:rPr sz="1200" b="0">
-                <a:solidFill>
-                  <a:srgbClr val="B76E79"/>
-                </a:solidFill>
-                <a:latin typeface="Calibri"/>
+              <a:rPr sz="1000" b="1">
+                <a:solidFill>
+                  <a:srgbClr val="C8A04A"/>
+                </a:solidFill>
+                <a:latin typeface="Montserrat"/>
               </a:rPr>
-              <a:t>Lidia Nails</a:t>
+              <a:t>LIDIA · NAIL EXPERT</a:t>
             </a:r>
           </a:p>
         </p:txBody>
@@ -6378,7 +6679,7 @@
             <a:avLst/>
           </a:prstGeom>
           <a:solidFill>
-            <a:srgbClr val="FFFFFF"/>
+            <a:srgbClr val="FAF7F0"/>
           </a:solidFill>
           <a:ln>
             <a:noFill/>
@@ -6415,13 +6716,13 @@
         <p:spPr>
           <a:xfrm>
             <a:off x="0" y="0"/>
-            <a:ext cx="228600" cy="6858000"/>
+            <a:ext cx="201168" cy="6858000"/>
           </a:xfrm>
           <a:prstGeom prst="rect">
             <a:avLst/>
           </a:prstGeom>
           <a:solidFill>
-            <a:srgbClr val="B76E79"/>
+            <a:srgbClr val="C9D8C5"/>
           </a:solidFill>
           <a:ln>
             <a:noFill/>
@@ -6451,14 +6752,57 @@
       </p:sp>
       <p:sp>
         <p:nvSpPr>
-          <p:cNvPr id="4" name="TextBox 3"/>
+          <p:cNvPr id="4" name="Rectangle 3"/>
+          <p:cNvSpPr/>
+          <p:nvPr/>
+        </p:nvSpPr>
+        <p:spPr>
+          <a:xfrm>
+            <a:off x="201168" y="0"/>
+            <a:ext cx="36576" cy="6858000"/>
+          </a:xfrm>
+          <a:prstGeom prst="rect">
+            <a:avLst/>
+          </a:prstGeom>
+          <a:solidFill>
+            <a:srgbClr val="C8A04A"/>
+          </a:solidFill>
+          <a:ln>
+            <a:noFill/>
+          </a:ln>
+        </p:spPr>
+        <p:style>
+          <a:lnRef idx="1">
+            <a:schemeClr val="accent1"/>
+          </a:lnRef>
+          <a:fillRef idx="3">
+            <a:schemeClr val="accent1"/>
+          </a:fillRef>
+          <a:effectRef idx="2">
+            <a:schemeClr val="accent1"/>
+          </a:effectRef>
+          <a:fontRef idx="minor">
+            <a:schemeClr val="lt1"/>
+          </a:fontRef>
+        </p:style>
+        <p:txBody>
+          <a:bodyPr rtlCol="0" anchor="ctr"/>
+          <a:lstStyle/>
+          <a:p>
+            <a:pPr algn="ctr"/>
+          </a:p>
+        </p:txBody>
+      </p:sp>
+      <p:sp>
+        <p:nvSpPr>
+          <p:cNvPr id="5" name="TextBox 4"/>
           <p:cNvSpPr txBox="1"/>
           <p:nvPr/>
         </p:nvSpPr>
         <p:spPr>
           <a:xfrm>
-            <a:off x="822960" y="548640"/>
-            <a:ext cx="10515600" cy="914400"/>
+            <a:off x="822960" y="502920"/>
+            <a:ext cx="10789920" cy="914400"/>
           </a:xfrm>
           <a:prstGeom prst="rect">
             <a:avLst/>
@@ -6472,11 +6816,11 @@
           <a:lstStyle/>
           <a:p>
             <a:r>
-              <a:rPr sz="3600" b="1">
-                <a:solidFill>
-                  <a:srgbClr val="2B2B2B"/>
-                </a:solidFill>
-                <a:latin typeface="Calibri"/>
+              <a:rPr sz="3400" b="0">
+                <a:solidFill>
+                  <a:srgbClr val="34402F"/>
+                </a:solidFill>
+                <a:latin typeface="Playfair Display"/>
               </a:rPr>
               <a:t>13. Rimozione e rifacimento</a:t>
             </a:r>
@@ -6485,7 +6829,7 @@
       </p:sp>
       <p:sp>
         <p:nvSpPr>
-          <p:cNvPr id="5" name="TextBox 4"/>
+          <p:cNvPr id="6" name="TextBox 5"/>
           <p:cNvSpPr txBox="1"/>
           <p:nvPr/>
         </p:nvSpPr>
@@ -6507,24 +6851,24 @@
           <a:p>
             <a:pPr>
               <a:spcAft>
-                <a:spcPts val="1800"/>
+                <a:spcPts val="1600"/>
               </a:spcAft>
             </a:pPr>
             <a:r>
-              <a:rPr sz="2400" b="0">
-                <a:solidFill>
-                  <a:srgbClr val="2B2B2B"/>
-                </a:solidFill>
-                <a:latin typeface="Calibri"/>
+              <a:rPr sz="2200" b="0">
+                <a:solidFill>
+                  <a:srgbClr val="34402F"/>
+                </a:solidFill>
+                <a:latin typeface="Montserrat"/>
               </a:rPr>
               <a:t/>
             </a:r>
             <a:r>
-              <a:rPr sz="2400">
-                <a:solidFill>
-                  <a:srgbClr val="2B2B2B"/>
-                </a:solidFill>
-                <a:latin typeface="Calibri"/>
+              <a:rPr sz="2000">
+                <a:solidFill>
+                  <a:srgbClr val="34402F"/>
+                </a:solidFill>
+                <a:latin typeface="Montserrat"/>
               </a:rPr>
               <a:t>•  Nessun refill: si rimuove e si rifà (3–6 settimane)</a:t>
             </a:r>
@@ -6532,15 +6876,15 @@
           <a:p>
             <a:pPr>
               <a:spcAft>
-                <a:spcPts val="1800"/>
+                <a:spcPts val="1600"/>
               </a:spcAft>
             </a:pPr>
             <a:r>
-              <a:rPr sz="2400">
-                <a:solidFill>
-                  <a:srgbClr val="2B2B2B"/>
-                </a:solidFill>
-                <a:latin typeface="Calibri"/>
+              <a:rPr sz="2000">
+                <a:solidFill>
+                  <a:srgbClr val="34402F"/>
+                </a:solidFill>
+                <a:latin typeface="Montserrat"/>
               </a:rPr>
               <a:t>•  Taglia, togli colore con la fresa, ammollo 5 min</a:t>
             </a:r>
@@ -6548,15 +6892,15 @@
           <a:p>
             <a:pPr>
               <a:spcAft>
-                <a:spcPts val="1800"/>
+                <a:spcPts val="1600"/>
               </a:spcAft>
             </a:pPr>
             <a:r>
-              <a:rPr sz="2400">
-                <a:solidFill>
-                  <a:srgbClr val="2B2B2B"/>
-                </a:solidFill>
-                <a:latin typeface="Calibri"/>
+              <a:rPr sz="2000">
+                <a:solidFill>
+                  <a:srgbClr val="34402F"/>
+                </a:solidFill>
+                <a:latin typeface="Montserrat"/>
               </a:rPr>
               <a:t>•  Pusher + passata di fresa, poi nuova tip</a:t>
             </a:r>
@@ -6564,15 +6908,15 @@
           <a:p>
             <a:pPr>
               <a:spcAft>
-                <a:spcPts val="1800"/>
+                <a:spcPts val="1600"/>
               </a:spcAft>
             </a:pPr>
             <a:r>
-              <a:rPr sz="2400">
-                <a:solidFill>
-                  <a:srgbClr val="2B2B2B"/>
-                </a:solidFill>
-                <a:latin typeface="Calibri"/>
+              <a:rPr sz="2000">
+                <a:solidFill>
+                  <a:srgbClr val="34402F"/>
+                </a:solidFill>
+                <a:latin typeface="Montserrat"/>
               </a:rPr>
               <a:t>•  Una mano in ammollo, lavori sull'altra</a:t>
             </a:r>
@@ -6581,7 +6925,7 @@
       </p:sp>
       <p:pic>
         <p:nvPicPr>
-          <p:cNvPr id="6" name="Picture 5" descr="rimozione.png"/>
+          <p:cNvPr id="7" name="Picture 6" descr="rimozione.png"/>
           <p:cNvPicPr>
             <a:picLocks noChangeAspect="1"/>
           </p:cNvPicPr>
@@ -6603,15 +6947,39 @@
           </a:prstGeom>
         </p:spPr>
       </p:pic>
-      <p:sp>
-        <p:nvSpPr>
-          <p:cNvPr id="7" name="TextBox 6"/>
+      <p:pic>
+        <p:nvPicPr>
+          <p:cNvPr id="8" name="Picture 7" descr="emblema-oliva.png"/>
+          <p:cNvPicPr>
+            <a:picLocks noChangeAspect="1"/>
+          </p:cNvPicPr>
+          <p:nvPr/>
+        </p:nvPicPr>
+        <p:blipFill>
+          <a:blip r:embed="rId3"/>
+          <a:stretch>
+            <a:fillRect/>
+          </a:stretch>
+        </p:blipFill>
+        <p:spPr>
+          <a:xfrm>
+            <a:off x="822960" y="6126480"/>
+            <a:ext cx="342900" cy="457200"/>
+          </a:xfrm>
+          <a:prstGeom prst="rect">
+            <a:avLst/>
+          </a:prstGeom>
+        </p:spPr>
+      </p:pic>
+      <p:sp>
+        <p:nvSpPr>
+          <p:cNvPr id="9" name="TextBox 8"/>
           <p:cNvSpPr txBox="1"/>
           <p:nvPr/>
         </p:nvSpPr>
         <p:spPr>
           <a:xfrm>
-            <a:off x="822960" y="6309360"/>
+            <a:off x="1371600" y="6236208"/>
             <a:ext cx="3657600" cy="365760"/>
           </a:xfrm>
           <a:prstGeom prst="rect">
@@ -6626,13 +6994,13 @@
           <a:lstStyle/>
           <a:p>
             <a:r>
-              <a:rPr sz="1200" b="0">
-                <a:solidFill>
-                  <a:srgbClr val="B76E79"/>
-                </a:solidFill>
-                <a:latin typeface="Calibri"/>
+              <a:rPr sz="1000" b="1">
+                <a:solidFill>
+                  <a:srgbClr val="C8A04A"/>
+                </a:solidFill>
+                <a:latin typeface="Montserrat"/>
               </a:rPr>
-              <a:t>Lidia Nails</a:t>
+              <a:t>LIDIA · NAIL EXPERT</a:t>
             </a:r>
           </a:p>
         </p:txBody>
@@ -6670,7 +7038,7 @@
             <a:avLst/>
           </a:prstGeom>
           <a:solidFill>
-            <a:srgbClr val="FFFFFF"/>
+            <a:srgbClr val="FAF7F0"/>
           </a:solidFill>
           <a:ln>
             <a:noFill/>
@@ -6707,13 +7075,13 @@
         <p:spPr>
           <a:xfrm>
             <a:off x="0" y="0"/>
-            <a:ext cx="228600" cy="6858000"/>
+            <a:ext cx="201168" cy="6858000"/>
           </a:xfrm>
           <a:prstGeom prst="rect">
             <a:avLst/>
           </a:prstGeom>
           <a:solidFill>
-            <a:srgbClr val="B76E79"/>
+            <a:srgbClr val="C9D8C5"/>
           </a:solidFill>
           <a:ln>
             <a:noFill/>
@@ -6743,14 +7111,57 @@
       </p:sp>
       <p:sp>
         <p:nvSpPr>
-          <p:cNvPr id="4" name="TextBox 3"/>
+          <p:cNvPr id="4" name="Rectangle 3"/>
+          <p:cNvSpPr/>
+          <p:nvPr/>
+        </p:nvSpPr>
+        <p:spPr>
+          <a:xfrm>
+            <a:off x="201168" y="0"/>
+            <a:ext cx="36576" cy="6858000"/>
+          </a:xfrm>
+          <a:prstGeom prst="rect">
+            <a:avLst/>
+          </a:prstGeom>
+          <a:solidFill>
+            <a:srgbClr val="C8A04A"/>
+          </a:solidFill>
+          <a:ln>
+            <a:noFill/>
+          </a:ln>
+        </p:spPr>
+        <p:style>
+          <a:lnRef idx="1">
+            <a:schemeClr val="accent1"/>
+          </a:lnRef>
+          <a:fillRef idx="3">
+            <a:schemeClr val="accent1"/>
+          </a:fillRef>
+          <a:effectRef idx="2">
+            <a:schemeClr val="accent1"/>
+          </a:effectRef>
+          <a:fontRef idx="minor">
+            <a:schemeClr val="lt1"/>
+          </a:fontRef>
+        </p:style>
+        <p:txBody>
+          <a:bodyPr rtlCol="0" anchor="ctr"/>
+          <a:lstStyle/>
+          <a:p>
+            <a:pPr algn="ctr"/>
+          </a:p>
+        </p:txBody>
+      </p:sp>
+      <p:sp>
+        <p:nvSpPr>
+          <p:cNvPr id="5" name="TextBox 4"/>
           <p:cNvSpPr txBox="1"/>
           <p:nvPr/>
         </p:nvSpPr>
         <p:spPr>
           <a:xfrm>
-            <a:off x="822960" y="548640"/>
-            <a:ext cx="10515600" cy="914400"/>
+            <a:off x="822960" y="502920"/>
+            <a:ext cx="10789920" cy="914400"/>
           </a:xfrm>
           <a:prstGeom prst="rect">
             <a:avLst/>
@@ -6764,11 +7175,11 @@
           <a:lstStyle/>
           <a:p>
             <a:r>
-              <a:rPr sz="3600" b="1">
-                <a:solidFill>
-                  <a:srgbClr val="2B2B2B"/>
-                </a:solidFill>
-                <a:latin typeface="Calibri"/>
+              <a:rPr sz="3400" b="0">
+                <a:solidFill>
+                  <a:srgbClr val="34402F"/>
+                </a:solidFill>
+                <a:latin typeface="Playfair Display"/>
               </a:rPr>
               <a:t>14. Messaggi chiave per la cliente</a:t>
             </a:r>
@@ -6777,7 +7188,7 @@
       </p:sp>
       <p:sp>
         <p:nvSpPr>
-          <p:cNvPr id="5" name="TextBox 4"/>
+          <p:cNvPr id="6" name="TextBox 5"/>
           <p:cNvSpPr txBox="1"/>
           <p:nvPr/>
         </p:nvSpPr>
@@ -6799,24 +7210,24 @@
           <a:p>
             <a:pPr>
               <a:spcAft>
-                <a:spcPts val="1800"/>
+                <a:spcPts val="1600"/>
               </a:spcAft>
             </a:pPr>
             <a:r>
-              <a:rPr sz="2400" b="0">
-                <a:solidFill>
-                  <a:srgbClr val="2B2B2B"/>
-                </a:solidFill>
-                <a:latin typeface="Calibri"/>
+              <a:rPr sz="2200" b="0">
+                <a:solidFill>
+                  <a:srgbClr val="34402F"/>
+                </a:solidFill>
+                <a:latin typeface="Montserrat"/>
               </a:rPr>
               <a:t/>
             </a:r>
             <a:r>
-              <a:rPr sz="2800">
-                <a:solidFill>
-                  <a:srgbClr val="2B2B2B"/>
-                </a:solidFill>
-                <a:latin typeface="Calibri"/>
+              <a:rPr sz="2400">
+                <a:solidFill>
+                  <a:srgbClr val="34402F"/>
+                </a:solidFill>
+                <a:latin typeface="Montserrat"/>
               </a:rPr>
               <a:t>•  Unghia naturale corta = protetta</a:t>
             </a:r>
@@ -6824,15 +7235,15 @@
           <a:p>
             <a:pPr>
               <a:spcAft>
-                <a:spcPts val="1800"/>
+                <a:spcPts val="1600"/>
               </a:spcAft>
             </a:pPr>
             <a:r>
-              <a:rPr sz="2800">
-                <a:solidFill>
-                  <a:srgbClr val="2B2B2B"/>
-                </a:solidFill>
-                <a:latin typeface="Calibri"/>
+              <a:rPr sz="2400">
+                <a:solidFill>
+                  <a:srgbClr val="34402F"/>
+                </a:solidFill>
+                <a:latin typeface="Montserrat"/>
               </a:rPr>
               <a:t>•  Se prendi un colpo si rompe solo la tip</a:t>
             </a:r>
@@ -6840,15 +7251,15 @@
           <a:p>
             <a:pPr>
               <a:spcAft>
-                <a:spcPts val="1800"/>
+                <a:spcPts val="1600"/>
               </a:spcAft>
             </a:pPr>
             <a:r>
-              <a:rPr sz="2800">
-                <a:solidFill>
-                  <a:srgbClr val="2B2B2B"/>
-                </a:solidFill>
-                <a:latin typeface="Calibri"/>
+              <a:rPr sz="2400">
+                <a:solidFill>
+                  <a:srgbClr val="34402F"/>
+                </a:solidFill>
+                <a:latin typeface="Montserrat"/>
               </a:rPr>
               <a:t>•  Risultato sottile e naturale</a:t>
             </a:r>
@@ -6856,30 +7267,54 @@
           <a:p>
             <a:pPr>
               <a:spcAft>
-                <a:spcPts val="1800"/>
+                <a:spcPts val="1600"/>
               </a:spcAft>
             </a:pPr>
             <a:r>
-              <a:rPr sz="2800">
-                <a:solidFill>
-                  <a:srgbClr val="2B2B2B"/>
-                </a:solidFill>
-                <a:latin typeface="Calibri"/>
+              <a:rPr sz="2400">
+                <a:solidFill>
+                  <a:srgbClr val="34402F"/>
+                </a:solidFill>
+                <a:latin typeface="Montserrat"/>
               </a:rPr>
               <a:t>•  Mai staccarla da sola</a:t>
             </a:r>
           </a:p>
         </p:txBody>
       </p:sp>
-      <p:sp>
-        <p:nvSpPr>
-          <p:cNvPr id="6" name="TextBox 5"/>
+      <p:pic>
+        <p:nvPicPr>
+          <p:cNvPr id="7" name="Picture 6" descr="emblema-oliva.png"/>
+          <p:cNvPicPr>
+            <a:picLocks noChangeAspect="1"/>
+          </p:cNvPicPr>
+          <p:nvPr/>
+        </p:nvPicPr>
+        <p:blipFill>
+          <a:blip r:embed="rId2"/>
+          <a:stretch>
+            <a:fillRect/>
+          </a:stretch>
+        </p:blipFill>
+        <p:spPr>
+          <a:xfrm>
+            <a:off x="822960" y="6126480"/>
+            <a:ext cx="342900" cy="457200"/>
+          </a:xfrm>
+          <a:prstGeom prst="rect">
+            <a:avLst/>
+          </a:prstGeom>
+        </p:spPr>
+      </p:pic>
+      <p:sp>
+        <p:nvSpPr>
+          <p:cNvPr id="8" name="TextBox 7"/>
           <p:cNvSpPr txBox="1"/>
           <p:nvPr/>
         </p:nvSpPr>
         <p:spPr>
           <a:xfrm>
-            <a:off x="822960" y="6309360"/>
+            <a:off x="1371600" y="6236208"/>
             <a:ext cx="3657600" cy="365760"/>
           </a:xfrm>
           <a:prstGeom prst="rect">
@@ -6894,13 +7329,13 @@
           <a:lstStyle/>
           <a:p>
             <a:r>
-              <a:rPr sz="1200" b="0">
-                <a:solidFill>
-                  <a:srgbClr val="B76E79"/>
-                </a:solidFill>
-                <a:latin typeface="Calibri"/>
+              <a:rPr sz="1000" b="1">
+                <a:solidFill>
+                  <a:srgbClr val="C8A04A"/>
+                </a:solidFill>
+                <a:latin typeface="Montserrat"/>
               </a:rPr>
-              <a:t>Lidia Nails</a:t>
+              <a:t>LIDIA · NAIL EXPERT</a:t>
             </a:r>
           </a:p>
         </p:txBody>
@@ -6938,7 +7373,7 @@
             <a:avLst/>
           </a:prstGeom>
           <a:solidFill>
-            <a:srgbClr val="FFFFFF"/>
+            <a:srgbClr val="FAF7F0"/>
           </a:solidFill>
           <a:ln>
             <a:noFill/>
@@ -6975,13 +7410,13 @@
         <p:spPr>
           <a:xfrm>
             <a:off x="0" y="0"/>
-            <a:ext cx="228600" cy="6858000"/>
+            <a:ext cx="201168" cy="6858000"/>
           </a:xfrm>
           <a:prstGeom prst="rect">
             <a:avLst/>
           </a:prstGeom>
           <a:solidFill>
-            <a:srgbClr val="B76E79"/>
+            <a:srgbClr val="C9D8C5"/>
           </a:solidFill>
           <a:ln>
             <a:noFill/>
@@ -7011,14 +7446,57 @@
       </p:sp>
       <p:sp>
         <p:nvSpPr>
-          <p:cNvPr id="4" name="TextBox 3"/>
+          <p:cNvPr id="4" name="Rectangle 3"/>
+          <p:cNvSpPr/>
+          <p:nvPr/>
+        </p:nvSpPr>
+        <p:spPr>
+          <a:xfrm>
+            <a:off x="201168" y="0"/>
+            <a:ext cx="36576" cy="6858000"/>
+          </a:xfrm>
+          <a:prstGeom prst="rect">
+            <a:avLst/>
+          </a:prstGeom>
+          <a:solidFill>
+            <a:srgbClr val="C8A04A"/>
+          </a:solidFill>
+          <a:ln>
+            <a:noFill/>
+          </a:ln>
+        </p:spPr>
+        <p:style>
+          <a:lnRef idx="1">
+            <a:schemeClr val="accent1"/>
+          </a:lnRef>
+          <a:fillRef idx="3">
+            <a:schemeClr val="accent1"/>
+          </a:fillRef>
+          <a:effectRef idx="2">
+            <a:schemeClr val="accent1"/>
+          </a:effectRef>
+          <a:fontRef idx="minor">
+            <a:schemeClr val="lt1"/>
+          </a:fontRef>
+        </p:style>
+        <p:txBody>
+          <a:bodyPr rtlCol="0" anchor="ctr"/>
+          <a:lstStyle/>
+          <a:p>
+            <a:pPr algn="ctr"/>
+          </a:p>
+        </p:txBody>
+      </p:sp>
+      <p:sp>
+        <p:nvSpPr>
+          <p:cNvPr id="5" name="TextBox 4"/>
           <p:cNvSpPr txBox="1"/>
           <p:nvPr/>
         </p:nvSpPr>
         <p:spPr>
           <a:xfrm>
-            <a:off x="822960" y="548640"/>
-            <a:ext cx="10515600" cy="914400"/>
+            <a:off x="822960" y="502920"/>
+            <a:ext cx="10789920" cy="914400"/>
           </a:xfrm>
           <a:prstGeom prst="rect">
             <a:avLst/>
@@ -7032,11 +7510,11 @@
           <a:lstStyle/>
           <a:p>
             <a:r>
-              <a:rPr sz="3600" b="1">
-                <a:solidFill>
-                  <a:srgbClr val="2B2B2B"/>
-                </a:solidFill>
-                <a:latin typeface="Calibri"/>
+              <a:rPr sz="3400" b="0">
+                <a:solidFill>
+                  <a:srgbClr val="34402F"/>
+                </a:solidFill>
+                <a:latin typeface="Playfair Display"/>
               </a:rPr>
               <a:t>15. Anomalie: quando fermarsi</a:t>
             </a:r>
@@ -7045,7 +7523,7 @@
       </p:sp>
       <p:sp>
         <p:nvSpPr>
-          <p:cNvPr id="5" name="TextBox 4"/>
+          <p:cNvPr id="6" name="TextBox 5"/>
           <p:cNvSpPr txBox="1"/>
           <p:nvPr/>
         </p:nvSpPr>
@@ -7067,24 +7545,24 @@
           <a:p>
             <a:pPr>
               <a:spcAft>
-                <a:spcPts val="1800"/>
+                <a:spcPts val="1600"/>
               </a:spcAft>
             </a:pPr>
             <a:r>
-              <a:rPr sz="2400" b="0">
-                <a:solidFill>
-                  <a:srgbClr val="2B2B2B"/>
-                </a:solidFill>
-                <a:latin typeface="Calibri"/>
+              <a:rPr sz="2200" b="0">
+                <a:solidFill>
+                  <a:srgbClr val="34402F"/>
+                </a:solidFill>
+                <a:latin typeface="Montserrat"/>
               </a:rPr>
               <a:t/>
             </a:r>
             <a:r>
-              <a:rPr sz="2400">
-                <a:solidFill>
-                  <a:srgbClr val="2B2B2B"/>
-                </a:solidFill>
-                <a:latin typeface="Calibri"/>
+              <a:rPr sz="2000">
+                <a:solidFill>
+                  <a:srgbClr val="34402F"/>
+                </a:solidFill>
+                <a:latin typeface="Montserrat"/>
               </a:rPr>
               <a:t>•  Noi curiamo l'estetica, non la salute</a:t>
             </a:r>
@@ -7092,15 +7570,15 @@
           <a:p>
             <a:pPr>
               <a:spcAft>
-                <a:spcPts val="1800"/>
+                <a:spcPts val="1600"/>
               </a:spcAft>
             </a:pPr>
             <a:r>
-              <a:rPr sz="2400">
-                <a:solidFill>
-                  <a:srgbClr val="2B2B2B"/>
-                </a:solidFill>
-                <a:latin typeface="Calibri"/>
+              <a:rPr sz="2000">
+                <a:solidFill>
+                  <a:srgbClr val="34402F"/>
+                </a:solidFill>
+                <a:latin typeface="Montserrat"/>
               </a:rPr>
               <a:t>•  Anomalia su molte dita → medico</a:t>
             </a:r>
@@ -7108,15 +7586,15 @@
           <a:p>
             <a:pPr>
               <a:spcAft>
-                <a:spcPts val="1800"/>
+                <a:spcPts val="1600"/>
               </a:spcAft>
             </a:pPr>
             <a:r>
-              <a:rPr sz="2400">
-                <a:solidFill>
-                  <a:srgbClr val="2B2B2B"/>
-                </a:solidFill>
-                <a:latin typeface="Calibri"/>
+              <a:rPr sz="2000">
+                <a:solidFill>
+                  <a:srgbClr val="34402F"/>
+                </a:solidFill>
+                <a:latin typeface="Montserrat"/>
               </a:rPr>
               <a:t>•  Fungo, pseudomonas grave, paronichia, allergia → si ferma</a:t>
             </a:r>
@@ -7124,15 +7602,15 @@
           <a:p>
             <a:pPr>
               <a:spcAft>
-                <a:spcPts val="1800"/>
+                <a:spcPts val="1600"/>
               </a:spcAft>
             </a:pPr>
             <a:r>
-              <a:rPr sz="2400">
-                <a:solidFill>
-                  <a:srgbClr val="2B2B2B"/>
-                </a:solidFill>
-                <a:latin typeface="Calibri"/>
+              <a:rPr sz="2000">
+                <a:solidFill>
+                  <a:srgbClr val="34402F"/>
+                </a:solidFill>
+                <a:latin typeface="Montserrat"/>
               </a:rPr>
               <a:t>•  Prodotto mai sulla pelle</a:t>
             </a:r>
@@ -7141,7 +7619,7 @@
       </p:sp>
       <p:pic>
         <p:nvPicPr>
-          <p:cNvPr id="6" name="Picture 5" descr="semaforo.png"/>
+          <p:cNvPr id="7" name="Picture 6" descr="semaforo.png"/>
           <p:cNvPicPr>
             <a:picLocks noChangeAspect="1"/>
           </p:cNvPicPr>
@@ -7163,15 +7641,39 @@
           </a:prstGeom>
         </p:spPr>
       </p:pic>
-      <p:sp>
-        <p:nvSpPr>
-          <p:cNvPr id="7" name="TextBox 6"/>
+      <p:pic>
+        <p:nvPicPr>
+          <p:cNvPr id="8" name="Picture 7" descr="emblema-oliva.png"/>
+          <p:cNvPicPr>
+            <a:picLocks noChangeAspect="1"/>
+          </p:cNvPicPr>
+          <p:nvPr/>
+        </p:nvPicPr>
+        <p:blipFill>
+          <a:blip r:embed="rId3"/>
+          <a:stretch>
+            <a:fillRect/>
+          </a:stretch>
+        </p:blipFill>
+        <p:spPr>
+          <a:xfrm>
+            <a:off x="822960" y="6126480"/>
+            <a:ext cx="342900" cy="457200"/>
+          </a:xfrm>
+          <a:prstGeom prst="rect">
+            <a:avLst/>
+          </a:prstGeom>
+        </p:spPr>
+      </p:pic>
+      <p:sp>
+        <p:nvSpPr>
+          <p:cNvPr id="9" name="TextBox 8"/>
           <p:cNvSpPr txBox="1"/>
           <p:nvPr/>
         </p:nvSpPr>
         <p:spPr>
           <a:xfrm>
-            <a:off x="822960" y="6309360"/>
+            <a:off x="1371600" y="6236208"/>
             <a:ext cx="3657600" cy="365760"/>
           </a:xfrm>
           <a:prstGeom prst="rect">
@@ -7186,13 +7688,13 @@
           <a:lstStyle/>
           <a:p>
             <a:r>
-              <a:rPr sz="1200" b="0">
-                <a:solidFill>
-                  <a:srgbClr val="B76E79"/>
-                </a:solidFill>
-                <a:latin typeface="Calibri"/>
+              <a:rPr sz="1000" b="1">
+                <a:solidFill>
+                  <a:srgbClr val="C8A04A"/>
+                </a:solidFill>
+                <a:latin typeface="Montserrat"/>
               </a:rPr>
-              <a:t>Lidia Nails</a:t>
+              <a:t>LIDIA · NAIL EXPERT</a:t>
             </a:r>
           </a:p>
         </p:txBody>
@@ -7230,7 +7732,7 @@
             <a:avLst/>
           </a:prstGeom>
           <a:solidFill>
-            <a:srgbClr val="FFFFFF"/>
+            <a:srgbClr val="FAF7F0"/>
           </a:solidFill>
           <a:ln>
             <a:noFill/>
@@ -7267,13 +7769,13 @@
         <p:spPr>
           <a:xfrm>
             <a:off x="0" y="0"/>
-            <a:ext cx="228600" cy="6858000"/>
+            <a:ext cx="201168" cy="6858000"/>
           </a:xfrm>
           <a:prstGeom prst="rect">
             <a:avLst/>
           </a:prstGeom>
           <a:solidFill>
-            <a:srgbClr val="B76E79"/>
+            <a:srgbClr val="C9D8C5"/>
           </a:solidFill>
           <a:ln>
             <a:noFill/>
@@ -7303,14 +7805,57 @@
       </p:sp>
       <p:sp>
         <p:nvSpPr>
-          <p:cNvPr id="4" name="TextBox 3"/>
+          <p:cNvPr id="4" name="Rectangle 3"/>
+          <p:cNvSpPr/>
+          <p:nvPr/>
+        </p:nvSpPr>
+        <p:spPr>
+          <a:xfrm>
+            <a:off x="201168" y="0"/>
+            <a:ext cx="36576" cy="6858000"/>
+          </a:xfrm>
+          <a:prstGeom prst="rect">
+            <a:avLst/>
+          </a:prstGeom>
+          <a:solidFill>
+            <a:srgbClr val="C8A04A"/>
+          </a:solidFill>
+          <a:ln>
+            <a:noFill/>
+          </a:ln>
+        </p:spPr>
+        <p:style>
+          <a:lnRef idx="1">
+            <a:schemeClr val="accent1"/>
+          </a:lnRef>
+          <a:fillRef idx="3">
+            <a:schemeClr val="accent1"/>
+          </a:fillRef>
+          <a:effectRef idx="2">
+            <a:schemeClr val="accent1"/>
+          </a:effectRef>
+          <a:fontRef idx="minor">
+            <a:schemeClr val="lt1"/>
+          </a:fontRef>
+        </p:style>
+        <p:txBody>
+          <a:bodyPr rtlCol="0" anchor="ctr"/>
+          <a:lstStyle/>
+          <a:p>
+            <a:pPr algn="ctr"/>
+          </a:p>
+        </p:txBody>
+      </p:sp>
+      <p:sp>
+        <p:nvSpPr>
+          <p:cNvPr id="5" name="TextBox 4"/>
           <p:cNvSpPr txBox="1"/>
           <p:nvPr/>
         </p:nvSpPr>
         <p:spPr>
           <a:xfrm>
-            <a:off x="822960" y="548640"/>
-            <a:ext cx="10515600" cy="914400"/>
+            <a:off x="822960" y="502920"/>
+            <a:ext cx="10789920" cy="914400"/>
           </a:xfrm>
           <a:prstGeom prst="rect">
             <a:avLst/>
@@ -7324,11 +7869,11 @@
           <a:lstStyle/>
           <a:p>
             <a:r>
-              <a:rPr sz="3600" b="1">
-                <a:solidFill>
-                  <a:srgbClr val="2B2B2B"/>
-                </a:solidFill>
-                <a:latin typeface="Calibri"/>
+              <a:rPr sz="3400" b="0">
+                <a:solidFill>
+                  <a:srgbClr val="34402F"/>
+                </a:solidFill>
+                <a:latin typeface="Playfair Display"/>
               </a:rPr>
               <a:t>16. Materiali da avere</a:t>
             </a:r>
@@ -7337,7 +7882,7 @@
       </p:sp>
       <p:sp>
         <p:nvSpPr>
-          <p:cNvPr id="5" name="TextBox 4"/>
+          <p:cNvPr id="6" name="TextBox 5"/>
           <p:cNvSpPr txBox="1"/>
           <p:nvPr/>
         </p:nvSpPr>
@@ -7359,24 +7904,24 @@
           <a:p>
             <a:pPr>
               <a:spcAft>
-                <a:spcPts val="1800"/>
+                <a:spcPts val="1600"/>
               </a:spcAft>
             </a:pPr>
             <a:r>
-              <a:rPr sz="2400" b="0">
-                <a:solidFill>
-                  <a:srgbClr val="2B2B2B"/>
-                </a:solidFill>
-                <a:latin typeface="Calibri"/>
+              <a:rPr sz="2200" b="0">
+                <a:solidFill>
+                  <a:srgbClr val="34402F"/>
+                </a:solidFill>
+                <a:latin typeface="Montserrat"/>
               </a:rPr>
               <a:t/>
             </a:r>
             <a:r>
-              <a:rPr sz="2800">
-                <a:solidFill>
-                  <a:srgbClr val="2B2B2B"/>
-                </a:solidFill>
-                <a:latin typeface="Calibri"/>
+              <a:rPr sz="2400">
+                <a:solidFill>
+                  <a:srgbClr val="34402F"/>
+                </a:solidFill>
+                <a:latin typeface="Montserrat"/>
               </a:rPr>
               <a:t>•  Gel tip trasparenti, tutte le misure</a:t>
             </a:r>
@@ -7384,15 +7929,15 @@
           <a:p>
             <a:pPr>
               <a:spcAft>
-                <a:spcPts val="1800"/>
+                <a:spcPts val="1600"/>
               </a:spcAft>
             </a:pPr>
             <a:r>
-              <a:rPr sz="2800">
-                <a:solidFill>
-                  <a:srgbClr val="2B2B2B"/>
-                </a:solidFill>
-                <a:latin typeface="Calibri"/>
+              <a:rPr sz="2400">
+                <a:solidFill>
+                  <a:srgbClr val="34402F"/>
+                </a:solidFill>
+                <a:latin typeface="Montserrat"/>
               </a:rPr>
               <a:t>•  Base/extension gel, deidratante, primer acid-free</a:t>
             </a:r>
@@ -7400,15 +7945,15 @@
           <a:p>
             <a:pPr>
               <a:spcAft>
-                <a:spcPts val="1800"/>
+                <a:spcPts val="1600"/>
               </a:spcAft>
             </a:pPr>
             <a:r>
-              <a:rPr sz="2800">
-                <a:solidFill>
-                  <a:srgbClr val="2B2B2B"/>
-                </a:solidFill>
-                <a:latin typeface="Calibri"/>
+              <a:rPr sz="2400">
+                <a:solidFill>
+                  <a:srgbClr val="34402F"/>
+                </a:solidFill>
+                <a:latin typeface="Montserrat"/>
               </a:rPr>
               <a:t>•  Mandrino, punta ceramica, punta scalino, buffer</a:t>
             </a:r>
@@ -7416,15 +7961,15 @@
           <a:p>
             <a:pPr>
               <a:spcAft>
-                <a:spcPts val="1800"/>
+                <a:spcPts val="1600"/>
               </a:spcAft>
             </a:pPr>
             <a:r>
-              <a:rPr sz="2800">
-                <a:solidFill>
-                  <a:srgbClr val="2B2B2B"/>
-                </a:solidFill>
-                <a:latin typeface="Calibri"/>
+              <a:rPr sz="2400">
+                <a:solidFill>
+                  <a:srgbClr val="34402F"/>
+                </a:solidFill>
+                <a:latin typeface="Montserrat"/>
               </a:rPr>
               <a:t>•  Torcia + lampada</a:t>
             </a:r>
@@ -7432,30 +7977,54 @@
           <a:p>
             <a:pPr>
               <a:spcAft>
-                <a:spcPts val="1800"/>
+                <a:spcPts val="1600"/>
               </a:spcAft>
             </a:pPr>
             <a:r>
-              <a:rPr sz="2800">
-                <a:solidFill>
-                  <a:srgbClr val="2B2B2B"/>
-                </a:solidFill>
-                <a:latin typeface="Calibri"/>
+              <a:rPr sz="2400">
+                <a:solidFill>
+                  <a:srgbClr val="34402F"/>
+                </a:solidFill>
+                <a:latin typeface="Montserrat"/>
               </a:rPr>
               <a:t>•  Remover, vaschetta, pusher</a:t>
             </a:r>
           </a:p>
         </p:txBody>
       </p:sp>
-      <p:sp>
-        <p:nvSpPr>
-          <p:cNvPr id="6" name="TextBox 5"/>
+      <p:pic>
+        <p:nvPicPr>
+          <p:cNvPr id="7" name="Picture 6" descr="emblema-oliva.png"/>
+          <p:cNvPicPr>
+            <a:picLocks noChangeAspect="1"/>
+          </p:cNvPicPr>
+          <p:nvPr/>
+        </p:nvPicPr>
+        <p:blipFill>
+          <a:blip r:embed="rId2"/>
+          <a:stretch>
+            <a:fillRect/>
+          </a:stretch>
+        </p:blipFill>
+        <p:spPr>
+          <a:xfrm>
+            <a:off x="822960" y="6126480"/>
+            <a:ext cx="342900" cy="457200"/>
+          </a:xfrm>
+          <a:prstGeom prst="rect">
+            <a:avLst/>
+          </a:prstGeom>
+        </p:spPr>
+      </p:pic>
+      <p:sp>
+        <p:nvSpPr>
+          <p:cNvPr id="8" name="TextBox 7"/>
           <p:cNvSpPr txBox="1"/>
           <p:nvPr/>
         </p:nvSpPr>
         <p:spPr>
           <a:xfrm>
-            <a:off x="822960" y="6309360"/>
+            <a:off x="1371600" y="6236208"/>
             <a:ext cx="3657600" cy="365760"/>
           </a:xfrm>
           <a:prstGeom prst="rect">
@@ -7470,13 +8039,13 @@
           <a:lstStyle/>
           <a:p>
             <a:r>
-              <a:rPr sz="1200" b="0">
-                <a:solidFill>
-                  <a:srgbClr val="B76E79"/>
-                </a:solidFill>
-                <a:latin typeface="Calibri"/>
+              <a:rPr sz="1000" b="1">
+                <a:solidFill>
+                  <a:srgbClr val="C8A04A"/>
+                </a:solidFill>
+                <a:latin typeface="Montserrat"/>
               </a:rPr>
-              <a:t>Lidia Nails</a:t>
+              <a:t>LIDIA · NAIL EXPERT</a:t>
             </a:r>
           </a:p>
         </p:txBody>
@@ -7514,7 +8083,7 @@
             <a:avLst/>
           </a:prstGeom>
           <a:solidFill>
-            <a:srgbClr val="FFFFFF"/>
+            <a:srgbClr val="FAF7F0"/>
           </a:solidFill>
           <a:ln>
             <a:noFill/>
@@ -7551,13 +8120,13 @@
         <p:spPr>
           <a:xfrm>
             <a:off x="0" y="0"/>
-            <a:ext cx="228600" cy="6858000"/>
+            <a:ext cx="201168" cy="6858000"/>
           </a:xfrm>
           <a:prstGeom prst="rect">
             <a:avLst/>
           </a:prstGeom>
           <a:solidFill>
-            <a:srgbClr val="B76E79"/>
+            <a:srgbClr val="C9D8C5"/>
           </a:solidFill>
           <a:ln>
             <a:noFill/>
@@ -7587,14 +8156,57 @@
       </p:sp>
       <p:sp>
         <p:nvSpPr>
-          <p:cNvPr id="4" name="TextBox 3"/>
+          <p:cNvPr id="4" name="Rectangle 3"/>
+          <p:cNvSpPr/>
+          <p:nvPr/>
+        </p:nvSpPr>
+        <p:spPr>
+          <a:xfrm>
+            <a:off x="201168" y="0"/>
+            <a:ext cx="36576" cy="6858000"/>
+          </a:xfrm>
+          <a:prstGeom prst="rect">
+            <a:avLst/>
+          </a:prstGeom>
+          <a:solidFill>
+            <a:srgbClr val="C8A04A"/>
+          </a:solidFill>
+          <a:ln>
+            <a:noFill/>
+          </a:ln>
+        </p:spPr>
+        <p:style>
+          <a:lnRef idx="1">
+            <a:schemeClr val="accent1"/>
+          </a:lnRef>
+          <a:fillRef idx="3">
+            <a:schemeClr val="accent1"/>
+          </a:fillRef>
+          <a:effectRef idx="2">
+            <a:schemeClr val="accent1"/>
+          </a:effectRef>
+          <a:fontRef idx="minor">
+            <a:schemeClr val="lt1"/>
+          </a:fontRef>
+        </p:style>
+        <p:txBody>
+          <a:bodyPr rtlCol="0" anchor="ctr"/>
+          <a:lstStyle/>
+          <a:p>
+            <a:pPr algn="ctr"/>
+          </a:p>
+        </p:txBody>
+      </p:sp>
+      <p:sp>
+        <p:nvSpPr>
+          <p:cNvPr id="5" name="TextBox 4"/>
           <p:cNvSpPr txBox="1"/>
           <p:nvPr/>
         </p:nvSpPr>
         <p:spPr>
           <a:xfrm>
-            <a:off x="822960" y="548640"/>
-            <a:ext cx="10515600" cy="914400"/>
+            <a:off x="822960" y="502920"/>
+            <a:ext cx="10789920" cy="914400"/>
           </a:xfrm>
           <a:prstGeom prst="rect">
             <a:avLst/>
@@ -7608,11 +8220,11 @@
           <a:lstStyle/>
           <a:p>
             <a:r>
-              <a:rPr sz="3600" b="1">
-                <a:solidFill>
-                  <a:srgbClr val="2B2B2B"/>
-                </a:solidFill>
-                <a:latin typeface="Calibri"/>
+              <a:rPr sz="3400" b="0">
+                <a:solidFill>
+                  <a:srgbClr val="34402F"/>
+                </a:solidFill>
+                <a:latin typeface="Playfair Display"/>
               </a:rPr>
               <a:t>1. Cosa sono le Gel Tip</a:t>
             </a:r>
@@ -7621,7 +8233,7 @@
       </p:sp>
       <p:sp>
         <p:nvSpPr>
-          <p:cNvPr id="5" name="TextBox 4"/>
+          <p:cNvPr id="6" name="TextBox 5"/>
           <p:cNvSpPr txBox="1"/>
           <p:nvPr/>
         </p:nvSpPr>
@@ -7643,24 +8255,24 @@
           <a:p>
             <a:pPr>
               <a:spcAft>
-                <a:spcPts val="1800"/>
+                <a:spcPts val="1600"/>
               </a:spcAft>
             </a:pPr>
             <a:r>
-              <a:rPr sz="2400" b="0">
-                <a:solidFill>
-                  <a:srgbClr val="2B2B2B"/>
-                </a:solidFill>
-                <a:latin typeface="Calibri"/>
+              <a:rPr sz="2200" b="0">
+                <a:solidFill>
+                  <a:srgbClr val="34402F"/>
+                </a:solidFill>
+                <a:latin typeface="Montserrat"/>
               </a:rPr>
               <a:t/>
             </a:r>
             <a:r>
-              <a:rPr sz="2800">
-                <a:solidFill>
-                  <a:srgbClr val="2B2B2B"/>
-                </a:solidFill>
-                <a:latin typeface="Calibri"/>
+              <a:rPr sz="2400">
+                <a:solidFill>
+                  <a:srgbClr val="34402F"/>
+                </a:solidFill>
+                <a:latin typeface="Montserrat"/>
               </a:rPr>
               <a:t>•  Estensioni preformate in soft gel</a:t>
             </a:r>
@@ -7668,15 +8280,15 @@
           <a:p>
             <a:pPr>
               <a:spcAft>
-                <a:spcPts val="1800"/>
+                <a:spcPts val="1600"/>
               </a:spcAft>
             </a:pPr>
             <a:r>
-              <a:rPr sz="2800">
-                <a:solidFill>
-                  <a:srgbClr val="2B2B2B"/>
-                </a:solidFill>
-                <a:latin typeface="Calibri"/>
+              <a:rPr sz="2400">
+                <a:solidFill>
+                  <a:srgbClr val="34402F"/>
+                </a:solidFill>
+                <a:latin typeface="Montserrat"/>
               </a:rPr>
               <a:t>•  Coprono tutta l'unghia: cuticola → bordo libero + laterali</a:t>
             </a:r>
@@ -7684,15 +8296,15 @@
           <a:p>
             <a:pPr>
               <a:spcAft>
-                <a:spcPts val="1800"/>
+                <a:spcPts val="1600"/>
               </a:spcAft>
             </a:pPr>
             <a:r>
-              <a:rPr sz="2800">
-                <a:solidFill>
-                  <a:srgbClr val="2B2B2B"/>
-                </a:solidFill>
-                <a:latin typeface="Calibri"/>
+              <a:rPr sz="2400">
+                <a:solidFill>
+                  <a:srgbClr val="34402F"/>
+                </a:solidFill>
+                <a:latin typeface="Montserrat"/>
               </a:rPr>
               <a:t>•  Si applicano con il gel, non con la colla</a:t>
             </a:r>
@@ -7700,30 +8312,54 @@
           <a:p>
             <a:pPr>
               <a:spcAft>
-                <a:spcPts val="1800"/>
+                <a:spcPts val="1600"/>
               </a:spcAft>
             </a:pPr>
             <a:r>
-              <a:rPr sz="2800">
-                <a:solidFill>
-                  <a:srgbClr val="2B2B2B"/>
-                </a:solidFill>
-                <a:latin typeface="Calibri"/>
+              <a:rPr sz="2400">
+                <a:solidFill>
+                  <a:srgbClr val="34402F"/>
+                </a:solidFill>
+                <a:latin typeface="Montserrat"/>
               </a:rPr>
               <a:t>•  Metà del tempo, forme identiche su ogni dito</a:t>
             </a:r>
           </a:p>
         </p:txBody>
       </p:sp>
-      <p:sp>
-        <p:nvSpPr>
-          <p:cNvPr id="6" name="TextBox 5"/>
+      <p:pic>
+        <p:nvPicPr>
+          <p:cNvPr id="7" name="Picture 6" descr="emblema-oliva.png"/>
+          <p:cNvPicPr>
+            <a:picLocks noChangeAspect="1"/>
+          </p:cNvPicPr>
+          <p:nvPr/>
+        </p:nvPicPr>
+        <p:blipFill>
+          <a:blip r:embed="rId2"/>
+          <a:stretch>
+            <a:fillRect/>
+          </a:stretch>
+        </p:blipFill>
+        <p:spPr>
+          <a:xfrm>
+            <a:off x="822960" y="6126480"/>
+            <a:ext cx="342900" cy="457200"/>
+          </a:xfrm>
+          <a:prstGeom prst="rect">
+            <a:avLst/>
+          </a:prstGeom>
+        </p:spPr>
+      </p:pic>
+      <p:sp>
+        <p:nvSpPr>
+          <p:cNvPr id="8" name="TextBox 7"/>
           <p:cNvSpPr txBox="1"/>
           <p:nvPr/>
         </p:nvSpPr>
         <p:spPr>
           <a:xfrm>
-            <a:off x="822960" y="6309360"/>
+            <a:off x="1371600" y="6236208"/>
             <a:ext cx="3657600" cy="365760"/>
           </a:xfrm>
           <a:prstGeom prst="rect">
@@ -7738,13 +8374,13 @@
           <a:lstStyle/>
           <a:p>
             <a:r>
-              <a:rPr sz="1200" b="0">
-                <a:solidFill>
-                  <a:srgbClr val="B76E79"/>
-                </a:solidFill>
-                <a:latin typeface="Calibri"/>
+              <a:rPr sz="1000" b="1">
+                <a:solidFill>
+                  <a:srgbClr val="C8A04A"/>
+                </a:solidFill>
+                <a:latin typeface="Montserrat"/>
               </a:rPr>
-              <a:t>Lidia Nails</a:t>
+              <a:t>LIDIA · NAIL EXPERT</a:t>
             </a:r>
           </a:p>
         </p:txBody>
@@ -7782,7 +8418,7 @@
             <a:avLst/>
           </a:prstGeom>
           <a:solidFill>
-            <a:srgbClr val="FFFFFF"/>
+            <a:srgbClr val="FAF7F0"/>
           </a:solidFill>
           <a:ln>
             <a:noFill/>
@@ -7819,13 +8455,13 @@
         <p:spPr>
           <a:xfrm>
             <a:off x="0" y="0"/>
-            <a:ext cx="228600" cy="6858000"/>
+            <a:ext cx="201168" cy="6858000"/>
           </a:xfrm>
           <a:prstGeom prst="rect">
             <a:avLst/>
           </a:prstGeom>
           <a:solidFill>
-            <a:srgbClr val="B76E79"/>
+            <a:srgbClr val="C9D8C5"/>
           </a:solidFill>
           <a:ln>
             <a:noFill/>
@@ -7855,14 +8491,57 @@
       </p:sp>
       <p:sp>
         <p:nvSpPr>
-          <p:cNvPr id="4" name="TextBox 3"/>
+          <p:cNvPr id="4" name="Rectangle 3"/>
+          <p:cNvSpPr/>
+          <p:nvPr/>
+        </p:nvSpPr>
+        <p:spPr>
+          <a:xfrm>
+            <a:off x="201168" y="0"/>
+            <a:ext cx="36576" cy="6858000"/>
+          </a:xfrm>
+          <a:prstGeom prst="rect">
+            <a:avLst/>
+          </a:prstGeom>
+          <a:solidFill>
+            <a:srgbClr val="C8A04A"/>
+          </a:solidFill>
+          <a:ln>
+            <a:noFill/>
+          </a:ln>
+        </p:spPr>
+        <p:style>
+          <a:lnRef idx="1">
+            <a:schemeClr val="accent1"/>
+          </a:lnRef>
+          <a:fillRef idx="3">
+            <a:schemeClr val="accent1"/>
+          </a:fillRef>
+          <a:effectRef idx="2">
+            <a:schemeClr val="accent1"/>
+          </a:effectRef>
+          <a:fontRef idx="minor">
+            <a:schemeClr val="lt1"/>
+          </a:fontRef>
+        </p:style>
+        <p:txBody>
+          <a:bodyPr rtlCol="0" anchor="ctr"/>
+          <a:lstStyle/>
+          <a:p>
+            <a:pPr algn="ctr"/>
+          </a:p>
+        </p:txBody>
+      </p:sp>
+      <p:sp>
+        <p:nvSpPr>
+          <p:cNvPr id="5" name="TextBox 4"/>
           <p:cNvSpPr txBox="1"/>
           <p:nvPr/>
         </p:nvSpPr>
         <p:spPr>
           <a:xfrm>
-            <a:off x="822960" y="548640"/>
-            <a:ext cx="10515600" cy="914400"/>
+            <a:off x="822960" y="502920"/>
+            <a:ext cx="10789920" cy="914400"/>
           </a:xfrm>
           <a:prstGeom prst="rect">
             <a:avLst/>
@@ -7876,11 +8555,11 @@
           <a:lstStyle/>
           <a:p>
             <a:r>
-              <a:rPr sz="3600" b="1">
-                <a:solidFill>
-                  <a:srgbClr val="2B2B2B"/>
-                </a:solidFill>
-                <a:latin typeface="Calibri"/>
+              <a:rPr sz="3400" b="0">
+                <a:solidFill>
+                  <a:srgbClr val="34402F"/>
+                </a:solidFill>
+                <a:latin typeface="Playfair Display"/>
               </a:rPr>
               <a:t>2. Non confondere: tip classiche, press-on, dual form</a:t>
             </a:r>
@@ -7889,7 +8568,7 @@
       </p:sp>
       <p:sp>
         <p:nvSpPr>
-          <p:cNvPr id="5" name="TextBox 4"/>
+          <p:cNvPr id="6" name="TextBox 5"/>
           <p:cNvSpPr txBox="1"/>
           <p:nvPr/>
         </p:nvSpPr>
@@ -7911,24 +8590,24 @@
           <a:p>
             <a:pPr>
               <a:spcAft>
-                <a:spcPts val="1800"/>
+                <a:spcPts val="1600"/>
               </a:spcAft>
             </a:pPr>
             <a:r>
-              <a:rPr sz="2400" b="0">
-                <a:solidFill>
-                  <a:srgbClr val="2B2B2B"/>
-                </a:solidFill>
-                <a:latin typeface="Calibri"/>
+              <a:rPr sz="2200" b="0">
+                <a:solidFill>
+                  <a:srgbClr val="34402F"/>
+                </a:solidFill>
+                <a:latin typeface="Montserrat"/>
               </a:rPr>
               <a:t/>
             </a:r>
             <a:r>
-              <a:rPr sz="2800">
-                <a:solidFill>
-                  <a:srgbClr val="2B2B2B"/>
-                </a:solidFill>
-                <a:latin typeface="Calibri"/>
+              <a:rPr sz="2400">
+                <a:solidFill>
+                  <a:srgbClr val="34402F"/>
+                </a:solidFill>
+                <a:latin typeface="Montserrat"/>
               </a:rPr>
               <a:t>•  Tip classiche: parziali, rigide, incollate</a:t>
             </a:r>
@@ -7936,15 +8615,15 @@
           <a:p>
             <a:pPr>
               <a:spcAft>
-                <a:spcPts val="1800"/>
+                <a:spcPts val="1600"/>
               </a:spcAft>
             </a:pPr>
             <a:r>
-              <a:rPr sz="2800">
-                <a:solidFill>
-                  <a:srgbClr val="2B2B2B"/>
-                </a:solidFill>
-                <a:latin typeface="Calibri"/>
+              <a:rPr sz="2400">
+                <a:solidFill>
+                  <a:srgbClr val="34402F"/>
+                </a:solidFill>
+                <a:latin typeface="Montserrat"/>
               </a:rPr>
               <a:t>•  Gel Tip: copertura totale, applicate con gel</a:t>
             </a:r>
@@ -7952,15 +8631,15 @@
           <a:p>
             <a:pPr>
               <a:spcAft>
-                <a:spcPts val="1800"/>
+                <a:spcPts val="1600"/>
               </a:spcAft>
             </a:pPr>
             <a:r>
-              <a:rPr sz="2800">
-                <a:solidFill>
-                  <a:srgbClr val="2B2B2B"/>
-                </a:solidFill>
-                <a:latin typeface="Calibri"/>
+              <a:rPr sz="2400">
+                <a:solidFill>
+                  <a:srgbClr val="34402F"/>
+                </a:solidFill>
+                <a:latin typeface="Montserrat"/>
               </a:rPr>
               <a:t>•  Press-on: unghie finte in ABS, uso occasionale</a:t>
             </a:r>
@@ -7968,30 +8647,54 @@
           <a:p>
             <a:pPr>
               <a:spcAft>
-                <a:spcPts val="1800"/>
+                <a:spcPts val="1600"/>
               </a:spcAft>
             </a:pPr>
             <a:r>
-              <a:rPr sz="2800">
-                <a:solidFill>
-                  <a:srgbClr val="2B2B2B"/>
-                </a:solidFill>
-                <a:latin typeface="Calibri"/>
+              <a:rPr sz="2400">
+                <a:solidFill>
+                  <a:srgbClr val="34402F"/>
+                </a:solidFill>
+                <a:latin typeface="Montserrat"/>
               </a:rPr>
               <a:t>•  Dual form: tecnica manuale, non è una tip</a:t>
             </a:r>
           </a:p>
         </p:txBody>
       </p:sp>
-      <p:sp>
-        <p:nvSpPr>
-          <p:cNvPr id="6" name="TextBox 5"/>
+      <p:pic>
+        <p:nvPicPr>
+          <p:cNvPr id="7" name="Picture 6" descr="emblema-oliva.png"/>
+          <p:cNvPicPr>
+            <a:picLocks noChangeAspect="1"/>
+          </p:cNvPicPr>
+          <p:nvPr/>
+        </p:nvPicPr>
+        <p:blipFill>
+          <a:blip r:embed="rId2"/>
+          <a:stretch>
+            <a:fillRect/>
+          </a:stretch>
+        </p:blipFill>
+        <p:spPr>
+          <a:xfrm>
+            <a:off x="822960" y="6126480"/>
+            <a:ext cx="342900" cy="457200"/>
+          </a:xfrm>
+          <a:prstGeom prst="rect">
+            <a:avLst/>
+          </a:prstGeom>
+        </p:spPr>
+      </p:pic>
+      <p:sp>
+        <p:nvSpPr>
+          <p:cNvPr id="8" name="TextBox 7"/>
           <p:cNvSpPr txBox="1"/>
           <p:nvPr/>
         </p:nvSpPr>
         <p:spPr>
           <a:xfrm>
-            <a:off x="822960" y="6309360"/>
+            <a:off x="1371600" y="6236208"/>
             <a:ext cx="3657600" cy="365760"/>
           </a:xfrm>
           <a:prstGeom prst="rect">
@@ -8006,13 +8709,13 @@
           <a:lstStyle/>
           <a:p>
             <a:r>
-              <a:rPr sz="1200" b="0">
-                <a:solidFill>
-                  <a:srgbClr val="B76E79"/>
-                </a:solidFill>
-                <a:latin typeface="Calibri"/>
+              <a:rPr sz="1000" b="1">
+                <a:solidFill>
+                  <a:srgbClr val="C8A04A"/>
+                </a:solidFill>
+                <a:latin typeface="Montserrat"/>
               </a:rPr>
-              <a:t>Lidia Nails</a:t>
+              <a:t>LIDIA · NAIL EXPERT</a:t>
             </a:r>
           </a:p>
         </p:txBody>
@@ -8050,7 +8753,7 @@
             <a:avLst/>
           </a:prstGeom>
           <a:solidFill>
-            <a:srgbClr val="FFFFFF"/>
+            <a:srgbClr val="FAF7F0"/>
           </a:solidFill>
           <a:ln>
             <a:noFill/>
@@ -8087,13 +8790,13 @@
         <p:spPr>
           <a:xfrm>
             <a:off x="0" y="0"/>
-            <a:ext cx="228600" cy="6858000"/>
+            <a:ext cx="201168" cy="6858000"/>
           </a:xfrm>
           <a:prstGeom prst="rect">
             <a:avLst/>
           </a:prstGeom>
           <a:solidFill>
-            <a:srgbClr val="B76E79"/>
+            <a:srgbClr val="C9D8C5"/>
           </a:solidFill>
           <a:ln>
             <a:noFill/>
@@ -8123,14 +8826,57 @@
       </p:sp>
       <p:sp>
         <p:nvSpPr>
-          <p:cNvPr id="4" name="TextBox 3"/>
+          <p:cNvPr id="4" name="Rectangle 3"/>
+          <p:cNvSpPr/>
+          <p:nvPr/>
+        </p:nvSpPr>
+        <p:spPr>
+          <a:xfrm>
+            <a:off x="201168" y="0"/>
+            <a:ext cx="36576" cy="6858000"/>
+          </a:xfrm>
+          <a:prstGeom prst="rect">
+            <a:avLst/>
+          </a:prstGeom>
+          <a:solidFill>
+            <a:srgbClr val="C8A04A"/>
+          </a:solidFill>
+          <a:ln>
+            <a:noFill/>
+          </a:ln>
+        </p:spPr>
+        <p:style>
+          <a:lnRef idx="1">
+            <a:schemeClr val="accent1"/>
+          </a:lnRef>
+          <a:fillRef idx="3">
+            <a:schemeClr val="accent1"/>
+          </a:fillRef>
+          <a:effectRef idx="2">
+            <a:schemeClr val="accent1"/>
+          </a:effectRef>
+          <a:fontRef idx="minor">
+            <a:schemeClr val="lt1"/>
+          </a:fontRef>
+        </p:style>
+        <p:txBody>
+          <a:bodyPr rtlCol="0" anchor="ctr"/>
+          <a:lstStyle/>
+          <a:p>
+            <a:pPr algn="ctr"/>
+          </a:p>
+        </p:txBody>
+      </p:sp>
+      <p:sp>
+        <p:nvSpPr>
+          <p:cNvPr id="5" name="TextBox 4"/>
           <p:cNvSpPr txBox="1"/>
           <p:nvPr/>
         </p:nvSpPr>
         <p:spPr>
           <a:xfrm>
-            <a:off x="822960" y="548640"/>
-            <a:ext cx="10515600" cy="914400"/>
+            <a:off x="822960" y="502920"/>
+            <a:ext cx="10789920" cy="914400"/>
           </a:xfrm>
           <a:prstGeom prst="rect">
             <a:avLst/>
@@ -8144,11 +8890,11 @@
           <a:lstStyle/>
           <a:p>
             <a:r>
-              <a:rPr sz="3600" b="1">
-                <a:solidFill>
-                  <a:srgbClr val="2B2B2B"/>
-                </a:solidFill>
-                <a:latin typeface="Calibri"/>
+              <a:rPr sz="3400" b="0">
+                <a:solidFill>
+                  <a:srgbClr val="34402F"/>
+                </a:solidFill>
+                <a:latin typeface="Playfair Display"/>
               </a:rPr>
               <a:t>3. Gel vs plastica: come riconoscere la qualità</a:t>
             </a:r>
@@ -8157,7 +8903,7 @@
       </p:sp>
       <p:sp>
         <p:nvSpPr>
-          <p:cNvPr id="5" name="TextBox 4"/>
+          <p:cNvPr id="6" name="TextBox 5"/>
           <p:cNvSpPr txBox="1"/>
           <p:nvPr/>
         </p:nvSpPr>
@@ -8179,24 +8925,24 @@
           <a:p>
             <a:pPr>
               <a:spcAft>
-                <a:spcPts val="1800"/>
+                <a:spcPts val="1600"/>
               </a:spcAft>
             </a:pPr>
             <a:r>
-              <a:rPr sz="2400" b="0">
-                <a:solidFill>
-                  <a:srgbClr val="2B2B2B"/>
-                </a:solidFill>
-                <a:latin typeface="Calibri"/>
+              <a:rPr sz="2200" b="0">
+                <a:solidFill>
+                  <a:srgbClr val="34402F"/>
+                </a:solidFill>
+                <a:latin typeface="Montserrat"/>
               </a:rPr>
               <a:t/>
             </a:r>
             <a:r>
-              <a:rPr sz="2800">
-                <a:solidFill>
-                  <a:srgbClr val="2B2B2B"/>
-                </a:solidFill>
-                <a:latin typeface="Calibri"/>
+              <a:rPr sz="2400">
+                <a:solidFill>
+                  <a:srgbClr val="34402F"/>
+                </a:solidFill>
+                <a:latin typeface="Montserrat"/>
               </a:rPr>
               <a:t>•  Gel: flessibile ma resistente. ABS: rigida e cede</a:t>
             </a:r>
@@ -8204,15 +8950,15 @@
           <a:p>
             <a:pPr>
               <a:spcAft>
-                <a:spcPts val="1800"/>
+                <a:spcPts val="1600"/>
               </a:spcAft>
             </a:pPr>
             <a:r>
-              <a:rPr sz="2800">
-                <a:solidFill>
-                  <a:srgbClr val="2B2B2B"/>
-                </a:solidFill>
-                <a:latin typeface="Calibri"/>
+              <a:rPr sz="2400">
+                <a:solidFill>
+                  <a:srgbClr val="34402F"/>
+                </a:solidFill>
+                <a:latin typeface="Montserrat"/>
               </a:rPr>
               <a:t>•  Allarmi: prezzo troppo basso, ABS, struttura sbagliata</a:t>
             </a:r>
@@ -8220,15 +8966,15 @@
           <a:p>
             <a:pPr>
               <a:spcAft>
-                <a:spcPts val="1800"/>
+                <a:spcPts val="1600"/>
               </a:spcAft>
             </a:pPr>
             <a:r>
-              <a:rPr sz="2800">
-                <a:solidFill>
-                  <a:srgbClr val="2B2B2B"/>
-                </a:solidFill>
-                <a:latin typeface="Calibri"/>
+              <a:rPr sz="2400">
+                <a:solidFill>
+                  <a:srgbClr val="34402F"/>
+                </a:solidFill>
+                <a:latin typeface="Montserrat"/>
               </a:rPr>
               <a:t>•  Test della lima: odore di plastica bruciata = plastica</a:t>
             </a:r>
@@ -8236,30 +8982,54 @@
           <a:p>
             <a:pPr>
               <a:spcAft>
-                <a:spcPts val="1800"/>
+                <a:spcPts val="1600"/>
               </a:spcAft>
             </a:pPr>
             <a:r>
-              <a:rPr sz="2800">
-                <a:solidFill>
-                  <a:srgbClr val="2B2B2B"/>
-                </a:solidFill>
-                <a:latin typeface="Calibri"/>
+              <a:rPr sz="2400">
+                <a:solidFill>
+                  <a:srgbClr val="34402F"/>
+                </a:solidFill>
+                <a:latin typeface="Montserrat"/>
               </a:rPr>
               <a:t>•  Valutare la tip, non il marchio</a:t>
             </a:r>
           </a:p>
         </p:txBody>
       </p:sp>
-      <p:sp>
-        <p:nvSpPr>
-          <p:cNvPr id="6" name="TextBox 5"/>
+      <p:pic>
+        <p:nvPicPr>
+          <p:cNvPr id="7" name="Picture 6" descr="emblema-oliva.png"/>
+          <p:cNvPicPr>
+            <a:picLocks noChangeAspect="1"/>
+          </p:cNvPicPr>
+          <p:nvPr/>
+        </p:nvPicPr>
+        <p:blipFill>
+          <a:blip r:embed="rId2"/>
+          <a:stretch>
+            <a:fillRect/>
+          </a:stretch>
+        </p:blipFill>
+        <p:spPr>
+          <a:xfrm>
+            <a:off x="822960" y="6126480"/>
+            <a:ext cx="342900" cy="457200"/>
+          </a:xfrm>
+          <a:prstGeom prst="rect">
+            <a:avLst/>
+          </a:prstGeom>
+        </p:spPr>
+      </p:pic>
+      <p:sp>
+        <p:nvSpPr>
+          <p:cNvPr id="8" name="TextBox 7"/>
           <p:cNvSpPr txBox="1"/>
           <p:nvPr/>
         </p:nvSpPr>
         <p:spPr>
           <a:xfrm>
-            <a:off x="822960" y="6309360"/>
+            <a:off x="1371600" y="6236208"/>
             <a:ext cx="3657600" cy="365760"/>
           </a:xfrm>
           <a:prstGeom prst="rect">
@@ -8274,13 +9044,13 @@
           <a:lstStyle/>
           <a:p>
             <a:r>
-              <a:rPr sz="1200" b="0">
-                <a:solidFill>
-                  <a:srgbClr val="B76E79"/>
-                </a:solidFill>
-                <a:latin typeface="Calibri"/>
+              <a:rPr sz="1000" b="1">
+                <a:solidFill>
+                  <a:srgbClr val="C8A04A"/>
+                </a:solidFill>
+                <a:latin typeface="Montserrat"/>
               </a:rPr>
-              <a:t>Lidia Nails</a:t>
+              <a:t>LIDIA · NAIL EXPERT</a:t>
             </a:r>
           </a:p>
         </p:txBody>
@@ -8318,7 +9088,7 @@
             <a:avLst/>
           </a:prstGeom>
           <a:solidFill>
-            <a:srgbClr val="FFFFFF"/>
+            <a:srgbClr val="FAF7F0"/>
           </a:solidFill>
           <a:ln>
             <a:noFill/>
@@ -8355,13 +9125,13 @@
         <p:spPr>
           <a:xfrm>
             <a:off x="0" y="0"/>
-            <a:ext cx="228600" cy="6858000"/>
+            <a:ext cx="201168" cy="6858000"/>
           </a:xfrm>
           <a:prstGeom prst="rect">
             <a:avLst/>
           </a:prstGeom>
           <a:solidFill>
-            <a:srgbClr val="B76E79"/>
+            <a:srgbClr val="C9D8C5"/>
           </a:solidFill>
           <a:ln>
             <a:noFill/>
@@ -8391,14 +9161,57 @@
       </p:sp>
       <p:sp>
         <p:nvSpPr>
-          <p:cNvPr id="4" name="TextBox 3"/>
+          <p:cNvPr id="4" name="Rectangle 3"/>
+          <p:cNvSpPr/>
+          <p:nvPr/>
+        </p:nvSpPr>
+        <p:spPr>
+          <a:xfrm>
+            <a:off x="201168" y="0"/>
+            <a:ext cx="36576" cy="6858000"/>
+          </a:xfrm>
+          <a:prstGeom prst="rect">
+            <a:avLst/>
+          </a:prstGeom>
+          <a:solidFill>
+            <a:srgbClr val="C8A04A"/>
+          </a:solidFill>
+          <a:ln>
+            <a:noFill/>
+          </a:ln>
+        </p:spPr>
+        <p:style>
+          <a:lnRef idx="1">
+            <a:schemeClr val="accent1"/>
+          </a:lnRef>
+          <a:fillRef idx="3">
+            <a:schemeClr val="accent1"/>
+          </a:fillRef>
+          <a:effectRef idx="2">
+            <a:schemeClr val="accent1"/>
+          </a:effectRef>
+          <a:fontRef idx="minor">
+            <a:schemeClr val="lt1"/>
+          </a:fontRef>
+        </p:style>
+        <p:txBody>
+          <a:bodyPr rtlCol="0" anchor="ctr"/>
+          <a:lstStyle/>
+          <a:p>
+            <a:pPr algn="ctr"/>
+          </a:p>
+        </p:txBody>
+      </p:sp>
+      <p:sp>
+        <p:nvSpPr>
+          <p:cNvPr id="5" name="TextBox 4"/>
           <p:cNvSpPr txBox="1"/>
           <p:nvPr/>
         </p:nvSpPr>
         <p:spPr>
           <a:xfrm>
-            <a:off x="822960" y="548640"/>
-            <a:ext cx="10515600" cy="914400"/>
+            <a:off x="822960" y="502920"/>
+            <a:ext cx="10789920" cy="914400"/>
           </a:xfrm>
           <a:prstGeom prst="rect">
             <a:avLst/>
@@ -8412,11 +9225,11 @@
           <a:lstStyle/>
           <a:p>
             <a:r>
-              <a:rPr sz="3600" b="1">
-                <a:solidFill>
-                  <a:srgbClr val="2B2B2B"/>
-                </a:solidFill>
-                <a:latin typeface="Calibri"/>
+              <a:rPr sz="3400" b="0">
+                <a:solidFill>
+                  <a:srgbClr val="34402F"/>
+                </a:solidFill>
+                <a:latin typeface="Playfair Display"/>
               </a:rPr>
               <a:t>4. Struttura corretta di una tip professionale</a:t>
             </a:r>
@@ -8425,7 +9238,7 @@
       </p:sp>
       <p:sp>
         <p:nvSpPr>
-          <p:cNvPr id="5" name="TextBox 4"/>
+          <p:cNvPr id="6" name="TextBox 5"/>
           <p:cNvSpPr txBox="1"/>
           <p:nvPr/>
         </p:nvSpPr>
@@ -8447,24 +9260,24 @@
           <a:p>
             <a:pPr>
               <a:spcAft>
-                <a:spcPts val="1800"/>
+                <a:spcPts val="1600"/>
               </a:spcAft>
             </a:pPr>
             <a:r>
-              <a:rPr sz="2400" b="0">
-                <a:solidFill>
-                  <a:srgbClr val="2B2B2B"/>
-                </a:solidFill>
-                <a:latin typeface="Calibri"/>
+              <a:rPr sz="2200" b="0">
+                <a:solidFill>
+                  <a:srgbClr val="34402F"/>
+                </a:solidFill>
+                <a:latin typeface="Montserrat"/>
               </a:rPr>
               <a:t/>
             </a:r>
             <a:r>
-              <a:rPr sz="2400">
-                <a:solidFill>
-                  <a:srgbClr val="2B2B2B"/>
-                </a:solidFill>
-                <a:latin typeface="Calibri"/>
+              <a:rPr sz="2000">
+                <a:solidFill>
+                  <a:srgbClr val="34402F"/>
+                </a:solidFill>
+                <a:latin typeface="Montserrat"/>
               </a:rPr>
               <a:t>•  Spessore: sottile alla cuticola, più spesso al bordo libero</a:t>
             </a:r>
@@ -8472,15 +9285,15 @@
           <a:p>
             <a:pPr>
               <a:spcAft>
-                <a:spcPts val="1800"/>
+                <a:spcPts val="1600"/>
               </a:spcAft>
             </a:pPr>
             <a:r>
-              <a:rPr sz="2400">
-                <a:solidFill>
-                  <a:srgbClr val="2B2B2B"/>
-                </a:solidFill>
-                <a:latin typeface="Calibri"/>
+              <a:rPr sz="2000">
+                <a:solidFill>
+                  <a:srgbClr val="34402F"/>
+                </a:solidFill>
+                <a:latin typeface="Montserrat"/>
               </a:rPr>
               <a:t>•  Giro cuticola tondo a mezzaluna, senza angoli</a:t>
             </a:r>
@@ -8488,15 +9301,15 @@
           <a:p>
             <a:pPr>
               <a:spcAft>
-                <a:spcPts val="1800"/>
+                <a:spcPts val="1600"/>
               </a:spcAft>
             </a:pPr>
             <a:r>
-              <a:rPr sz="2400">
-                <a:solidFill>
-                  <a:srgbClr val="2B2B2B"/>
-                </a:solidFill>
-                <a:latin typeface="Calibri"/>
+              <a:rPr sz="2000">
+                <a:solidFill>
+                  <a:srgbClr val="34402F"/>
+                </a:solidFill>
+                <a:latin typeface="Montserrat"/>
               </a:rPr>
               <a:t>•  Profilo laterale morbido, laterali coperti</a:t>
             </a:r>
@@ -8504,15 +9317,15 @@
           <a:p>
             <a:pPr>
               <a:spcAft>
-                <a:spcPts val="1800"/>
+                <a:spcPts val="1600"/>
               </a:spcAft>
             </a:pPr>
             <a:r>
-              <a:rPr sz="2400">
-                <a:solidFill>
-                  <a:srgbClr val="2B2B2B"/>
-                </a:solidFill>
-                <a:latin typeface="Calibri"/>
+              <a:rPr sz="2000">
+                <a:solidFill>
+                  <a:srgbClr val="34402F"/>
+                </a:solidFill>
+                <a:latin typeface="Montserrat"/>
               </a:rPr>
               <a:t>•  No apice alto, no becco di pappagallo</a:t>
             </a:r>
@@ -8521,7 +9334,7 @@
       </p:sp>
       <p:pic>
         <p:nvPicPr>
-          <p:cNvPr id="6" name="Picture 5" descr="struttura-tip.png"/>
+          <p:cNvPr id="7" name="Picture 6" descr="struttura-tip.png"/>
           <p:cNvPicPr>
             <a:picLocks noChangeAspect="1"/>
           </p:cNvPicPr>
@@ -8543,15 +9356,39 @@
           </a:prstGeom>
         </p:spPr>
       </p:pic>
-      <p:sp>
-        <p:nvSpPr>
-          <p:cNvPr id="7" name="TextBox 6"/>
+      <p:pic>
+        <p:nvPicPr>
+          <p:cNvPr id="8" name="Picture 7" descr="emblema-oliva.png"/>
+          <p:cNvPicPr>
+            <a:picLocks noChangeAspect="1"/>
+          </p:cNvPicPr>
+          <p:nvPr/>
+        </p:nvPicPr>
+        <p:blipFill>
+          <a:blip r:embed="rId3"/>
+          <a:stretch>
+            <a:fillRect/>
+          </a:stretch>
+        </p:blipFill>
+        <p:spPr>
+          <a:xfrm>
+            <a:off x="822960" y="6126480"/>
+            <a:ext cx="342900" cy="457200"/>
+          </a:xfrm>
+          <a:prstGeom prst="rect">
+            <a:avLst/>
+          </a:prstGeom>
+        </p:spPr>
+      </p:pic>
+      <p:sp>
+        <p:nvSpPr>
+          <p:cNvPr id="9" name="TextBox 8"/>
           <p:cNvSpPr txBox="1"/>
           <p:nvPr/>
         </p:nvSpPr>
         <p:spPr>
           <a:xfrm>
-            <a:off x="822960" y="6309360"/>
+            <a:off x="1371600" y="6236208"/>
             <a:ext cx="3657600" cy="365760"/>
           </a:xfrm>
           <a:prstGeom prst="rect">
@@ -8566,13 +9403,13 @@
           <a:lstStyle/>
           <a:p>
             <a:r>
-              <a:rPr sz="1200" b="0">
-                <a:solidFill>
-                  <a:srgbClr val="B76E79"/>
-                </a:solidFill>
-                <a:latin typeface="Calibri"/>
+              <a:rPr sz="1000" b="1">
+                <a:solidFill>
+                  <a:srgbClr val="C8A04A"/>
+                </a:solidFill>
+                <a:latin typeface="Montserrat"/>
               </a:rPr>
-              <a:t>Lidia Nails</a:t>
+              <a:t>LIDIA · NAIL EXPERT</a:t>
             </a:r>
           </a:p>
         </p:txBody>
@@ -8610,7 +9447,7 @@
             <a:avLst/>
           </a:prstGeom>
           <a:solidFill>
-            <a:srgbClr val="FFFFFF"/>
+            <a:srgbClr val="FAF7F0"/>
           </a:solidFill>
           <a:ln>
             <a:noFill/>
@@ -8647,13 +9484,13 @@
         <p:spPr>
           <a:xfrm>
             <a:off x="0" y="0"/>
-            <a:ext cx="228600" cy="6858000"/>
+            <a:ext cx="201168" cy="6858000"/>
           </a:xfrm>
           <a:prstGeom prst="rect">
             <a:avLst/>
           </a:prstGeom>
           <a:solidFill>
-            <a:srgbClr val="B76E79"/>
+            <a:srgbClr val="C9D8C5"/>
           </a:solidFill>
           <a:ln>
             <a:noFill/>
@@ -8683,14 +9520,57 @@
       </p:sp>
       <p:sp>
         <p:nvSpPr>
-          <p:cNvPr id="4" name="TextBox 3"/>
+          <p:cNvPr id="4" name="Rectangle 3"/>
+          <p:cNvSpPr/>
+          <p:nvPr/>
+        </p:nvSpPr>
+        <p:spPr>
+          <a:xfrm>
+            <a:off x="201168" y="0"/>
+            <a:ext cx="36576" cy="6858000"/>
+          </a:xfrm>
+          <a:prstGeom prst="rect">
+            <a:avLst/>
+          </a:prstGeom>
+          <a:solidFill>
+            <a:srgbClr val="C8A04A"/>
+          </a:solidFill>
+          <a:ln>
+            <a:noFill/>
+          </a:ln>
+        </p:spPr>
+        <p:style>
+          <a:lnRef idx="1">
+            <a:schemeClr val="accent1"/>
+          </a:lnRef>
+          <a:fillRef idx="3">
+            <a:schemeClr val="accent1"/>
+          </a:fillRef>
+          <a:effectRef idx="2">
+            <a:schemeClr val="accent1"/>
+          </a:effectRef>
+          <a:fontRef idx="minor">
+            <a:schemeClr val="lt1"/>
+          </a:fontRef>
+        </p:style>
+        <p:txBody>
+          <a:bodyPr rtlCol="0" anchor="ctr"/>
+          <a:lstStyle/>
+          <a:p>
+            <a:pPr algn="ctr"/>
+          </a:p>
+        </p:txBody>
+      </p:sp>
+      <p:sp>
+        <p:nvSpPr>
+          <p:cNvPr id="5" name="TextBox 4"/>
           <p:cNvSpPr txBox="1"/>
           <p:nvPr/>
         </p:nvSpPr>
         <p:spPr>
           <a:xfrm>
-            <a:off x="822960" y="548640"/>
-            <a:ext cx="10515600" cy="914400"/>
+            <a:off x="822960" y="502920"/>
+            <a:ext cx="10789920" cy="914400"/>
           </a:xfrm>
           <a:prstGeom prst="rect">
             <a:avLst/>
@@ -8704,11 +9584,11 @@
           <a:lstStyle/>
           <a:p>
             <a:r>
-              <a:rPr sz="3600" b="1">
-                <a:solidFill>
-                  <a:srgbClr val="2B2B2B"/>
-                </a:solidFill>
-                <a:latin typeface="Calibri"/>
+              <a:rPr sz="3400" b="0">
+                <a:solidFill>
+                  <a:srgbClr val="34402F"/>
+                </a:solidFill>
+                <a:latin typeface="Playfair Display"/>
               </a:rPr>
               <a:t>5. Quale tip scegliere</a:t>
             </a:r>
@@ -8717,7 +9597,7 @@
       </p:sp>
       <p:sp>
         <p:nvSpPr>
-          <p:cNvPr id="5" name="TextBox 4"/>
+          <p:cNvPr id="6" name="TextBox 5"/>
           <p:cNvSpPr txBox="1"/>
           <p:nvPr/>
         </p:nvSpPr>
@@ -8739,24 +9619,24 @@
           <a:p>
             <a:pPr>
               <a:spcAft>
-                <a:spcPts val="1800"/>
+                <a:spcPts val="1600"/>
               </a:spcAft>
             </a:pPr>
             <a:r>
-              <a:rPr sz="2400" b="0">
-                <a:solidFill>
-                  <a:srgbClr val="2B2B2B"/>
-                </a:solidFill>
-                <a:latin typeface="Calibri"/>
+              <a:rPr sz="2200" b="0">
+                <a:solidFill>
+                  <a:srgbClr val="34402F"/>
+                </a:solidFill>
+                <a:latin typeface="Montserrat"/>
               </a:rPr>
               <a:t/>
             </a:r>
             <a:r>
-              <a:rPr sz="2400">
-                <a:solidFill>
-                  <a:srgbClr val="2B2B2B"/>
-                </a:solidFill>
-                <a:latin typeface="Calibri"/>
+              <a:rPr sz="2000">
+                <a:solidFill>
+                  <a:srgbClr val="34402F"/>
+                </a:solidFill>
+                <a:latin typeface="Montserrat"/>
               </a:rPr>
               <a:t>•  Trasparente: vedi il gel camminare, blocco in 7-8 secondi</a:t>
             </a:r>
@@ -8764,15 +9644,15 @@
           <a:p>
             <a:pPr>
               <a:spcAft>
-                <a:spcPts val="1800"/>
+                <a:spcPts val="1600"/>
               </a:spcAft>
             </a:pPr>
             <a:r>
-              <a:rPr sz="2400">
-                <a:solidFill>
-                  <a:srgbClr val="2B2B2B"/>
-                </a:solidFill>
-                <a:latin typeface="Calibri"/>
+              <a:rPr sz="2000">
+                <a:solidFill>
+                  <a:srgbClr val="34402F"/>
+                </a:solidFill>
+                <a:latin typeface="Montserrat"/>
               </a:rPr>
               <a:t>•  Colorata: meno controllo, luce più lenta, meno flessibile</a:t>
             </a:r>
@@ -8780,15 +9660,15 @@
           <a:p>
             <a:pPr>
               <a:spcAft>
-                <a:spcPts val="1800"/>
+                <a:spcPts val="1600"/>
               </a:spcAft>
             </a:pPr>
             <a:r>
-              <a:rPr sz="2400">
-                <a:solidFill>
-                  <a:srgbClr val="2B2B2B"/>
-                </a:solidFill>
-                <a:latin typeface="Calibri"/>
+              <a:rPr sz="2000">
+                <a:solidFill>
+                  <a:srgbClr val="34402F"/>
+                </a:solidFill>
+                <a:latin typeface="Montserrat"/>
               </a:rPr>
               <a:t>•  Semi-opaca: liscia dentro, già sottile → scartarla</a:t>
             </a:r>
@@ -8797,7 +9677,7 @@
       </p:sp>
       <p:pic>
         <p:nvPicPr>
-          <p:cNvPr id="6" name="Picture 5" descr="tip-tipi.png"/>
+          <p:cNvPr id="7" name="Picture 6" descr="tip-tipi.png"/>
           <p:cNvPicPr>
             <a:picLocks noChangeAspect="1"/>
           </p:cNvPicPr>
@@ -8819,15 +9699,39 @@
           </a:prstGeom>
         </p:spPr>
       </p:pic>
-      <p:sp>
-        <p:nvSpPr>
-          <p:cNvPr id="7" name="TextBox 6"/>
+      <p:pic>
+        <p:nvPicPr>
+          <p:cNvPr id="8" name="Picture 7" descr="emblema-oliva.png"/>
+          <p:cNvPicPr>
+            <a:picLocks noChangeAspect="1"/>
+          </p:cNvPicPr>
+          <p:nvPr/>
+        </p:nvPicPr>
+        <p:blipFill>
+          <a:blip r:embed="rId3"/>
+          <a:stretch>
+            <a:fillRect/>
+          </a:stretch>
+        </p:blipFill>
+        <p:spPr>
+          <a:xfrm>
+            <a:off x="822960" y="6126480"/>
+            <a:ext cx="342900" cy="457200"/>
+          </a:xfrm>
+          <a:prstGeom prst="rect">
+            <a:avLst/>
+          </a:prstGeom>
+        </p:spPr>
+      </p:pic>
+      <p:sp>
+        <p:nvSpPr>
+          <p:cNvPr id="9" name="TextBox 8"/>
           <p:cNvSpPr txBox="1"/>
           <p:nvPr/>
         </p:nvSpPr>
         <p:spPr>
           <a:xfrm>
-            <a:off x="822960" y="6309360"/>
+            <a:off x="1371600" y="6236208"/>
             <a:ext cx="3657600" cy="365760"/>
           </a:xfrm>
           <a:prstGeom prst="rect">
@@ -8842,13 +9746,13 @@
           <a:lstStyle/>
           <a:p>
             <a:r>
-              <a:rPr sz="1200" b="0">
-                <a:solidFill>
-                  <a:srgbClr val="B76E79"/>
-                </a:solidFill>
-                <a:latin typeface="Calibri"/>
+              <a:rPr sz="1000" b="1">
+                <a:solidFill>
+                  <a:srgbClr val="C8A04A"/>
+                </a:solidFill>
+                <a:latin typeface="Montserrat"/>
               </a:rPr>
-              <a:t>Lidia Nails</a:t>
+              <a:t>LIDIA · NAIL EXPERT</a:t>
             </a:r>
           </a:p>
         </p:txBody>
@@ -8886,7 +9790,7 @@
             <a:avLst/>
           </a:prstGeom>
           <a:solidFill>
-            <a:srgbClr val="FFFFFF"/>
+            <a:srgbClr val="FAF7F0"/>
           </a:solidFill>
           <a:ln>
             <a:noFill/>
@@ -8923,13 +9827,13 @@
         <p:spPr>
           <a:xfrm>
             <a:off x="0" y="0"/>
-            <a:ext cx="228600" cy="6858000"/>
+            <a:ext cx="201168" cy="6858000"/>
           </a:xfrm>
           <a:prstGeom prst="rect">
             <a:avLst/>
           </a:prstGeom>
           <a:solidFill>
-            <a:srgbClr val="B76E79"/>
+            <a:srgbClr val="C9D8C5"/>
           </a:solidFill>
           <a:ln>
             <a:noFill/>
@@ -8959,14 +9863,57 @@
       </p:sp>
       <p:sp>
         <p:nvSpPr>
-          <p:cNvPr id="4" name="TextBox 3"/>
+          <p:cNvPr id="4" name="Rectangle 3"/>
+          <p:cNvSpPr/>
+          <p:nvPr/>
+        </p:nvSpPr>
+        <p:spPr>
+          <a:xfrm>
+            <a:off x="201168" y="0"/>
+            <a:ext cx="36576" cy="6858000"/>
+          </a:xfrm>
+          <a:prstGeom prst="rect">
+            <a:avLst/>
+          </a:prstGeom>
+          <a:solidFill>
+            <a:srgbClr val="C8A04A"/>
+          </a:solidFill>
+          <a:ln>
+            <a:noFill/>
+          </a:ln>
+        </p:spPr>
+        <p:style>
+          <a:lnRef idx="1">
+            <a:schemeClr val="accent1"/>
+          </a:lnRef>
+          <a:fillRef idx="3">
+            <a:schemeClr val="accent1"/>
+          </a:fillRef>
+          <a:effectRef idx="2">
+            <a:schemeClr val="accent1"/>
+          </a:effectRef>
+          <a:fontRef idx="minor">
+            <a:schemeClr val="lt1"/>
+          </a:fontRef>
+        </p:style>
+        <p:txBody>
+          <a:bodyPr rtlCol="0" anchor="ctr"/>
+          <a:lstStyle/>
+          <a:p>
+            <a:pPr algn="ctr"/>
+          </a:p>
+        </p:txBody>
+      </p:sp>
+      <p:sp>
+        <p:nvSpPr>
+          <p:cNvPr id="5" name="TextBox 4"/>
           <p:cNvSpPr txBox="1"/>
           <p:nvPr/>
         </p:nvSpPr>
         <p:spPr>
           <a:xfrm>
-            <a:off x="822960" y="548640"/>
-            <a:ext cx="10515600" cy="914400"/>
+            <a:off x="822960" y="502920"/>
+            <a:ext cx="10789920" cy="914400"/>
           </a:xfrm>
           <a:prstGeom prst="rect">
             <a:avLst/>
@@ -8980,11 +9927,11 @@
           <a:lstStyle/>
           <a:p>
             <a:r>
-              <a:rPr sz="3600" b="1">
-                <a:solidFill>
-                  <a:srgbClr val="2B2B2B"/>
-                </a:solidFill>
-                <a:latin typeface="Calibri"/>
+              <a:rPr sz="3400" b="0">
+                <a:solidFill>
+                  <a:srgbClr val="34402F"/>
+                </a:solidFill>
+                <a:latin typeface="Playfair Display"/>
               </a:rPr>
               <a:t>6. Lunghezze, forme e misure</a:t>
             </a:r>
@@ -8993,7 +9940,7 @@
       </p:sp>
       <p:sp>
         <p:nvSpPr>
-          <p:cNvPr id="5" name="TextBox 4"/>
+          <p:cNvPr id="6" name="TextBox 5"/>
           <p:cNvSpPr txBox="1"/>
           <p:nvPr/>
         </p:nvSpPr>
@@ -9015,24 +9962,24 @@
           <a:p>
             <a:pPr>
               <a:spcAft>
-                <a:spcPts val="1800"/>
+                <a:spcPts val="1600"/>
               </a:spcAft>
             </a:pPr>
             <a:r>
-              <a:rPr sz="2400" b="0">
-                <a:solidFill>
-                  <a:srgbClr val="2B2B2B"/>
-                </a:solidFill>
-                <a:latin typeface="Calibri"/>
+              <a:rPr sz="2200" b="0">
+                <a:solidFill>
+                  <a:srgbClr val="34402F"/>
+                </a:solidFill>
+                <a:latin typeface="Montserrat"/>
               </a:rPr>
               <a:t/>
             </a:r>
             <a:r>
-              <a:rPr sz="2400">
-                <a:solidFill>
-                  <a:srgbClr val="2B2B2B"/>
-                </a:solidFill>
-                <a:latin typeface="Calibri"/>
+              <a:rPr sz="2000">
+                <a:solidFill>
+                  <a:srgbClr val="34402F"/>
+                </a:solidFill>
+                <a:latin typeface="Montserrat"/>
               </a:rPr>
               <a:t>•  Lunghezze XS – XL</a:t>
             </a:r>
@@ -9040,15 +9987,15 @@
           <a:p>
             <a:pPr>
               <a:spcAft>
-                <a:spcPts val="1800"/>
+                <a:spcPts val="1600"/>
               </a:spcAft>
             </a:pPr>
             <a:r>
-              <a:rPr sz="2400">
-                <a:solidFill>
-                  <a:srgbClr val="2B2B2B"/>
-                </a:solidFill>
-                <a:latin typeface="Calibri"/>
+              <a:rPr sz="2000">
+                <a:solidFill>
+                  <a:srgbClr val="34402F"/>
+                </a:solidFill>
+                <a:latin typeface="Montserrat"/>
               </a:rPr>
               <a:t>•  14 misure (0–9 con le mezze)</a:t>
             </a:r>
@@ -9056,15 +10003,15 @@
           <a:p>
             <a:pPr>
               <a:spcAft>
-                <a:spcPts val="1800"/>
+                <a:spcPts val="1600"/>
               </a:spcAft>
             </a:pPr>
             <a:r>
-              <a:rPr sz="2400">
-                <a:solidFill>
-                  <a:srgbClr val="2B2B2B"/>
-                </a:solidFill>
-                <a:latin typeface="Calibri"/>
+              <a:rPr sz="2000">
+                <a:solidFill>
+                  <a:srgbClr val="34402F"/>
+                </a:solidFill>
+                <a:latin typeface="Montserrat"/>
               </a:rPr>
               <a:t>•  0–1 pollice · 2–6,5 dita centrali · 7–9 mignolo</a:t>
             </a:r>
@@ -9072,15 +10019,15 @@
           <a:p>
             <a:pPr>
               <a:spcAft>
-                <a:spcPts val="1800"/>
+                <a:spcPts val="1600"/>
               </a:spcAft>
             </a:pPr>
             <a:r>
-              <a:rPr sz="2400">
-                <a:solidFill>
-                  <a:srgbClr val="2B2B2B"/>
-                </a:solidFill>
-                <a:latin typeface="Calibri"/>
+              <a:rPr sz="2000">
+                <a:solidFill>
+                  <a:srgbClr val="34402F"/>
+                </a:solidFill>
+                <a:latin typeface="Montserrat"/>
               </a:rPr>
               <a:t>•  La numerazione cambia per forma e per mano</a:t>
             </a:r>
@@ -9089,7 +10036,7 @@
       </p:sp>
       <p:pic>
         <p:nvPicPr>
-          <p:cNvPr id="6" name="Picture 5" descr="misure-mano.png"/>
+          <p:cNvPr id="7" name="Picture 6" descr="misure-mano.png"/>
           <p:cNvPicPr>
             <a:picLocks noChangeAspect="1"/>
           </p:cNvPicPr>
@@ -9111,15 +10058,39 @@
           </a:prstGeom>
         </p:spPr>
       </p:pic>
-      <p:sp>
-        <p:nvSpPr>
-          <p:cNvPr id="7" name="TextBox 6"/>
+      <p:pic>
+        <p:nvPicPr>
+          <p:cNvPr id="8" name="Picture 7" descr="emblema-oliva.png"/>
+          <p:cNvPicPr>
+            <a:picLocks noChangeAspect="1"/>
+          </p:cNvPicPr>
+          <p:nvPr/>
+        </p:nvPicPr>
+        <p:blipFill>
+          <a:blip r:embed="rId3"/>
+          <a:stretch>
+            <a:fillRect/>
+          </a:stretch>
+        </p:blipFill>
+        <p:spPr>
+          <a:xfrm>
+            <a:off x="822960" y="6126480"/>
+            <a:ext cx="342900" cy="457200"/>
+          </a:xfrm>
+          <a:prstGeom prst="rect">
+            <a:avLst/>
+          </a:prstGeom>
+        </p:spPr>
+      </p:pic>
+      <p:sp>
+        <p:nvSpPr>
+          <p:cNvPr id="9" name="TextBox 8"/>
           <p:cNvSpPr txBox="1"/>
           <p:nvPr/>
         </p:nvSpPr>
         <p:spPr>
           <a:xfrm>
-            <a:off x="822960" y="6309360"/>
+            <a:off x="1371600" y="6236208"/>
             <a:ext cx="3657600" cy="365760"/>
           </a:xfrm>
           <a:prstGeom prst="rect">
@@ -9134,13 +10105,13 @@
           <a:lstStyle/>
           <a:p>
             <a:r>
-              <a:rPr sz="1200" b="0">
-                <a:solidFill>
-                  <a:srgbClr val="B76E79"/>
-                </a:solidFill>
-                <a:latin typeface="Calibri"/>
+              <a:rPr sz="1000" b="1">
+                <a:solidFill>
+                  <a:srgbClr val="C8A04A"/>
+                </a:solidFill>
+                <a:latin typeface="Montserrat"/>
               </a:rPr>
-              <a:t>Lidia Nails</a:t>
+              <a:t>LIDIA · NAIL EXPERT</a:t>
             </a:r>
           </a:p>
         </p:txBody>
@@ -9178,7 +10149,7 @@
             <a:avLst/>
           </a:prstGeom>
           <a:solidFill>
-            <a:srgbClr val="FFFFFF"/>
+            <a:srgbClr val="FAF7F0"/>
           </a:solidFill>
           <a:ln>
             <a:noFill/>
@@ -9215,13 +10186,13 @@
         <p:spPr>
           <a:xfrm>
             <a:off x="0" y="0"/>
-            <a:ext cx="228600" cy="6858000"/>
+            <a:ext cx="201168" cy="6858000"/>
           </a:xfrm>
           <a:prstGeom prst="rect">
             <a:avLst/>
           </a:prstGeom>
           <a:solidFill>
-            <a:srgbClr val="B76E79"/>
+            <a:srgbClr val="C9D8C5"/>
           </a:solidFill>
           <a:ln>
             <a:noFill/>
@@ -9251,14 +10222,57 @@
       </p:sp>
       <p:sp>
         <p:nvSpPr>
-          <p:cNvPr id="4" name="TextBox 3"/>
+          <p:cNvPr id="4" name="Rectangle 3"/>
+          <p:cNvSpPr/>
+          <p:nvPr/>
+        </p:nvSpPr>
+        <p:spPr>
+          <a:xfrm>
+            <a:off x="201168" y="0"/>
+            <a:ext cx="36576" cy="6858000"/>
+          </a:xfrm>
+          <a:prstGeom prst="rect">
+            <a:avLst/>
+          </a:prstGeom>
+          <a:solidFill>
+            <a:srgbClr val="C8A04A"/>
+          </a:solidFill>
+          <a:ln>
+            <a:noFill/>
+          </a:ln>
+        </p:spPr>
+        <p:style>
+          <a:lnRef idx="1">
+            <a:schemeClr val="accent1"/>
+          </a:lnRef>
+          <a:fillRef idx="3">
+            <a:schemeClr val="accent1"/>
+          </a:fillRef>
+          <a:effectRef idx="2">
+            <a:schemeClr val="accent1"/>
+          </a:effectRef>
+          <a:fontRef idx="minor">
+            <a:schemeClr val="lt1"/>
+          </a:fontRef>
+        </p:style>
+        <p:txBody>
+          <a:bodyPr rtlCol="0" anchor="ctr"/>
+          <a:lstStyle/>
+          <a:p>
+            <a:pPr algn="ctr"/>
+          </a:p>
+        </p:txBody>
+      </p:sp>
+      <p:sp>
+        <p:nvSpPr>
+          <p:cNvPr id="5" name="TextBox 4"/>
           <p:cNvSpPr txBox="1"/>
           <p:nvPr/>
         </p:nvSpPr>
         <p:spPr>
           <a:xfrm>
-            <a:off x="822960" y="548640"/>
-            <a:ext cx="10515600" cy="914400"/>
+            <a:off x="822960" y="502920"/>
+            <a:ext cx="10789920" cy="914400"/>
           </a:xfrm>
           <a:prstGeom prst="rect">
             <a:avLst/>
@@ -9272,11 +10286,11 @@
           <a:lstStyle/>
           <a:p>
             <a:r>
-              <a:rPr sz="3600" b="1">
-                <a:solidFill>
-                  <a:srgbClr val="2B2B2B"/>
-                </a:solidFill>
-                <a:latin typeface="Calibri"/>
+              <a:rPr sz="3400" b="0">
+                <a:solidFill>
+                  <a:srgbClr val="34402F"/>
+                </a:solidFill>
+                <a:latin typeface="Playfair Display"/>
               </a:rPr>
               <a:t>7. Preparare l'unghia naturale</a:t>
             </a:r>
@@ -9285,7 +10299,7 @@
       </p:sp>
       <p:sp>
         <p:nvSpPr>
-          <p:cNvPr id="5" name="TextBox 4"/>
+          <p:cNvPr id="6" name="TextBox 5"/>
           <p:cNvSpPr txBox="1"/>
           <p:nvPr/>
         </p:nvSpPr>
@@ -9307,24 +10321,24 @@
           <a:p>
             <a:pPr>
               <a:spcAft>
-                <a:spcPts val="1800"/>
+                <a:spcPts val="1600"/>
               </a:spcAft>
             </a:pPr>
             <a:r>
-              <a:rPr sz="2400" b="0">
-                <a:solidFill>
-                  <a:srgbClr val="2B2B2B"/>
-                </a:solidFill>
-                <a:latin typeface="Calibri"/>
+              <a:rPr sz="2200" b="0">
+                <a:solidFill>
+                  <a:srgbClr val="34402F"/>
+                </a:solidFill>
+                <a:latin typeface="Montserrat"/>
               </a:rPr>
               <a:t/>
             </a:r>
             <a:r>
-              <a:rPr sz="2400">
-                <a:solidFill>
-                  <a:srgbClr val="2B2B2B"/>
-                </a:solidFill>
-                <a:latin typeface="Calibri"/>
+              <a:rPr sz="2000">
+                <a:solidFill>
+                  <a:srgbClr val="34402F"/>
+                </a:solidFill>
+                <a:latin typeface="Montserrat"/>
               </a:rPr>
               <a:t>•  Unghia corta, pari al polpastrello, stondata</a:t>
             </a:r>
@@ -9332,15 +10346,15 @@
           <a:p>
             <a:pPr>
               <a:spcAft>
-                <a:spcPts val="1800"/>
+                <a:spcPts val="1600"/>
               </a:spcAft>
             </a:pPr>
             <a:r>
-              <a:rPr sz="2400">
-                <a:solidFill>
-                  <a:srgbClr val="2B2B2B"/>
-                </a:solidFill>
-                <a:latin typeface="Calibri"/>
+              <a:rPr sz="2000">
+                <a:solidFill>
+                  <a:srgbClr val="34402F"/>
+                </a:solidFill>
+                <a:latin typeface="Montserrat"/>
               </a:rPr>
               <a:t>•  Lunga = tasche d'aria + effetto pappagallo</a:t>
             </a:r>
@@ -9348,15 +10362,15 @@
           <a:p>
             <a:pPr>
               <a:spcAft>
-                <a:spcPts val="1800"/>
+                <a:spcPts val="1600"/>
               </a:spcAft>
             </a:pPr>
             <a:r>
-              <a:rPr sz="2400">
-                <a:solidFill>
-                  <a:srgbClr val="2B2B2B"/>
-                </a:solidFill>
-                <a:latin typeface="Calibri"/>
+              <a:rPr sz="2000">
+                <a:solidFill>
+                  <a:srgbClr val="34402F"/>
+                </a:solidFill>
+                <a:latin typeface="Montserrat"/>
               </a:rPr>
               <a:t>•  Se si rompe, cede solo la tip</a:t>
             </a:r>
@@ -9364,15 +10378,15 @@
           <a:p>
             <a:pPr>
               <a:spcAft>
-                <a:spcPts val="1800"/>
+                <a:spcPts val="1600"/>
               </a:spcAft>
             </a:pPr>
             <a:r>
-              <a:rPr sz="2400">
-                <a:solidFill>
-                  <a:srgbClr val="2B2B2B"/>
-                </a:solidFill>
-                <a:latin typeface="Calibri"/>
+              <a:rPr sz="2000">
+                <a:solidFill>
+                  <a:srgbClr val="34402F"/>
+                </a:solidFill>
+                <a:latin typeface="Montserrat"/>
               </a:rPr>
               <a:t>•  Via TUTTO il vecchio prodotto</a:t>
             </a:r>
@@ -9381,7 +10395,7 @@
       </p:sp>
       <p:pic>
         <p:nvPicPr>
-          <p:cNvPr id="6" name="Picture 5" descr="unghia-naturale.png"/>
+          <p:cNvPr id="7" name="Picture 6" descr="unghia-naturale.png"/>
           <p:cNvPicPr>
             <a:picLocks noChangeAspect="1"/>
           </p:cNvPicPr>
@@ -9403,15 +10417,39 @@
           </a:prstGeom>
         </p:spPr>
       </p:pic>
-      <p:sp>
-        <p:nvSpPr>
-          <p:cNvPr id="7" name="TextBox 6"/>
+      <p:pic>
+        <p:nvPicPr>
+          <p:cNvPr id="8" name="Picture 7" descr="emblema-oliva.png"/>
+          <p:cNvPicPr>
+            <a:picLocks noChangeAspect="1"/>
+          </p:cNvPicPr>
+          <p:nvPr/>
+        </p:nvPicPr>
+        <p:blipFill>
+          <a:blip r:embed="rId3"/>
+          <a:stretch>
+            <a:fillRect/>
+          </a:stretch>
+        </p:blipFill>
+        <p:spPr>
+          <a:xfrm>
+            <a:off x="822960" y="6126480"/>
+            <a:ext cx="342900" cy="457200"/>
+          </a:xfrm>
+          <a:prstGeom prst="rect">
+            <a:avLst/>
+          </a:prstGeom>
+        </p:spPr>
+      </p:pic>
+      <p:sp>
+        <p:nvSpPr>
+          <p:cNvPr id="9" name="TextBox 8"/>
           <p:cNvSpPr txBox="1"/>
           <p:nvPr/>
         </p:nvSpPr>
         <p:spPr>
           <a:xfrm>
-            <a:off x="822960" y="6309360"/>
+            <a:off x="1371600" y="6236208"/>
             <a:ext cx="3657600" cy="365760"/>
           </a:xfrm>
           <a:prstGeom prst="rect">
@@ -9426,13 +10464,13 @@
           <a:lstStyle/>
           <a:p>
             <a:r>
-              <a:rPr sz="1200" b="0">
-                <a:solidFill>
-                  <a:srgbClr val="B76E79"/>
-                </a:solidFill>
-                <a:latin typeface="Calibri"/>
+              <a:rPr sz="1000" b="1">
+                <a:solidFill>
+                  <a:srgbClr val="C8A04A"/>
+                </a:solidFill>
+                <a:latin typeface="Montserrat"/>
               </a:rPr>
-              <a:t>Lidia Nails</a:t>
+              <a:t>LIDIA · NAIL EXPERT</a:t>
             </a:r>
           </a:p>
         </p:txBody>
@@ -9470,7 +10508,7 @@
             <a:avLst/>
           </a:prstGeom>
           <a:solidFill>
-            <a:srgbClr val="FFFFFF"/>
+            <a:srgbClr val="FAF7F0"/>
           </a:solidFill>
           <a:ln>
             <a:noFill/>
@@ -9507,13 +10545,13 @@
         <p:spPr>
           <a:xfrm>
             <a:off x="0" y="0"/>
-            <a:ext cx="228600" cy="6858000"/>
+            <a:ext cx="201168" cy="6858000"/>
           </a:xfrm>
           <a:prstGeom prst="rect">
             <a:avLst/>
           </a:prstGeom>
           <a:solidFill>
-            <a:srgbClr val="B76E79"/>
+            <a:srgbClr val="C9D8C5"/>
           </a:solidFill>
           <a:ln>
             <a:noFill/>
@@ -9543,14 +10581,57 @@
       </p:sp>
       <p:sp>
         <p:nvSpPr>
-          <p:cNvPr id="4" name="TextBox 3"/>
+          <p:cNvPr id="4" name="Rectangle 3"/>
+          <p:cNvSpPr/>
+          <p:nvPr/>
+        </p:nvSpPr>
+        <p:spPr>
+          <a:xfrm>
+            <a:off x="201168" y="0"/>
+            <a:ext cx="36576" cy="6858000"/>
+          </a:xfrm>
+          <a:prstGeom prst="rect">
+            <a:avLst/>
+          </a:prstGeom>
+          <a:solidFill>
+            <a:srgbClr val="C8A04A"/>
+          </a:solidFill>
+          <a:ln>
+            <a:noFill/>
+          </a:ln>
+        </p:spPr>
+        <p:style>
+          <a:lnRef idx="1">
+            <a:schemeClr val="accent1"/>
+          </a:lnRef>
+          <a:fillRef idx="3">
+            <a:schemeClr val="accent1"/>
+          </a:fillRef>
+          <a:effectRef idx="2">
+            <a:schemeClr val="accent1"/>
+          </a:effectRef>
+          <a:fontRef idx="minor">
+            <a:schemeClr val="lt1"/>
+          </a:fontRef>
+        </p:style>
+        <p:txBody>
+          <a:bodyPr rtlCol="0" anchor="ctr"/>
+          <a:lstStyle/>
+          <a:p>
+            <a:pPr algn="ctr"/>
+          </a:p>
+        </p:txBody>
+      </p:sp>
+      <p:sp>
+        <p:nvSpPr>
+          <p:cNvPr id="5" name="TextBox 4"/>
           <p:cNvSpPr txBox="1"/>
           <p:nvPr/>
         </p:nvSpPr>
         <p:spPr>
           <a:xfrm>
-            <a:off x="822960" y="548640"/>
-            <a:ext cx="10515600" cy="914400"/>
+            <a:off x="822960" y="502920"/>
+            <a:ext cx="10789920" cy="914400"/>
           </a:xfrm>
           <a:prstGeom prst="rect">
             <a:avLst/>
@@ -9564,11 +10645,11 @@
           <a:lstStyle/>
           <a:p>
             <a:r>
-              <a:rPr sz="3600" b="1">
-                <a:solidFill>
-                  <a:srgbClr val="2B2B2B"/>
-                </a:solidFill>
-                <a:latin typeface="Calibri"/>
+              <a:rPr sz="3400" b="0">
+                <a:solidFill>
+                  <a:srgbClr val="34402F"/>
+                </a:solidFill>
+                <a:latin typeface="Playfair Display"/>
               </a:rPr>
               <a:t>8. Scegliere la misura sull'unghia</a:t>
             </a:r>
@@ -9577,7 +10658,7 @@
       </p:sp>
       <p:sp>
         <p:nvSpPr>
-          <p:cNvPr id="5" name="TextBox 4"/>
+          <p:cNvPr id="6" name="TextBox 5"/>
           <p:cNvSpPr txBox="1"/>
           <p:nvPr/>
         </p:nvSpPr>
@@ -9599,24 +10680,24 @@
           <a:p>
             <a:pPr>
               <a:spcAft>
-                <a:spcPts val="1800"/>
+                <a:spcPts val="1600"/>
               </a:spcAft>
             </a:pPr>
             <a:r>
-              <a:rPr sz="2400" b="0">
-                <a:solidFill>
-                  <a:srgbClr val="2B2B2B"/>
-                </a:solidFill>
-                <a:latin typeface="Calibri"/>
+              <a:rPr sz="2200" b="0">
+                <a:solidFill>
+                  <a:srgbClr val="34402F"/>
+                </a:solidFill>
+                <a:latin typeface="Montserrat"/>
               </a:rPr>
               <a:t/>
             </a:r>
             <a:r>
-              <a:rPr sz="2400">
-                <a:solidFill>
-                  <a:srgbClr val="2B2B2B"/>
-                </a:solidFill>
-                <a:latin typeface="Calibri"/>
+              <a:rPr sz="2000">
+                <a:solidFill>
+                  <a:srgbClr val="34402F"/>
+                </a:solidFill>
+                <a:latin typeface="Montserrat"/>
               </a:rPr>
               <a:t>•  Appoggia al centro e scorri</a:t>
             </a:r>
@@ -9624,15 +10705,15 @@
           <a:p>
             <a:pPr>
               <a:spcAft>
-                <a:spcPts val="1800"/>
+                <a:spcPts val="1600"/>
               </a:spcAft>
             </a:pPr>
             <a:r>
-              <a:rPr sz="2400">
-                <a:solidFill>
-                  <a:srgbClr val="2B2B2B"/>
-                </a:solidFill>
-                <a:latin typeface="Calibri"/>
+              <a:rPr sz="2000">
+                <a:solidFill>
+                  <a:srgbClr val="34402F"/>
+                </a:solidFill>
+                <a:latin typeface="Montserrat"/>
               </a:rPr>
               <a:t>•  Deve combaciare col punto di crescita</a:t>
             </a:r>
@@ -9640,15 +10721,15 @@
           <a:p>
             <a:pPr>
               <a:spcAft>
-                <a:spcPts val="1800"/>
+                <a:spcPts val="1600"/>
               </a:spcAft>
             </a:pPr>
             <a:r>
-              <a:rPr sz="2400">
-                <a:solidFill>
-                  <a:srgbClr val="2B2B2B"/>
-                </a:solidFill>
-                <a:latin typeface="Calibri"/>
+              <a:rPr sz="2000">
+                <a:solidFill>
+                  <a:srgbClr val="34402F"/>
+                </a:solidFill>
+                <a:latin typeface="Montserrat"/>
               </a:rPr>
               <a:t>•  Dubbio? La più grande (si flette)</a:t>
             </a:r>
@@ -9656,15 +10737,15 @@
           <a:p>
             <a:pPr>
               <a:spcAft>
-                <a:spcPts val="1800"/>
+                <a:spcPts val="1600"/>
               </a:spcAft>
             </a:pPr>
             <a:r>
-              <a:rPr sz="2400">
-                <a:solidFill>
-                  <a:srgbClr val="2B2B2B"/>
-                </a:solidFill>
-                <a:latin typeface="Calibri"/>
+              <a:rPr sz="2000">
+                <a:solidFill>
+                  <a:srgbClr val="34402F"/>
+                </a:solidFill>
+                <a:latin typeface="Montserrat"/>
               </a:rPr>
               <a:t>•  Troppo grande: lima i laterali. Troppo piccola: non si allarga</a:t>
             </a:r>
@@ -9673,7 +10754,7 @@
       </p:sp>
       <p:pic>
         <p:nvPicPr>
-          <p:cNvPr id="6" name="Picture 5" descr="scelta-misura.png"/>
+          <p:cNvPr id="7" name="Picture 6" descr="scelta-misura.png"/>
           <p:cNvPicPr>
             <a:picLocks noChangeAspect="1"/>
           </p:cNvPicPr>
@@ -9695,15 +10776,39 @@
           </a:prstGeom>
         </p:spPr>
       </p:pic>
-      <p:sp>
-        <p:nvSpPr>
-          <p:cNvPr id="7" name="TextBox 6"/>
+      <p:pic>
+        <p:nvPicPr>
+          <p:cNvPr id="8" name="Picture 7" descr="emblema-oliva.png"/>
+          <p:cNvPicPr>
+            <a:picLocks noChangeAspect="1"/>
+          </p:cNvPicPr>
+          <p:nvPr/>
+        </p:nvPicPr>
+        <p:blipFill>
+          <a:blip r:embed="rId3"/>
+          <a:stretch>
+            <a:fillRect/>
+          </a:stretch>
+        </p:blipFill>
+        <p:spPr>
+          <a:xfrm>
+            <a:off x="822960" y="6126480"/>
+            <a:ext cx="342900" cy="457200"/>
+          </a:xfrm>
+          <a:prstGeom prst="rect">
+            <a:avLst/>
+          </a:prstGeom>
+        </p:spPr>
+      </p:pic>
+      <p:sp>
+        <p:nvSpPr>
+          <p:cNvPr id="9" name="TextBox 8"/>
           <p:cNvSpPr txBox="1"/>
           <p:nvPr/>
         </p:nvSpPr>
         <p:spPr>
           <a:xfrm>
-            <a:off x="822960" y="6309360"/>
+            <a:off x="1371600" y="6236208"/>
             <a:ext cx="3657600" cy="365760"/>
           </a:xfrm>
           <a:prstGeom prst="rect">
@@ -9718,13 +10823,13 @@
           <a:lstStyle/>
           <a:p>
             <a:r>
-              <a:rPr sz="1200" b="0">
-                <a:solidFill>
-                  <a:srgbClr val="B76E79"/>
-                </a:solidFill>
-                <a:latin typeface="Calibri"/>
+              <a:rPr sz="1000" b="1">
+                <a:solidFill>
+                  <a:srgbClr val="C8A04A"/>
+                </a:solidFill>
+                <a:latin typeface="Montserrat"/>
               </a:rPr>
-              <a:t>Lidia Nails</a:t>
+              <a:t>LIDIA · NAIL EXPERT</a:t>
             </a:r>
           </a:p>
         </p:txBody>

</xml_diff>